<commit_message>
Support image primitive + per-slide top-right lab logo slot (awaiting logo file)
Co-authored-by: arena-agent <297053741+arena-agent@users.noreply.github.com>
</commit_message>
<xml_diff>
--- a/hn-ad-seminar/output/组会汇报_高效好氧降氨菌的筛选机制解析及堆肥应用.pptx
+++ b/hn-ad-seminar/output/组会汇报_高效好氧降氨菌的筛选机制解析及堆肥应用.pptx
@@ -5445,48 +5445,7 @@
       </p:sp>
       <p:sp>
         <p:nvSpPr>
-          <p:cNvPr id="6" name="TextBox 5"/>
-          <p:cNvSpPr txBox="1"/>
-          <p:nvPr/>
-        </p:nvSpPr>
-        <p:spPr>
-          <a:xfrm>
-            <a:off x="10312400" y="254000"/>
-            <a:ext cx="1270000" cy="558800"/>
-          </a:xfrm>
-          <a:prstGeom prst="rect">
-            <a:avLst/>
-          </a:prstGeom>
-          <a:noFill/>
-        </p:spPr>
-        <p:txBody>
-          <a:bodyPr wrap="square" lIns="0" rIns="0" tIns="0" bIns="0" anchor="t">
-            <a:noAutofit/>
-          </a:bodyPr>
-          <a:lstStyle/>
-          <a:p>
-            <a:pPr algn="r">
-              <a:lnSpc>
-                <a:spcPct val="100000"/>
-              </a:lnSpc>
-            </a:pPr>
-            <a:r>
-              <a:rPr sz="3000" b="1" i="0">
-                <a:solidFill>
-                  <a:srgbClr val="E3EAF2"/>
-                </a:solidFill>
-                <a:latin typeface="Arial"/>
-                <a:ea typeface="Microsoft YaHei"/>
-                <a:cs typeface="Arial"/>
-              </a:rPr>
-              <a:t>02</a:t>
-            </a:r>
-          </a:p>
-        </p:txBody>
-      </p:sp>
-      <p:sp>
-        <p:nvSpPr>
-          <p:cNvPr id="7" name="Freeform 6"/>
+          <p:cNvPr id="6" name="Freeform 5"/>
           <p:cNvSpPr/>
           <p:nvPr/>
         </p:nvSpPr>
@@ -5544,7 +5503,7 @@
       </p:sp>
       <p:sp>
         <p:nvSpPr>
-          <p:cNvPr id="8" name="Freeform 7"/>
+          <p:cNvPr id="7" name="Freeform 6"/>
           <p:cNvSpPr/>
           <p:nvPr/>
         </p:nvSpPr>
@@ -5602,7 +5561,7 @@
       </p:sp>
       <p:sp>
         <p:nvSpPr>
-          <p:cNvPr id="9" name="TextBox 8"/>
+          <p:cNvPr id="8" name="TextBox 7"/>
           <p:cNvSpPr txBox="1"/>
           <p:nvPr/>
         </p:nvSpPr>
@@ -5643,7 +5602,7 @@
       </p:sp>
       <p:sp>
         <p:nvSpPr>
-          <p:cNvPr id="10" name="TextBox 9"/>
+          <p:cNvPr id="9" name="TextBox 8"/>
           <p:cNvSpPr txBox="1"/>
           <p:nvPr/>
         </p:nvSpPr>
@@ -5684,7 +5643,7 @@
       </p:sp>
       <p:sp>
         <p:nvSpPr>
-          <p:cNvPr id="11" name="Rounded Rectangle 10"/>
+          <p:cNvPr id="10" name="Rounded Rectangle 9"/>
           <p:cNvSpPr/>
           <p:nvPr/>
         </p:nvSpPr>
@@ -5738,7 +5697,7 @@
       </p:sp>
       <p:sp>
         <p:nvSpPr>
-          <p:cNvPr id="12" name="Rounded Rectangle 11"/>
+          <p:cNvPr id="11" name="Rounded Rectangle 10"/>
           <p:cNvSpPr/>
           <p:nvPr/>
         </p:nvSpPr>
@@ -5784,7 +5743,7 @@
       </p:sp>
       <p:sp>
         <p:nvSpPr>
-          <p:cNvPr id="13" name="TextBox 12"/>
+          <p:cNvPr id="12" name="TextBox 11"/>
           <p:cNvSpPr txBox="1"/>
           <p:nvPr/>
         </p:nvSpPr>
@@ -5825,7 +5784,7 @@
       </p:sp>
       <p:sp>
         <p:nvSpPr>
-          <p:cNvPr id="14" name="Freeform 13"/>
+          <p:cNvPr id="13" name="Freeform 12"/>
           <p:cNvSpPr/>
           <p:nvPr/>
         </p:nvSpPr>
@@ -5883,7 +5842,7 @@
       </p:sp>
       <p:sp>
         <p:nvSpPr>
-          <p:cNvPr id="15" name="TextBox 14"/>
+          <p:cNvPr id="14" name="TextBox 13"/>
           <p:cNvSpPr txBox="1"/>
           <p:nvPr/>
         </p:nvSpPr>
@@ -5924,7 +5883,7 @@
       </p:sp>
       <p:sp>
         <p:nvSpPr>
-          <p:cNvPr id="16" name="TextBox 15"/>
+          <p:cNvPr id="15" name="TextBox 14"/>
           <p:cNvSpPr txBox="1"/>
           <p:nvPr/>
         </p:nvSpPr>
@@ -5965,7 +5924,7 @@
       </p:sp>
       <p:sp>
         <p:nvSpPr>
-          <p:cNvPr id="17" name="Oval 16"/>
+          <p:cNvPr id="16" name="Oval 15"/>
           <p:cNvSpPr/>
           <p:nvPr/>
         </p:nvSpPr>
@@ -6011,7 +5970,7 @@
       </p:sp>
       <p:sp>
         <p:nvSpPr>
-          <p:cNvPr id="18" name="TextBox 17"/>
+          <p:cNvPr id="17" name="TextBox 16"/>
           <p:cNvSpPr txBox="1"/>
           <p:nvPr/>
         </p:nvSpPr>
@@ -6052,7 +6011,7 @@
       </p:sp>
       <p:sp>
         <p:nvSpPr>
-          <p:cNvPr id="19" name="TextBox 18"/>
+          <p:cNvPr id="18" name="TextBox 17"/>
           <p:cNvSpPr txBox="1"/>
           <p:nvPr/>
         </p:nvSpPr>
@@ -6093,7 +6052,7 @@
       </p:sp>
       <p:sp>
         <p:nvSpPr>
-          <p:cNvPr id="20" name="Oval 19"/>
+          <p:cNvPr id="19" name="Oval 18"/>
           <p:cNvSpPr/>
           <p:nvPr/>
         </p:nvSpPr>
@@ -6139,7 +6098,7 @@
       </p:sp>
       <p:sp>
         <p:nvSpPr>
-          <p:cNvPr id="21" name="TextBox 20"/>
+          <p:cNvPr id="20" name="TextBox 19"/>
           <p:cNvSpPr txBox="1"/>
           <p:nvPr/>
         </p:nvSpPr>
@@ -6180,7 +6139,7 @@
       </p:sp>
       <p:sp>
         <p:nvSpPr>
-          <p:cNvPr id="22" name="TextBox 21"/>
+          <p:cNvPr id="21" name="TextBox 20"/>
           <p:cNvSpPr txBox="1"/>
           <p:nvPr/>
         </p:nvSpPr>
@@ -6221,7 +6180,7 @@
       </p:sp>
       <p:sp>
         <p:nvSpPr>
-          <p:cNvPr id="23" name="Oval 22"/>
+          <p:cNvPr id="22" name="Oval 21"/>
           <p:cNvSpPr/>
           <p:nvPr/>
         </p:nvSpPr>
@@ -6267,7 +6226,7 @@
       </p:sp>
       <p:sp>
         <p:nvSpPr>
-          <p:cNvPr id="24" name="TextBox 23"/>
+          <p:cNvPr id="23" name="TextBox 22"/>
           <p:cNvSpPr txBox="1"/>
           <p:nvPr/>
         </p:nvSpPr>
@@ -6308,7 +6267,7 @@
       </p:sp>
       <p:sp>
         <p:nvSpPr>
-          <p:cNvPr id="25" name="TextBox 24"/>
+          <p:cNvPr id="24" name="TextBox 23"/>
           <p:cNvSpPr txBox="1"/>
           <p:nvPr/>
         </p:nvSpPr>
@@ -6349,7 +6308,7 @@
       </p:sp>
       <p:sp>
         <p:nvSpPr>
-          <p:cNvPr id="26" name="Freeform 25"/>
+          <p:cNvPr id="25" name="Freeform 24"/>
           <p:cNvSpPr/>
           <p:nvPr/>
         </p:nvSpPr>
@@ -6407,7 +6366,7 @@
       </p:sp>
       <p:sp>
         <p:nvSpPr>
-          <p:cNvPr id="27" name="TextBox 26"/>
+          <p:cNvPr id="26" name="TextBox 25"/>
           <p:cNvSpPr txBox="1"/>
           <p:nvPr/>
         </p:nvSpPr>
@@ -6448,7 +6407,7 @@
       </p:sp>
       <p:sp>
         <p:nvSpPr>
-          <p:cNvPr id="28" name="Rounded Rectangle 27"/>
+          <p:cNvPr id="27" name="Rounded Rectangle 26"/>
           <p:cNvSpPr/>
           <p:nvPr/>
         </p:nvSpPr>
@@ -6502,7 +6461,7 @@
       </p:sp>
       <p:sp>
         <p:nvSpPr>
-          <p:cNvPr id="29" name="Rounded Rectangle 28"/>
+          <p:cNvPr id="28" name="Rounded Rectangle 27"/>
           <p:cNvSpPr/>
           <p:nvPr/>
         </p:nvSpPr>
@@ -6548,7 +6507,7 @@
       </p:sp>
       <p:sp>
         <p:nvSpPr>
-          <p:cNvPr id="30" name="TextBox 29"/>
+          <p:cNvPr id="29" name="TextBox 28"/>
           <p:cNvSpPr txBox="1"/>
           <p:nvPr/>
         </p:nvSpPr>
@@ -6589,7 +6548,7 @@
       </p:sp>
       <p:sp>
         <p:nvSpPr>
-          <p:cNvPr id="31" name="Freeform 30"/>
+          <p:cNvPr id="30" name="Freeform 29"/>
           <p:cNvSpPr/>
           <p:nvPr/>
         </p:nvSpPr>
@@ -6647,7 +6606,7 @@
       </p:sp>
       <p:sp>
         <p:nvSpPr>
-          <p:cNvPr id="32" name="TextBox 31"/>
+          <p:cNvPr id="31" name="TextBox 30"/>
           <p:cNvSpPr txBox="1"/>
           <p:nvPr/>
         </p:nvSpPr>
@@ -6688,7 +6647,7 @@
       </p:sp>
       <p:sp>
         <p:nvSpPr>
-          <p:cNvPr id="33" name="TextBox 32"/>
+          <p:cNvPr id="32" name="TextBox 31"/>
           <p:cNvSpPr txBox="1"/>
           <p:nvPr/>
         </p:nvSpPr>
@@ -6729,7 +6688,7 @@
       </p:sp>
       <p:sp>
         <p:nvSpPr>
-          <p:cNvPr id="34" name="Oval 33"/>
+          <p:cNvPr id="33" name="Oval 32"/>
           <p:cNvSpPr/>
           <p:nvPr/>
         </p:nvSpPr>
@@ -6775,7 +6734,7 @@
       </p:sp>
       <p:sp>
         <p:nvSpPr>
-          <p:cNvPr id="35" name="TextBox 34"/>
+          <p:cNvPr id="34" name="TextBox 33"/>
           <p:cNvSpPr txBox="1"/>
           <p:nvPr/>
         </p:nvSpPr>
@@ -6816,7 +6775,7 @@
       </p:sp>
       <p:sp>
         <p:nvSpPr>
-          <p:cNvPr id="36" name="TextBox 35"/>
+          <p:cNvPr id="35" name="TextBox 34"/>
           <p:cNvSpPr txBox="1"/>
           <p:nvPr/>
         </p:nvSpPr>
@@ -6857,7 +6816,7 @@
       </p:sp>
       <p:sp>
         <p:nvSpPr>
-          <p:cNvPr id="37" name="Oval 36"/>
+          <p:cNvPr id="36" name="Oval 35"/>
           <p:cNvSpPr/>
           <p:nvPr/>
         </p:nvSpPr>
@@ -6903,7 +6862,7 @@
       </p:sp>
       <p:sp>
         <p:nvSpPr>
-          <p:cNvPr id="38" name="TextBox 37"/>
+          <p:cNvPr id="37" name="TextBox 36"/>
           <p:cNvSpPr txBox="1"/>
           <p:nvPr/>
         </p:nvSpPr>
@@ -6944,7 +6903,7 @@
       </p:sp>
       <p:sp>
         <p:nvSpPr>
-          <p:cNvPr id="39" name="TextBox 38"/>
+          <p:cNvPr id="38" name="TextBox 37"/>
           <p:cNvSpPr txBox="1"/>
           <p:nvPr/>
         </p:nvSpPr>
@@ -6985,7 +6944,7 @@
       </p:sp>
       <p:sp>
         <p:nvSpPr>
-          <p:cNvPr id="40" name="Oval 39"/>
+          <p:cNvPr id="39" name="Oval 38"/>
           <p:cNvSpPr/>
           <p:nvPr/>
         </p:nvSpPr>
@@ -7031,7 +6990,7 @@
       </p:sp>
       <p:sp>
         <p:nvSpPr>
-          <p:cNvPr id="41" name="TextBox 40"/>
+          <p:cNvPr id="40" name="TextBox 39"/>
           <p:cNvSpPr txBox="1"/>
           <p:nvPr/>
         </p:nvSpPr>
@@ -7072,7 +7031,7 @@
       </p:sp>
       <p:sp>
         <p:nvSpPr>
-          <p:cNvPr id="42" name="TextBox 41"/>
+          <p:cNvPr id="41" name="TextBox 40"/>
           <p:cNvSpPr txBox="1"/>
           <p:nvPr/>
         </p:nvSpPr>
@@ -7113,7 +7072,7 @@
       </p:sp>
       <p:sp>
         <p:nvSpPr>
-          <p:cNvPr id="43" name="Oval 42"/>
+          <p:cNvPr id="42" name="Oval 41"/>
           <p:cNvSpPr/>
           <p:nvPr/>
         </p:nvSpPr>
@@ -7159,7 +7118,7 @@
       </p:sp>
       <p:sp>
         <p:nvSpPr>
-          <p:cNvPr id="44" name="TextBox 43"/>
+          <p:cNvPr id="43" name="TextBox 42"/>
           <p:cNvSpPr txBox="1"/>
           <p:nvPr/>
         </p:nvSpPr>
@@ -7200,7 +7159,7 @@
       </p:sp>
       <p:sp>
         <p:nvSpPr>
-          <p:cNvPr id="45" name="TextBox 44"/>
+          <p:cNvPr id="44" name="TextBox 43"/>
           <p:cNvSpPr txBox="1"/>
           <p:nvPr/>
         </p:nvSpPr>
@@ -7241,7 +7200,7 @@
       </p:sp>
       <p:sp>
         <p:nvSpPr>
-          <p:cNvPr id="46" name="Freeform 45"/>
+          <p:cNvPr id="45" name="Freeform 44"/>
           <p:cNvSpPr/>
           <p:nvPr/>
         </p:nvSpPr>
@@ -7299,7 +7258,7 @@
       </p:sp>
       <p:sp>
         <p:nvSpPr>
-          <p:cNvPr id="47" name="TextBox 46"/>
+          <p:cNvPr id="46" name="TextBox 45"/>
           <p:cNvSpPr txBox="1"/>
           <p:nvPr/>
         </p:nvSpPr>
@@ -7536,48 +7495,7 @@
       </p:sp>
       <p:sp>
         <p:nvSpPr>
-          <p:cNvPr id="6" name="TextBox 5"/>
-          <p:cNvSpPr txBox="1"/>
-          <p:nvPr/>
-        </p:nvSpPr>
-        <p:spPr>
-          <a:xfrm>
-            <a:off x="10312400" y="254000"/>
-            <a:ext cx="1270000" cy="558800"/>
-          </a:xfrm>
-          <a:prstGeom prst="rect">
-            <a:avLst/>
-          </a:prstGeom>
-          <a:noFill/>
-        </p:spPr>
-        <p:txBody>
-          <a:bodyPr wrap="square" lIns="0" rIns="0" tIns="0" bIns="0" anchor="t">
-            <a:noAutofit/>
-          </a:bodyPr>
-          <a:lstStyle/>
-          <a:p>
-            <a:pPr algn="r">
-              <a:lnSpc>
-                <a:spcPct val="100000"/>
-              </a:lnSpc>
-            </a:pPr>
-            <a:r>
-              <a:rPr sz="3000" b="1" i="0">
-                <a:solidFill>
-                  <a:srgbClr val="E3EAF2"/>
-                </a:solidFill>
-                <a:latin typeface="Arial"/>
-                <a:ea typeface="Microsoft YaHei"/>
-                <a:cs typeface="Arial"/>
-              </a:rPr>
-              <a:t>03</a:t>
-            </a:r>
-          </a:p>
-        </p:txBody>
-      </p:sp>
-      <p:sp>
-        <p:nvSpPr>
-          <p:cNvPr id="7" name="Freeform 6"/>
+          <p:cNvPr id="6" name="Freeform 5"/>
           <p:cNvSpPr/>
           <p:nvPr/>
         </p:nvSpPr>
@@ -7635,7 +7553,7 @@
       </p:sp>
       <p:sp>
         <p:nvSpPr>
-          <p:cNvPr id="8" name="Freeform 7"/>
+          <p:cNvPr id="7" name="Freeform 6"/>
           <p:cNvSpPr/>
           <p:nvPr/>
         </p:nvSpPr>
@@ -7693,7 +7611,7 @@
       </p:sp>
       <p:sp>
         <p:nvSpPr>
-          <p:cNvPr id="9" name="TextBox 8"/>
+          <p:cNvPr id="8" name="TextBox 7"/>
           <p:cNvSpPr txBox="1"/>
           <p:nvPr/>
         </p:nvSpPr>
@@ -7734,7 +7652,7 @@
       </p:sp>
       <p:sp>
         <p:nvSpPr>
-          <p:cNvPr id="10" name="TextBox 9"/>
+          <p:cNvPr id="9" name="TextBox 8"/>
           <p:cNvSpPr txBox="1"/>
           <p:nvPr/>
         </p:nvSpPr>
@@ -7775,7 +7693,7 @@
       </p:sp>
       <p:sp>
         <p:nvSpPr>
-          <p:cNvPr id="11" name="Rounded Rectangle 10"/>
+          <p:cNvPr id="10" name="Rounded Rectangle 9"/>
           <p:cNvSpPr/>
           <p:nvPr/>
         </p:nvSpPr>
@@ -7823,7 +7741,7 @@
       </p:sp>
       <p:sp>
         <p:nvSpPr>
-          <p:cNvPr id="12" name="Rounded Rectangle 11"/>
+          <p:cNvPr id="11" name="Rounded Rectangle 10"/>
           <p:cNvSpPr/>
           <p:nvPr/>
         </p:nvSpPr>
@@ -7869,7 +7787,7 @@
       </p:sp>
       <p:sp>
         <p:nvSpPr>
-          <p:cNvPr id="13" name="TextBox 12"/>
+          <p:cNvPr id="12" name="TextBox 11"/>
           <p:cNvSpPr txBox="1"/>
           <p:nvPr/>
         </p:nvSpPr>
@@ -7921,7 +7839,7 @@
       </p:sp>
       <p:sp>
         <p:nvSpPr>
-          <p:cNvPr id="14" name="Rounded Rectangle 13"/>
+          <p:cNvPr id="13" name="Rounded Rectangle 12"/>
           <p:cNvSpPr/>
           <p:nvPr/>
         </p:nvSpPr>
@@ -7975,7 +7893,7 @@
       </p:sp>
       <p:sp>
         <p:nvSpPr>
-          <p:cNvPr id="15" name="Rounded Rectangle 14"/>
+          <p:cNvPr id="14" name="Rounded Rectangle 13"/>
           <p:cNvSpPr/>
           <p:nvPr/>
         </p:nvSpPr>
@@ -8021,7 +7939,7 @@
       </p:sp>
       <p:sp>
         <p:nvSpPr>
-          <p:cNvPr id="16" name="Rounded Rectangle 15"/>
+          <p:cNvPr id="15" name="Rounded Rectangle 14"/>
           <p:cNvSpPr/>
           <p:nvPr/>
         </p:nvSpPr>
@@ -8067,7 +7985,7 @@
       </p:sp>
       <p:sp>
         <p:nvSpPr>
-          <p:cNvPr id="17" name="TextBox 16"/>
+          <p:cNvPr id="16" name="TextBox 15"/>
           <p:cNvSpPr txBox="1"/>
           <p:nvPr/>
         </p:nvSpPr>
@@ -8108,7 +8026,7 @@
       </p:sp>
       <p:sp>
         <p:nvSpPr>
-          <p:cNvPr id="18" name="TextBox 17"/>
+          <p:cNvPr id="17" name="TextBox 16"/>
           <p:cNvSpPr txBox="1"/>
           <p:nvPr/>
         </p:nvSpPr>
@@ -8149,7 +8067,7 @@
       </p:sp>
       <p:sp>
         <p:nvSpPr>
-          <p:cNvPr id="19" name="TextBox 18"/>
+          <p:cNvPr id="18" name="TextBox 17"/>
           <p:cNvSpPr txBox="1"/>
           <p:nvPr/>
         </p:nvSpPr>
@@ -8320,7 +8238,7 @@
       </p:sp>
       <p:sp>
         <p:nvSpPr>
-          <p:cNvPr id="20" name="Rounded Rectangle 19"/>
+          <p:cNvPr id="19" name="Rounded Rectangle 18"/>
           <p:cNvSpPr/>
           <p:nvPr/>
         </p:nvSpPr>
@@ -8374,7 +8292,7 @@
       </p:sp>
       <p:sp>
         <p:nvSpPr>
-          <p:cNvPr id="21" name="Rounded Rectangle 20"/>
+          <p:cNvPr id="20" name="Rounded Rectangle 19"/>
           <p:cNvSpPr/>
           <p:nvPr/>
         </p:nvSpPr>
@@ -8420,7 +8338,7 @@
       </p:sp>
       <p:sp>
         <p:nvSpPr>
-          <p:cNvPr id="22" name="Rounded Rectangle 21"/>
+          <p:cNvPr id="21" name="Rounded Rectangle 20"/>
           <p:cNvSpPr/>
           <p:nvPr/>
         </p:nvSpPr>
@@ -8466,7 +8384,7 @@
       </p:sp>
       <p:sp>
         <p:nvSpPr>
-          <p:cNvPr id="23" name="TextBox 22"/>
+          <p:cNvPr id="22" name="TextBox 21"/>
           <p:cNvSpPr txBox="1"/>
           <p:nvPr/>
         </p:nvSpPr>
@@ -8507,7 +8425,7 @@
       </p:sp>
       <p:sp>
         <p:nvSpPr>
-          <p:cNvPr id="24" name="TextBox 23"/>
+          <p:cNvPr id="23" name="TextBox 22"/>
           <p:cNvSpPr txBox="1"/>
           <p:nvPr/>
         </p:nvSpPr>
@@ -8548,7 +8466,7 @@
       </p:sp>
       <p:sp>
         <p:nvSpPr>
-          <p:cNvPr id="25" name="TextBox 24"/>
+          <p:cNvPr id="24" name="TextBox 23"/>
           <p:cNvSpPr txBox="1"/>
           <p:nvPr/>
         </p:nvSpPr>
@@ -8616,7 +8534,7 @@
       </p:sp>
       <p:sp>
         <p:nvSpPr>
-          <p:cNvPr id="26" name="Freeform 25"/>
+          <p:cNvPr id="25" name="Freeform 24"/>
           <p:cNvSpPr/>
           <p:nvPr/>
         </p:nvSpPr>
@@ -8674,7 +8592,7 @@
       </p:sp>
       <p:sp>
         <p:nvSpPr>
-          <p:cNvPr id="27" name="TextBox 26"/>
+          <p:cNvPr id="26" name="TextBox 25"/>
           <p:cNvSpPr txBox="1"/>
           <p:nvPr/>
         </p:nvSpPr>
@@ -8715,7 +8633,7 @@
       </p:sp>
       <p:sp>
         <p:nvSpPr>
-          <p:cNvPr id="28" name="TextBox 27"/>
+          <p:cNvPr id="27" name="TextBox 26"/>
           <p:cNvSpPr txBox="1"/>
           <p:nvPr/>
         </p:nvSpPr>
@@ -8756,7 +8674,7 @@
       </p:sp>
       <p:sp>
         <p:nvSpPr>
-          <p:cNvPr id="29" name="TextBox 28"/>
+          <p:cNvPr id="28" name="TextBox 27"/>
           <p:cNvSpPr txBox="1"/>
           <p:nvPr/>
         </p:nvSpPr>
@@ -8797,7 +8715,7 @@
       </p:sp>
       <p:sp>
         <p:nvSpPr>
-          <p:cNvPr id="30" name="Rounded Rectangle 29"/>
+          <p:cNvPr id="29" name="Rounded Rectangle 28"/>
           <p:cNvSpPr/>
           <p:nvPr/>
         </p:nvSpPr>
@@ -8851,7 +8769,7 @@
       </p:sp>
       <p:sp>
         <p:nvSpPr>
-          <p:cNvPr id="31" name="TextBox 30"/>
+          <p:cNvPr id="30" name="TextBox 29"/>
           <p:cNvSpPr txBox="1"/>
           <p:nvPr/>
         </p:nvSpPr>
@@ -8892,7 +8810,7 @@
       </p:sp>
       <p:sp>
         <p:nvSpPr>
-          <p:cNvPr id="32" name="Rounded Rectangle 31"/>
+          <p:cNvPr id="31" name="Rounded Rectangle 30"/>
           <p:cNvSpPr/>
           <p:nvPr/>
         </p:nvSpPr>
@@ -8938,7 +8856,7 @@
       </p:sp>
       <p:sp>
         <p:nvSpPr>
-          <p:cNvPr id="33" name="TextBox 32"/>
+          <p:cNvPr id="32" name="TextBox 31"/>
           <p:cNvSpPr txBox="1"/>
           <p:nvPr/>
         </p:nvSpPr>
@@ -8979,7 +8897,7 @@
       </p:sp>
       <p:sp>
         <p:nvSpPr>
-          <p:cNvPr id="34" name="Rounded Rectangle 33"/>
+          <p:cNvPr id="33" name="Rounded Rectangle 32"/>
           <p:cNvSpPr/>
           <p:nvPr/>
         </p:nvSpPr>
@@ -9025,7 +8943,7 @@
       </p:sp>
       <p:sp>
         <p:nvSpPr>
-          <p:cNvPr id="35" name="TextBox 34"/>
+          <p:cNvPr id="34" name="TextBox 33"/>
           <p:cNvSpPr txBox="1"/>
           <p:nvPr/>
         </p:nvSpPr>
@@ -9066,7 +8984,7 @@
       </p:sp>
       <p:sp>
         <p:nvSpPr>
-          <p:cNvPr id="36" name="Freeform 35"/>
+          <p:cNvPr id="35" name="Freeform 34"/>
           <p:cNvSpPr/>
           <p:nvPr/>
         </p:nvSpPr>
@@ -9131,7 +9049,7 @@
       </p:sp>
       <p:sp>
         <p:nvSpPr>
-          <p:cNvPr id="37" name="Freeform 36"/>
+          <p:cNvPr id="36" name="Freeform 35"/>
           <p:cNvSpPr/>
           <p:nvPr/>
         </p:nvSpPr>
@@ -9196,7 +9114,7 @@
       </p:sp>
       <p:sp>
         <p:nvSpPr>
-          <p:cNvPr id="38" name="Oval 37"/>
+          <p:cNvPr id="37" name="Oval 36"/>
           <p:cNvSpPr/>
           <p:nvPr/>
         </p:nvSpPr>
@@ -9242,7 +9160,7 @@
       </p:sp>
       <p:sp>
         <p:nvSpPr>
-          <p:cNvPr id="39" name="Oval 38"/>
+          <p:cNvPr id="38" name="Oval 37"/>
           <p:cNvSpPr/>
           <p:nvPr/>
         </p:nvSpPr>
@@ -9288,7 +9206,7 @@
       </p:sp>
       <p:sp>
         <p:nvSpPr>
-          <p:cNvPr id="40" name="Oval 39"/>
+          <p:cNvPr id="39" name="Oval 38"/>
           <p:cNvSpPr/>
           <p:nvPr/>
         </p:nvSpPr>
@@ -9334,7 +9252,7 @@
       </p:sp>
       <p:sp>
         <p:nvSpPr>
-          <p:cNvPr id="41" name="Oval 40"/>
+          <p:cNvPr id="40" name="Oval 39"/>
           <p:cNvSpPr/>
           <p:nvPr/>
         </p:nvSpPr>
@@ -9380,7 +9298,7 @@
       </p:sp>
       <p:sp>
         <p:nvSpPr>
-          <p:cNvPr id="42" name="Oval 41"/>
+          <p:cNvPr id="41" name="Oval 40"/>
           <p:cNvSpPr/>
           <p:nvPr/>
         </p:nvSpPr>
@@ -9426,7 +9344,7 @@
       </p:sp>
       <p:sp>
         <p:nvSpPr>
-          <p:cNvPr id="43" name="TextBox 42"/>
+          <p:cNvPr id="42" name="TextBox 41"/>
           <p:cNvSpPr txBox="1"/>
           <p:nvPr/>
         </p:nvSpPr>
@@ -9467,7 +9385,7 @@
       </p:sp>
       <p:sp>
         <p:nvSpPr>
-          <p:cNvPr id="44" name="Freeform 43"/>
+          <p:cNvPr id="43" name="Freeform 42"/>
           <p:cNvSpPr/>
           <p:nvPr/>
         </p:nvSpPr>
@@ -9525,7 +9443,7 @@
       </p:sp>
       <p:sp>
         <p:nvSpPr>
-          <p:cNvPr id="45" name="Freeform 44"/>
+          <p:cNvPr id="44" name="Freeform 43"/>
           <p:cNvSpPr/>
           <p:nvPr/>
         </p:nvSpPr>
@@ -9587,7 +9505,7 @@
       </p:sp>
       <p:sp>
         <p:nvSpPr>
-          <p:cNvPr id="46" name="TextBox 45"/>
+          <p:cNvPr id="45" name="TextBox 44"/>
           <p:cNvSpPr txBox="1"/>
           <p:nvPr/>
         </p:nvSpPr>
@@ -9628,7 +9546,7 @@
       </p:sp>
       <p:sp>
         <p:nvSpPr>
-          <p:cNvPr id="47" name="Freeform 46"/>
+          <p:cNvPr id="46" name="Freeform 45"/>
           <p:cNvSpPr/>
           <p:nvPr/>
         </p:nvSpPr>
@@ -9686,7 +9604,7 @@
       </p:sp>
       <p:sp>
         <p:nvSpPr>
-          <p:cNvPr id="48" name="Freeform 47"/>
+          <p:cNvPr id="47" name="Freeform 46"/>
           <p:cNvSpPr/>
           <p:nvPr/>
         </p:nvSpPr>
@@ -9748,7 +9666,7 @@
       </p:sp>
       <p:sp>
         <p:nvSpPr>
-          <p:cNvPr id="49" name="Freeform 48"/>
+          <p:cNvPr id="48" name="Freeform 47"/>
           <p:cNvSpPr/>
           <p:nvPr/>
         </p:nvSpPr>
@@ -9806,7 +9724,7 @@
       </p:sp>
       <p:sp>
         <p:nvSpPr>
-          <p:cNvPr id="50" name="Freeform 49"/>
+          <p:cNvPr id="49" name="Freeform 48"/>
           <p:cNvSpPr/>
           <p:nvPr/>
         </p:nvSpPr>
@@ -9868,7 +9786,7 @@
       </p:sp>
       <p:sp>
         <p:nvSpPr>
-          <p:cNvPr id="51" name="Freeform 50"/>
+          <p:cNvPr id="50" name="Freeform 49"/>
           <p:cNvSpPr/>
           <p:nvPr/>
         </p:nvSpPr>
@@ -9926,7 +9844,7 @@
       </p:sp>
       <p:sp>
         <p:nvSpPr>
-          <p:cNvPr id="52" name="Freeform 51"/>
+          <p:cNvPr id="51" name="Freeform 50"/>
           <p:cNvSpPr/>
           <p:nvPr/>
         </p:nvSpPr>
@@ -10184,48 +10102,7 @@
       </p:sp>
       <p:sp>
         <p:nvSpPr>
-          <p:cNvPr id="6" name="TextBox 5"/>
-          <p:cNvSpPr txBox="1"/>
-          <p:nvPr/>
-        </p:nvSpPr>
-        <p:spPr>
-          <a:xfrm>
-            <a:off x="10312400" y="254000"/>
-            <a:ext cx="1270000" cy="558800"/>
-          </a:xfrm>
-          <a:prstGeom prst="rect">
-            <a:avLst/>
-          </a:prstGeom>
-          <a:noFill/>
-        </p:spPr>
-        <p:txBody>
-          <a:bodyPr wrap="square" lIns="0" rIns="0" tIns="0" bIns="0" anchor="t">
-            <a:noAutofit/>
-          </a:bodyPr>
-          <a:lstStyle/>
-          <a:p>
-            <a:pPr algn="r">
-              <a:lnSpc>
-                <a:spcPct val="100000"/>
-              </a:lnSpc>
-            </a:pPr>
-            <a:r>
-              <a:rPr sz="3000" b="1" i="0">
-                <a:solidFill>
-                  <a:srgbClr val="E3EAF2"/>
-                </a:solidFill>
-                <a:latin typeface="Arial"/>
-                <a:ea typeface="Microsoft YaHei"/>
-                <a:cs typeface="Arial"/>
-              </a:rPr>
-              <a:t>04</a:t>
-            </a:r>
-          </a:p>
-        </p:txBody>
-      </p:sp>
-      <p:sp>
-        <p:nvSpPr>
-          <p:cNvPr id="7" name="Freeform 6"/>
+          <p:cNvPr id="6" name="Freeform 5"/>
           <p:cNvSpPr/>
           <p:nvPr/>
         </p:nvSpPr>
@@ -10283,7 +10160,7 @@
       </p:sp>
       <p:sp>
         <p:nvSpPr>
-          <p:cNvPr id="8" name="Freeform 7"/>
+          <p:cNvPr id="7" name="Freeform 6"/>
           <p:cNvSpPr/>
           <p:nvPr/>
         </p:nvSpPr>
@@ -10341,7 +10218,7 @@
       </p:sp>
       <p:sp>
         <p:nvSpPr>
-          <p:cNvPr id="9" name="TextBox 8"/>
+          <p:cNvPr id="8" name="TextBox 7"/>
           <p:cNvSpPr txBox="1"/>
           <p:nvPr/>
         </p:nvSpPr>
@@ -10382,7 +10259,7 @@
       </p:sp>
       <p:sp>
         <p:nvSpPr>
-          <p:cNvPr id="10" name="TextBox 9"/>
+          <p:cNvPr id="9" name="TextBox 8"/>
           <p:cNvSpPr txBox="1"/>
           <p:nvPr/>
         </p:nvSpPr>
@@ -10423,7 +10300,7 @@
       </p:sp>
       <p:sp>
         <p:nvSpPr>
-          <p:cNvPr id="11" name="Rounded Rectangle 10"/>
+          <p:cNvPr id="10" name="Rounded Rectangle 9"/>
           <p:cNvSpPr/>
           <p:nvPr/>
         </p:nvSpPr>
@@ -10477,7 +10354,7 @@
       </p:sp>
       <p:sp>
         <p:nvSpPr>
-          <p:cNvPr id="12" name="Rounded Rectangle 11"/>
+          <p:cNvPr id="11" name="Rounded Rectangle 10"/>
           <p:cNvSpPr/>
           <p:nvPr/>
         </p:nvSpPr>
@@ -10523,7 +10400,7 @@
       </p:sp>
       <p:sp>
         <p:nvSpPr>
-          <p:cNvPr id="13" name="Rounded Rectangle 12"/>
+          <p:cNvPr id="12" name="Rounded Rectangle 11"/>
           <p:cNvSpPr/>
           <p:nvPr/>
         </p:nvSpPr>
@@ -10569,7 +10446,7 @@
       </p:sp>
       <p:sp>
         <p:nvSpPr>
-          <p:cNvPr id="14" name="Oval 13"/>
+          <p:cNvPr id="13" name="Oval 12"/>
           <p:cNvSpPr/>
           <p:nvPr/>
         </p:nvSpPr>
@@ -10613,7 +10490,7 @@
       </p:sp>
       <p:sp>
         <p:nvSpPr>
-          <p:cNvPr id="15" name="Freeform 14"/>
+          <p:cNvPr id="14" name="Freeform 13"/>
           <p:cNvSpPr/>
           <p:nvPr/>
         </p:nvSpPr>
@@ -10671,7 +10548,7 @@
       </p:sp>
       <p:sp>
         <p:nvSpPr>
-          <p:cNvPr id="16" name="Rounded Rectangle 15"/>
+          <p:cNvPr id="15" name="Rounded Rectangle 14"/>
           <p:cNvSpPr/>
           <p:nvPr/>
         </p:nvSpPr>
@@ -10717,7 +10594,7 @@
       </p:sp>
       <p:sp>
         <p:nvSpPr>
-          <p:cNvPr id="17" name="TextBox 16"/>
+          <p:cNvPr id="16" name="TextBox 15"/>
           <p:cNvSpPr txBox="1"/>
           <p:nvPr/>
         </p:nvSpPr>
@@ -10758,7 +10635,7 @@
       </p:sp>
       <p:sp>
         <p:nvSpPr>
-          <p:cNvPr id="18" name="TextBox 17"/>
+          <p:cNvPr id="17" name="TextBox 16"/>
           <p:cNvSpPr txBox="1"/>
           <p:nvPr/>
         </p:nvSpPr>
@@ -10799,7 +10676,7 @@
       </p:sp>
       <p:sp>
         <p:nvSpPr>
-          <p:cNvPr id="19" name="TextBox 18"/>
+          <p:cNvPr id="18" name="TextBox 17"/>
           <p:cNvSpPr txBox="1"/>
           <p:nvPr/>
         </p:nvSpPr>
@@ -10867,7 +10744,7 @@
       </p:sp>
       <p:sp>
         <p:nvSpPr>
-          <p:cNvPr id="20" name="Rounded Rectangle 19"/>
+          <p:cNvPr id="19" name="Rounded Rectangle 18"/>
           <p:cNvSpPr/>
           <p:nvPr/>
         </p:nvSpPr>
@@ -10921,7 +10798,7 @@
       </p:sp>
       <p:sp>
         <p:nvSpPr>
-          <p:cNvPr id="21" name="Rounded Rectangle 20"/>
+          <p:cNvPr id="20" name="Rounded Rectangle 19"/>
           <p:cNvSpPr/>
           <p:nvPr/>
         </p:nvSpPr>
@@ -10967,7 +10844,7 @@
       </p:sp>
       <p:sp>
         <p:nvSpPr>
-          <p:cNvPr id="22" name="Rounded Rectangle 21"/>
+          <p:cNvPr id="21" name="Rounded Rectangle 20"/>
           <p:cNvSpPr/>
           <p:nvPr/>
         </p:nvSpPr>
@@ -11013,7 +10890,7 @@
       </p:sp>
       <p:sp>
         <p:nvSpPr>
-          <p:cNvPr id="23" name="Freeform 22"/>
+          <p:cNvPr id="22" name="Freeform 21"/>
           <p:cNvSpPr/>
           <p:nvPr/>
         </p:nvSpPr>
@@ -11212,7 +11089,7 @@
       </p:sp>
       <p:sp>
         <p:nvSpPr>
-          <p:cNvPr id="24" name="Freeform 23"/>
+          <p:cNvPr id="23" name="Freeform 22"/>
           <p:cNvSpPr/>
           <p:nvPr/>
         </p:nvSpPr>
@@ -11411,7 +11288,7 @@
       </p:sp>
       <p:sp>
         <p:nvSpPr>
-          <p:cNvPr id="25" name="Freeform 24"/>
+          <p:cNvPr id="24" name="Freeform 23"/>
           <p:cNvSpPr/>
           <p:nvPr/>
         </p:nvSpPr>
@@ -11610,7 +11487,7 @@
       </p:sp>
       <p:sp>
         <p:nvSpPr>
-          <p:cNvPr id="26" name="Rounded Rectangle 25"/>
+          <p:cNvPr id="25" name="Rounded Rectangle 24"/>
           <p:cNvSpPr/>
           <p:nvPr/>
         </p:nvSpPr>
@@ -11656,7 +11533,7 @@
       </p:sp>
       <p:sp>
         <p:nvSpPr>
-          <p:cNvPr id="27" name="TextBox 26"/>
+          <p:cNvPr id="26" name="TextBox 25"/>
           <p:cNvSpPr txBox="1"/>
           <p:nvPr/>
         </p:nvSpPr>
@@ -11697,7 +11574,7 @@
       </p:sp>
       <p:sp>
         <p:nvSpPr>
-          <p:cNvPr id="28" name="TextBox 27"/>
+          <p:cNvPr id="27" name="TextBox 26"/>
           <p:cNvSpPr txBox="1"/>
           <p:nvPr/>
         </p:nvSpPr>
@@ -11738,7 +11615,7 @@
       </p:sp>
       <p:sp>
         <p:nvSpPr>
-          <p:cNvPr id="29" name="TextBox 28"/>
+          <p:cNvPr id="28" name="TextBox 27"/>
           <p:cNvSpPr txBox="1"/>
           <p:nvPr/>
         </p:nvSpPr>
@@ -11806,7 +11683,7 @@
       </p:sp>
       <p:sp>
         <p:nvSpPr>
-          <p:cNvPr id="30" name="Oval 29"/>
+          <p:cNvPr id="29" name="Oval 28"/>
           <p:cNvSpPr/>
           <p:nvPr/>
         </p:nvSpPr>
@@ -11852,7 +11729,7 @@
       </p:sp>
       <p:sp>
         <p:nvSpPr>
-          <p:cNvPr id="31" name="TextBox 30"/>
+          <p:cNvPr id="30" name="TextBox 29"/>
           <p:cNvSpPr txBox="1"/>
           <p:nvPr/>
         </p:nvSpPr>
@@ -11893,7 +11770,7 @@
       </p:sp>
       <p:sp>
         <p:nvSpPr>
-          <p:cNvPr id="32" name="Freeform 31"/>
+          <p:cNvPr id="31" name="Freeform 30"/>
           <p:cNvSpPr/>
           <p:nvPr/>
         </p:nvSpPr>
@@ -11951,7 +11828,7 @@
       </p:sp>
       <p:sp>
         <p:nvSpPr>
-          <p:cNvPr id="33" name="Freeform 32"/>
+          <p:cNvPr id="32" name="Freeform 31"/>
           <p:cNvSpPr/>
           <p:nvPr/>
         </p:nvSpPr>
@@ -12013,7 +11890,7 @@
       </p:sp>
       <p:sp>
         <p:nvSpPr>
-          <p:cNvPr id="34" name="Freeform 33"/>
+          <p:cNvPr id="33" name="Freeform 32"/>
           <p:cNvSpPr/>
           <p:nvPr/>
         </p:nvSpPr>
@@ -12071,7 +11948,7 @@
       </p:sp>
       <p:sp>
         <p:nvSpPr>
-          <p:cNvPr id="35" name="Freeform 34"/>
+          <p:cNvPr id="34" name="Freeform 33"/>
           <p:cNvSpPr/>
           <p:nvPr/>
         </p:nvSpPr>
@@ -12133,7 +12010,7 @@
       </p:sp>
       <p:sp>
         <p:nvSpPr>
-          <p:cNvPr id="36" name="Rounded Rectangle 35"/>
+          <p:cNvPr id="35" name="Rounded Rectangle 34"/>
           <p:cNvSpPr/>
           <p:nvPr/>
         </p:nvSpPr>
@@ -12179,7 +12056,7 @@
       </p:sp>
       <p:sp>
         <p:nvSpPr>
-          <p:cNvPr id="37" name="Rounded Rectangle 36"/>
+          <p:cNvPr id="36" name="Rounded Rectangle 35"/>
           <p:cNvSpPr/>
           <p:nvPr/>
         </p:nvSpPr>
@@ -12225,7 +12102,7 @@
       </p:sp>
       <p:sp>
         <p:nvSpPr>
-          <p:cNvPr id="38" name="TextBox 37"/>
+          <p:cNvPr id="37" name="TextBox 36"/>
           <p:cNvSpPr txBox="1"/>
           <p:nvPr/>
         </p:nvSpPr>
@@ -12299,7 +12176,7 @@
       </p:sp>
       <p:sp>
         <p:nvSpPr>
-          <p:cNvPr id="39" name="Freeform 38"/>
+          <p:cNvPr id="38" name="Freeform 37"/>
           <p:cNvSpPr/>
           <p:nvPr/>
         </p:nvSpPr>
@@ -12357,7 +12234,7 @@
       </p:sp>
       <p:sp>
         <p:nvSpPr>
-          <p:cNvPr id="40" name="Freeform 39"/>
+          <p:cNvPr id="39" name="Freeform 38"/>
           <p:cNvSpPr/>
           <p:nvPr/>
         </p:nvSpPr>
@@ -12419,7 +12296,7 @@
       </p:sp>
       <p:sp>
         <p:nvSpPr>
-          <p:cNvPr id="41" name="Rounded Rectangle 40"/>
+          <p:cNvPr id="40" name="Rounded Rectangle 39"/>
           <p:cNvSpPr/>
           <p:nvPr/>
         </p:nvSpPr>
@@ -12465,7 +12342,7 @@
       </p:sp>
       <p:sp>
         <p:nvSpPr>
-          <p:cNvPr id="42" name="Rounded Rectangle 41"/>
+          <p:cNvPr id="41" name="Rounded Rectangle 40"/>
           <p:cNvSpPr/>
           <p:nvPr/>
         </p:nvSpPr>
@@ -12511,7 +12388,7 @@
       </p:sp>
       <p:sp>
         <p:nvSpPr>
-          <p:cNvPr id="43" name="TextBox 42"/>
+          <p:cNvPr id="42" name="TextBox 41"/>
           <p:cNvSpPr txBox="1"/>
           <p:nvPr/>
         </p:nvSpPr>
@@ -12607,7 +12484,7 @@
       </p:sp>
       <p:sp>
         <p:nvSpPr>
-          <p:cNvPr id="44" name="Rounded Rectangle 43"/>
+          <p:cNvPr id="43" name="Rounded Rectangle 42"/>
           <p:cNvSpPr/>
           <p:nvPr/>
         </p:nvSpPr>
@@ -12653,7 +12530,7 @@
       </p:sp>
       <p:sp>
         <p:nvSpPr>
-          <p:cNvPr id="45" name="TextBox 44"/>
+          <p:cNvPr id="44" name="TextBox 43"/>
           <p:cNvSpPr txBox="1"/>
           <p:nvPr/>
         </p:nvSpPr>
@@ -12890,48 +12767,7 @@
       </p:sp>
       <p:sp>
         <p:nvSpPr>
-          <p:cNvPr id="6" name="TextBox 5"/>
-          <p:cNvSpPr txBox="1"/>
-          <p:nvPr/>
-        </p:nvSpPr>
-        <p:spPr>
-          <a:xfrm>
-            <a:off x="10312400" y="254000"/>
-            <a:ext cx="1270000" cy="558800"/>
-          </a:xfrm>
-          <a:prstGeom prst="rect">
-            <a:avLst/>
-          </a:prstGeom>
-          <a:noFill/>
-        </p:spPr>
-        <p:txBody>
-          <a:bodyPr wrap="square" lIns="0" rIns="0" tIns="0" bIns="0" anchor="t">
-            <a:noAutofit/>
-          </a:bodyPr>
-          <a:lstStyle/>
-          <a:p>
-            <a:pPr algn="r">
-              <a:lnSpc>
-                <a:spcPct val="100000"/>
-              </a:lnSpc>
-            </a:pPr>
-            <a:r>
-              <a:rPr sz="3000" b="1" i="0">
-                <a:solidFill>
-                  <a:srgbClr val="E3EAF2"/>
-                </a:solidFill>
-                <a:latin typeface="Arial"/>
-                <a:ea typeface="Microsoft YaHei"/>
-                <a:cs typeface="Arial"/>
-              </a:rPr>
-              <a:t>05</a:t>
-            </a:r>
-          </a:p>
-        </p:txBody>
-      </p:sp>
-      <p:sp>
-        <p:nvSpPr>
-          <p:cNvPr id="7" name="Freeform 6"/>
+          <p:cNvPr id="6" name="Freeform 5"/>
           <p:cNvSpPr/>
           <p:nvPr/>
         </p:nvSpPr>
@@ -12989,7 +12825,7 @@
       </p:sp>
       <p:sp>
         <p:nvSpPr>
-          <p:cNvPr id="8" name="Freeform 7"/>
+          <p:cNvPr id="7" name="Freeform 6"/>
           <p:cNvSpPr/>
           <p:nvPr/>
         </p:nvSpPr>
@@ -13047,7 +12883,7 @@
       </p:sp>
       <p:sp>
         <p:nvSpPr>
-          <p:cNvPr id="9" name="TextBox 8"/>
+          <p:cNvPr id="8" name="TextBox 7"/>
           <p:cNvSpPr txBox="1"/>
           <p:nvPr/>
         </p:nvSpPr>
@@ -13088,7 +12924,7 @@
       </p:sp>
       <p:sp>
         <p:nvSpPr>
-          <p:cNvPr id="10" name="TextBox 9"/>
+          <p:cNvPr id="9" name="TextBox 8"/>
           <p:cNvSpPr txBox="1"/>
           <p:nvPr/>
         </p:nvSpPr>
@@ -13129,7 +12965,7 @@
       </p:sp>
       <p:sp>
         <p:nvSpPr>
-          <p:cNvPr id="11" name="Rounded Rectangle 10"/>
+          <p:cNvPr id="10" name="Rounded Rectangle 9"/>
           <p:cNvSpPr/>
           <p:nvPr/>
         </p:nvSpPr>
@@ -13183,7 +13019,7 @@
       </p:sp>
       <p:sp>
         <p:nvSpPr>
-          <p:cNvPr id="12" name="TextBox 11"/>
+          <p:cNvPr id="11" name="TextBox 10"/>
           <p:cNvSpPr txBox="1"/>
           <p:nvPr/>
         </p:nvSpPr>
@@ -13224,7 +13060,7 @@
       </p:sp>
       <p:sp>
         <p:nvSpPr>
-          <p:cNvPr id="13" name="Rounded Rectangle 12"/>
+          <p:cNvPr id="12" name="Rounded Rectangle 11"/>
           <p:cNvSpPr/>
           <p:nvPr/>
         </p:nvSpPr>
@@ -13270,7 +13106,7 @@
       </p:sp>
       <p:sp>
         <p:nvSpPr>
-          <p:cNvPr id="14" name="TextBox 13"/>
+          <p:cNvPr id="13" name="TextBox 12"/>
           <p:cNvSpPr txBox="1"/>
           <p:nvPr/>
         </p:nvSpPr>
@@ -13311,7 +13147,7 @@
       </p:sp>
       <p:sp>
         <p:nvSpPr>
-          <p:cNvPr id="15" name="Rounded Rectangle 14"/>
+          <p:cNvPr id="14" name="Rounded Rectangle 13"/>
           <p:cNvSpPr/>
           <p:nvPr/>
         </p:nvSpPr>
@@ -13357,7 +13193,7 @@
       </p:sp>
       <p:sp>
         <p:nvSpPr>
-          <p:cNvPr id="16" name="TextBox 15"/>
+          <p:cNvPr id="15" name="TextBox 14"/>
           <p:cNvSpPr txBox="1"/>
           <p:nvPr/>
         </p:nvSpPr>
@@ -13398,7 +13234,7 @@
       </p:sp>
       <p:sp>
         <p:nvSpPr>
-          <p:cNvPr id="17" name="Rounded Rectangle 16"/>
+          <p:cNvPr id="16" name="Rounded Rectangle 15"/>
           <p:cNvSpPr/>
           <p:nvPr/>
         </p:nvSpPr>
@@ -13452,7 +13288,7 @@
       </p:sp>
       <p:sp>
         <p:nvSpPr>
-          <p:cNvPr id="18" name="Rounded Rectangle 17"/>
+          <p:cNvPr id="17" name="Rounded Rectangle 16"/>
           <p:cNvSpPr/>
           <p:nvPr/>
         </p:nvSpPr>
@@ -13498,7 +13334,7 @@
       </p:sp>
       <p:sp>
         <p:nvSpPr>
-          <p:cNvPr id="19" name="TextBox 18"/>
+          <p:cNvPr id="18" name="TextBox 17"/>
           <p:cNvSpPr txBox="1"/>
           <p:nvPr/>
         </p:nvSpPr>
@@ -13572,7 +13408,7 @@
       </p:sp>
       <p:sp>
         <p:nvSpPr>
-          <p:cNvPr id="20" name="TextBox 19"/>
+          <p:cNvPr id="19" name="TextBox 18"/>
           <p:cNvSpPr txBox="1"/>
           <p:nvPr/>
         </p:nvSpPr>
@@ -13613,7 +13449,7 @@
       </p:sp>
       <p:sp>
         <p:nvSpPr>
-          <p:cNvPr id="21" name="Rounded Rectangle 20"/>
+          <p:cNvPr id="20" name="Rounded Rectangle 19"/>
           <p:cNvSpPr/>
           <p:nvPr/>
         </p:nvSpPr>
@@ -13667,7 +13503,7 @@
       </p:sp>
       <p:sp>
         <p:nvSpPr>
-          <p:cNvPr id="22" name="Rounded Rectangle 21"/>
+          <p:cNvPr id="21" name="Rounded Rectangle 20"/>
           <p:cNvSpPr/>
           <p:nvPr/>
         </p:nvSpPr>
@@ -13713,7 +13549,7 @@
       </p:sp>
       <p:sp>
         <p:nvSpPr>
-          <p:cNvPr id="23" name="TextBox 22"/>
+          <p:cNvPr id="22" name="TextBox 21"/>
           <p:cNvSpPr txBox="1"/>
           <p:nvPr/>
         </p:nvSpPr>
@@ -13787,7 +13623,7 @@
       </p:sp>
       <p:sp>
         <p:nvSpPr>
-          <p:cNvPr id="24" name="TextBox 23"/>
+          <p:cNvPr id="23" name="TextBox 22"/>
           <p:cNvSpPr txBox="1"/>
           <p:nvPr/>
         </p:nvSpPr>
@@ -13828,7 +13664,7 @@
       </p:sp>
       <p:sp>
         <p:nvSpPr>
-          <p:cNvPr id="25" name="Rounded Rectangle 24"/>
+          <p:cNvPr id="24" name="Rounded Rectangle 23"/>
           <p:cNvSpPr/>
           <p:nvPr/>
         </p:nvSpPr>
@@ -13882,7 +13718,7 @@
       </p:sp>
       <p:sp>
         <p:nvSpPr>
-          <p:cNvPr id="26" name="Rounded Rectangle 25"/>
+          <p:cNvPr id="25" name="Rounded Rectangle 24"/>
           <p:cNvSpPr/>
           <p:nvPr/>
         </p:nvSpPr>
@@ -13928,7 +13764,7 @@
       </p:sp>
       <p:sp>
         <p:nvSpPr>
-          <p:cNvPr id="27" name="TextBox 26"/>
+          <p:cNvPr id="26" name="TextBox 25"/>
           <p:cNvSpPr txBox="1"/>
           <p:nvPr/>
         </p:nvSpPr>
@@ -14002,7 +13838,7 @@
       </p:sp>
       <p:sp>
         <p:nvSpPr>
-          <p:cNvPr id="28" name="TextBox 27"/>
+          <p:cNvPr id="27" name="TextBox 26"/>
           <p:cNvSpPr txBox="1"/>
           <p:nvPr/>
         </p:nvSpPr>
@@ -14043,7 +13879,7 @@
       </p:sp>
       <p:sp>
         <p:nvSpPr>
-          <p:cNvPr id="29" name="Rounded Rectangle 28"/>
+          <p:cNvPr id="28" name="Rounded Rectangle 27"/>
           <p:cNvSpPr/>
           <p:nvPr/>
         </p:nvSpPr>
@@ -14097,7 +13933,7 @@
       </p:sp>
       <p:sp>
         <p:nvSpPr>
-          <p:cNvPr id="30" name="Rounded Rectangle 29"/>
+          <p:cNvPr id="29" name="Rounded Rectangle 28"/>
           <p:cNvSpPr/>
           <p:nvPr/>
         </p:nvSpPr>
@@ -14143,7 +13979,7 @@
       </p:sp>
       <p:sp>
         <p:nvSpPr>
-          <p:cNvPr id="31" name="TextBox 30"/>
+          <p:cNvPr id="30" name="TextBox 29"/>
           <p:cNvSpPr txBox="1"/>
           <p:nvPr/>
         </p:nvSpPr>
@@ -14206,7 +14042,7 @@
       </p:sp>
       <p:sp>
         <p:nvSpPr>
-          <p:cNvPr id="32" name="TextBox 31"/>
+          <p:cNvPr id="31" name="TextBox 30"/>
           <p:cNvSpPr txBox="1"/>
           <p:nvPr/>
         </p:nvSpPr>
@@ -14247,7 +14083,7 @@
       </p:sp>
       <p:sp>
         <p:nvSpPr>
-          <p:cNvPr id="33" name="Freeform 32"/>
+          <p:cNvPr id="32" name="Freeform 31"/>
           <p:cNvSpPr/>
           <p:nvPr/>
         </p:nvSpPr>
@@ -14305,7 +14141,7 @@
       </p:sp>
       <p:sp>
         <p:nvSpPr>
-          <p:cNvPr id="34" name="Freeform 33"/>
+          <p:cNvPr id="33" name="Freeform 32"/>
           <p:cNvSpPr/>
           <p:nvPr/>
         </p:nvSpPr>
@@ -14367,7 +14203,7 @@
       </p:sp>
       <p:sp>
         <p:nvSpPr>
-          <p:cNvPr id="35" name="TextBox 34"/>
+          <p:cNvPr id="34" name="TextBox 33"/>
           <p:cNvSpPr txBox="1"/>
           <p:nvPr/>
         </p:nvSpPr>
@@ -14408,7 +14244,7 @@
       </p:sp>
       <p:sp>
         <p:nvSpPr>
-          <p:cNvPr id="36" name="Freeform 35"/>
+          <p:cNvPr id="35" name="Freeform 34"/>
           <p:cNvSpPr/>
           <p:nvPr/>
         </p:nvSpPr>
@@ -14466,7 +14302,7 @@
       </p:sp>
       <p:sp>
         <p:nvSpPr>
-          <p:cNvPr id="37" name="Freeform 36"/>
+          <p:cNvPr id="36" name="Freeform 35"/>
           <p:cNvSpPr/>
           <p:nvPr/>
         </p:nvSpPr>
@@ -14528,7 +14364,7 @@
       </p:sp>
       <p:sp>
         <p:nvSpPr>
-          <p:cNvPr id="38" name="TextBox 37"/>
+          <p:cNvPr id="37" name="TextBox 36"/>
           <p:cNvSpPr txBox="1"/>
           <p:nvPr/>
         </p:nvSpPr>
@@ -14569,7 +14405,7 @@
       </p:sp>
       <p:sp>
         <p:nvSpPr>
-          <p:cNvPr id="39" name="Freeform 38"/>
+          <p:cNvPr id="38" name="Freeform 37"/>
           <p:cNvSpPr/>
           <p:nvPr/>
         </p:nvSpPr>
@@ -14627,7 +14463,7 @@
       </p:sp>
       <p:sp>
         <p:nvSpPr>
-          <p:cNvPr id="40" name="Freeform 39"/>
+          <p:cNvPr id="39" name="Freeform 38"/>
           <p:cNvSpPr/>
           <p:nvPr/>
         </p:nvSpPr>
@@ -14689,7 +14525,7 @@
       </p:sp>
       <p:sp>
         <p:nvSpPr>
-          <p:cNvPr id="41" name="TextBox 40"/>
+          <p:cNvPr id="40" name="TextBox 39"/>
           <p:cNvSpPr txBox="1"/>
           <p:nvPr/>
         </p:nvSpPr>
@@ -14730,7 +14566,7 @@
       </p:sp>
       <p:sp>
         <p:nvSpPr>
-          <p:cNvPr id="42" name="Freeform 41"/>
+          <p:cNvPr id="41" name="Freeform 40"/>
           <p:cNvSpPr/>
           <p:nvPr/>
         </p:nvSpPr>
@@ -14788,7 +14624,7 @@
       </p:sp>
       <p:sp>
         <p:nvSpPr>
-          <p:cNvPr id="43" name="Freeform 42"/>
+          <p:cNvPr id="42" name="Freeform 41"/>
           <p:cNvSpPr/>
           <p:nvPr/>
         </p:nvSpPr>
@@ -14850,7 +14686,7 @@
       </p:sp>
       <p:sp>
         <p:nvSpPr>
-          <p:cNvPr id="44" name="Rounded Rectangle 43"/>
+          <p:cNvPr id="43" name="Rounded Rectangle 42"/>
           <p:cNvSpPr/>
           <p:nvPr/>
         </p:nvSpPr>
@@ -14898,7 +14734,7 @@
       </p:sp>
       <p:sp>
         <p:nvSpPr>
-          <p:cNvPr id="45" name="TextBox 44"/>
+          <p:cNvPr id="44" name="TextBox 43"/>
           <p:cNvSpPr txBox="1"/>
           <p:nvPr/>
         </p:nvSpPr>
@@ -14939,7 +14775,7 @@
       </p:sp>
       <p:sp>
         <p:nvSpPr>
-          <p:cNvPr id="46" name="Rounded Rectangle 45"/>
+          <p:cNvPr id="45" name="Rounded Rectangle 44"/>
           <p:cNvSpPr/>
           <p:nvPr/>
         </p:nvSpPr>
@@ -14993,7 +14829,7 @@
       </p:sp>
       <p:sp>
         <p:nvSpPr>
-          <p:cNvPr id="47" name="Rounded Rectangle 46"/>
+          <p:cNvPr id="46" name="Rounded Rectangle 45"/>
           <p:cNvSpPr/>
           <p:nvPr/>
         </p:nvSpPr>
@@ -15039,7 +14875,7 @@
       </p:sp>
       <p:sp>
         <p:nvSpPr>
-          <p:cNvPr id="48" name="Rounded Rectangle 47"/>
+          <p:cNvPr id="47" name="Rounded Rectangle 46"/>
           <p:cNvSpPr/>
           <p:nvPr/>
         </p:nvSpPr>
@@ -15085,7 +14921,7 @@
       </p:sp>
       <p:sp>
         <p:nvSpPr>
-          <p:cNvPr id="49" name="Oval 48"/>
+          <p:cNvPr id="48" name="Oval 47"/>
           <p:cNvSpPr/>
           <p:nvPr/>
         </p:nvSpPr>
@@ -15129,7 +14965,7 @@
       </p:sp>
       <p:sp>
         <p:nvSpPr>
-          <p:cNvPr id="50" name="Oval 49"/>
+          <p:cNvPr id="49" name="Oval 48"/>
           <p:cNvSpPr/>
           <p:nvPr/>
         </p:nvSpPr>
@@ -15173,7 +15009,7 @@
       </p:sp>
       <p:sp>
         <p:nvSpPr>
-          <p:cNvPr id="51" name="Oval 50"/>
+          <p:cNvPr id="50" name="Oval 49"/>
           <p:cNvSpPr/>
           <p:nvPr/>
         </p:nvSpPr>
@@ -15217,7 +15053,7 @@
       </p:sp>
       <p:sp>
         <p:nvSpPr>
-          <p:cNvPr id="52" name="TextBox 51"/>
+          <p:cNvPr id="51" name="TextBox 50"/>
           <p:cNvSpPr txBox="1"/>
           <p:nvPr/>
         </p:nvSpPr>
@@ -15258,7 +15094,7 @@
       </p:sp>
       <p:sp>
         <p:nvSpPr>
-          <p:cNvPr id="53" name="Freeform 52"/>
+          <p:cNvPr id="52" name="Freeform 51"/>
           <p:cNvSpPr/>
           <p:nvPr/>
         </p:nvSpPr>
@@ -15316,7 +15152,7 @@
       </p:sp>
       <p:sp>
         <p:nvSpPr>
-          <p:cNvPr id="54" name="TextBox 53"/>
+          <p:cNvPr id="53" name="TextBox 52"/>
           <p:cNvSpPr txBox="1"/>
           <p:nvPr/>
         </p:nvSpPr>
@@ -15379,7 +15215,7 @@
       </p:sp>
       <p:sp>
         <p:nvSpPr>
-          <p:cNvPr id="55" name="Rounded Rectangle 54"/>
+          <p:cNvPr id="54" name="Rounded Rectangle 53"/>
           <p:cNvSpPr/>
           <p:nvPr/>
         </p:nvSpPr>
@@ -15433,7 +15269,7 @@
       </p:sp>
       <p:sp>
         <p:nvSpPr>
-          <p:cNvPr id="56" name="Rounded Rectangle 55"/>
+          <p:cNvPr id="55" name="Rounded Rectangle 54"/>
           <p:cNvSpPr/>
           <p:nvPr/>
         </p:nvSpPr>
@@ -15479,7 +15315,7 @@
       </p:sp>
       <p:sp>
         <p:nvSpPr>
-          <p:cNvPr id="57" name="Rounded Rectangle 56"/>
+          <p:cNvPr id="56" name="Rounded Rectangle 55"/>
           <p:cNvSpPr/>
           <p:nvPr/>
         </p:nvSpPr>
@@ -15525,7 +15361,7 @@
       </p:sp>
       <p:sp>
         <p:nvSpPr>
-          <p:cNvPr id="58" name="Freeform 57"/>
+          <p:cNvPr id="57" name="Freeform 56"/>
           <p:cNvSpPr/>
           <p:nvPr/>
         </p:nvSpPr>
@@ -15724,7 +15560,7 @@
       </p:sp>
       <p:sp>
         <p:nvSpPr>
-          <p:cNvPr id="59" name="Freeform 58"/>
+          <p:cNvPr id="58" name="Freeform 57"/>
           <p:cNvSpPr/>
           <p:nvPr/>
         </p:nvSpPr>
@@ -15923,7 +15759,7 @@
       </p:sp>
       <p:sp>
         <p:nvSpPr>
-          <p:cNvPr id="60" name="Freeform 59"/>
+          <p:cNvPr id="59" name="Freeform 58"/>
           <p:cNvSpPr/>
           <p:nvPr/>
         </p:nvSpPr>
@@ -16122,7 +15958,7 @@
       </p:sp>
       <p:sp>
         <p:nvSpPr>
-          <p:cNvPr id="61" name="TextBox 60"/>
+          <p:cNvPr id="60" name="TextBox 59"/>
           <p:cNvSpPr txBox="1"/>
           <p:nvPr/>
         </p:nvSpPr>
@@ -16163,7 +15999,7 @@
       </p:sp>
       <p:sp>
         <p:nvSpPr>
-          <p:cNvPr id="62" name="Freeform 61"/>
+          <p:cNvPr id="61" name="Freeform 60"/>
           <p:cNvSpPr/>
           <p:nvPr/>
         </p:nvSpPr>
@@ -16221,7 +16057,7 @@
       </p:sp>
       <p:sp>
         <p:nvSpPr>
-          <p:cNvPr id="63" name="TextBox 62"/>
+          <p:cNvPr id="62" name="TextBox 61"/>
           <p:cNvSpPr txBox="1"/>
           <p:nvPr/>
         </p:nvSpPr>
@@ -16284,7 +16120,7 @@
       </p:sp>
       <p:sp>
         <p:nvSpPr>
-          <p:cNvPr id="64" name="Rounded Rectangle 63"/>
+          <p:cNvPr id="63" name="Rounded Rectangle 62"/>
           <p:cNvSpPr/>
           <p:nvPr/>
         </p:nvSpPr>
@@ -16338,7 +16174,7 @@
       </p:sp>
       <p:sp>
         <p:nvSpPr>
-          <p:cNvPr id="65" name="Rounded Rectangle 64"/>
+          <p:cNvPr id="64" name="Rounded Rectangle 63"/>
           <p:cNvSpPr/>
           <p:nvPr/>
         </p:nvSpPr>
@@ -16384,7 +16220,7 @@
       </p:sp>
       <p:sp>
         <p:nvSpPr>
-          <p:cNvPr id="66" name="Rounded Rectangle 65"/>
+          <p:cNvPr id="65" name="Rounded Rectangle 64"/>
           <p:cNvSpPr/>
           <p:nvPr/>
         </p:nvSpPr>
@@ -16430,7 +16266,7 @@
       </p:sp>
       <p:sp>
         <p:nvSpPr>
-          <p:cNvPr id="67" name="Freeform 66"/>
+          <p:cNvPr id="66" name="Freeform 65"/>
           <p:cNvSpPr/>
           <p:nvPr/>
         </p:nvSpPr>
@@ -16629,7 +16465,7 @@
       </p:sp>
       <p:sp>
         <p:nvSpPr>
-          <p:cNvPr id="68" name="Freeform 67"/>
+          <p:cNvPr id="67" name="Freeform 66"/>
           <p:cNvSpPr/>
           <p:nvPr/>
         </p:nvSpPr>
@@ -16828,7 +16664,7 @@
       </p:sp>
       <p:sp>
         <p:nvSpPr>
-          <p:cNvPr id="69" name="Freeform 68"/>
+          <p:cNvPr id="68" name="Freeform 67"/>
           <p:cNvSpPr/>
           <p:nvPr/>
         </p:nvSpPr>
@@ -16886,7 +16722,7 @@
       </p:sp>
       <p:sp>
         <p:nvSpPr>
-          <p:cNvPr id="70" name="TextBox 69"/>
+          <p:cNvPr id="69" name="TextBox 68"/>
           <p:cNvSpPr txBox="1"/>
           <p:nvPr/>
         </p:nvSpPr>
@@ -16927,7 +16763,7 @@
       </p:sp>
       <p:sp>
         <p:nvSpPr>
-          <p:cNvPr id="71" name="Freeform 70"/>
+          <p:cNvPr id="70" name="Freeform 69"/>
           <p:cNvSpPr/>
           <p:nvPr/>
         </p:nvSpPr>
@@ -16985,7 +16821,7 @@
       </p:sp>
       <p:sp>
         <p:nvSpPr>
-          <p:cNvPr id="72" name="TextBox 71"/>
+          <p:cNvPr id="71" name="TextBox 70"/>
           <p:cNvSpPr txBox="1"/>
           <p:nvPr/>
         </p:nvSpPr>
@@ -17266,48 +17102,7 @@
       </p:sp>
       <p:sp>
         <p:nvSpPr>
-          <p:cNvPr id="6" name="TextBox 5"/>
-          <p:cNvSpPr txBox="1"/>
-          <p:nvPr/>
-        </p:nvSpPr>
-        <p:spPr>
-          <a:xfrm>
-            <a:off x="10312400" y="254000"/>
-            <a:ext cx="1270000" cy="558800"/>
-          </a:xfrm>
-          <a:prstGeom prst="rect">
-            <a:avLst/>
-          </a:prstGeom>
-          <a:noFill/>
-        </p:spPr>
-        <p:txBody>
-          <a:bodyPr wrap="square" lIns="0" rIns="0" tIns="0" bIns="0" anchor="t">
-            <a:noAutofit/>
-          </a:bodyPr>
-          <a:lstStyle/>
-          <a:p>
-            <a:pPr algn="r">
-              <a:lnSpc>
-                <a:spcPct val="100000"/>
-              </a:lnSpc>
-            </a:pPr>
-            <a:r>
-              <a:rPr sz="3000" b="1" i="0">
-                <a:solidFill>
-                  <a:srgbClr val="E3EAF2"/>
-                </a:solidFill>
-                <a:latin typeface="Arial"/>
-                <a:ea typeface="Microsoft YaHei"/>
-                <a:cs typeface="Arial"/>
-              </a:rPr>
-              <a:t>06</a:t>
-            </a:r>
-          </a:p>
-        </p:txBody>
-      </p:sp>
-      <p:sp>
-        <p:nvSpPr>
-          <p:cNvPr id="7" name="Freeform 6"/>
+          <p:cNvPr id="6" name="Freeform 5"/>
           <p:cNvSpPr/>
           <p:nvPr/>
         </p:nvSpPr>
@@ -17365,7 +17160,7 @@
       </p:sp>
       <p:sp>
         <p:nvSpPr>
-          <p:cNvPr id="8" name="Freeform 7"/>
+          <p:cNvPr id="7" name="Freeform 6"/>
           <p:cNvSpPr/>
           <p:nvPr/>
         </p:nvSpPr>
@@ -17423,7 +17218,7 @@
       </p:sp>
       <p:sp>
         <p:nvSpPr>
-          <p:cNvPr id="9" name="TextBox 8"/>
+          <p:cNvPr id="8" name="TextBox 7"/>
           <p:cNvSpPr txBox="1"/>
           <p:nvPr/>
         </p:nvSpPr>
@@ -17464,7 +17259,7 @@
       </p:sp>
       <p:sp>
         <p:nvSpPr>
-          <p:cNvPr id="10" name="TextBox 9"/>
+          <p:cNvPr id="9" name="TextBox 8"/>
           <p:cNvSpPr txBox="1"/>
           <p:nvPr/>
         </p:nvSpPr>
@@ -17505,7 +17300,7 @@
       </p:sp>
       <p:sp>
         <p:nvSpPr>
-          <p:cNvPr id="11" name="Freeform 10"/>
+          <p:cNvPr id="10" name="Freeform 9"/>
           <p:cNvSpPr/>
           <p:nvPr/>
         </p:nvSpPr>
@@ -17570,7 +17365,7 @@
       </p:sp>
       <p:sp>
         <p:nvSpPr>
-          <p:cNvPr id="12" name="TextBox 11"/>
+          <p:cNvPr id="11" name="TextBox 10"/>
           <p:cNvSpPr txBox="1"/>
           <p:nvPr/>
         </p:nvSpPr>
@@ -17611,7 +17406,7 @@
       </p:sp>
       <p:sp>
         <p:nvSpPr>
-          <p:cNvPr id="13" name="TextBox 12"/>
+          <p:cNvPr id="12" name="TextBox 11"/>
           <p:cNvSpPr txBox="1"/>
           <p:nvPr/>
         </p:nvSpPr>
@@ -17652,7 +17447,7 @@
       </p:sp>
       <p:sp>
         <p:nvSpPr>
-          <p:cNvPr id="14" name="Freeform 13"/>
+          <p:cNvPr id="13" name="Freeform 12"/>
           <p:cNvSpPr/>
           <p:nvPr/>
         </p:nvSpPr>
@@ -17711,7 +17506,7 @@
       </p:sp>
       <p:sp>
         <p:nvSpPr>
-          <p:cNvPr id="15" name="Oval 14"/>
+          <p:cNvPr id="14" name="Oval 13"/>
           <p:cNvSpPr/>
           <p:nvPr/>
         </p:nvSpPr>
@@ -17755,7 +17550,7 @@
       </p:sp>
       <p:sp>
         <p:nvSpPr>
-          <p:cNvPr id="16" name="TextBox 15"/>
+          <p:cNvPr id="15" name="TextBox 14"/>
           <p:cNvSpPr txBox="1"/>
           <p:nvPr/>
         </p:nvSpPr>
@@ -17796,7 +17591,7 @@
       </p:sp>
       <p:sp>
         <p:nvSpPr>
-          <p:cNvPr id="17" name="Rounded Rectangle 16"/>
+          <p:cNvPr id="16" name="Rounded Rectangle 15"/>
           <p:cNvSpPr/>
           <p:nvPr/>
         </p:nvSpPr>
@@ -17842,7 +17637,7 @@
       </p:sp>
       <p:sp>
         <p:nvSpPr>
-          <p:cNvPr id="18" name="TextBox 17"/>
+          <p:cNvPr id="17" name="TextBox 16"/>
           <p:cNvSpPr txBox="1"/>
           <p:nvPr/>
         </p:nvSpPr>
@@ -17883,7 +17678,7 @@
       </p:sp>
       <p:sp>
         <p:nvSpPr>
-          <p:cNvPr id="19" name="TextBox 18"/>
+          <p:cNvPr id="18" name="TextBox 17"/>
           <p:cNvSpPr txBox="1"/>
           <p:nvPr/>
         </p:nvSpPr>
@@ -17924,7 +17719,7 @@
       </p:sp>
       <p:sp>
         <p:nvSpPr>
-          <p:cNvPr id="20" name="TextBox 19"/>
+          <p:cNvPr id="19" name="TextBox 18"/>
           <p:cNvSpPr txBox="1"/>
           <p:nvPr/>
         </p:nvSpPr>
@@ -17965,7 +17760,7 @@
       </p:sp>
       <p:sp>
         <p:nvSpPr>
-          <p:cNvPr id="21" name="Freeform 20"/>
+          <p:cNvPr id="20" name="Freeform 19"/>
           <p:cNvSpPr/>
           <p:nvPr/>
         </p:nvSpPr>
@@ -18036,7 +17831,7 @@
       </p:sp>
       <p:sp>
         <p:nvSpPr>
-          <p:cNvPr id="22" name="Freeform 21"/>
+          <p:cNvPr id="21" name="Freeform 20"/>
           <p:cNvSpPr/>
           <p:nvPr/>
         </p:nvSpPr>
@@ -18101,7 +17896,7 @@
       </p:sp>
       <p:sp>
         <p:nvSpPr>
-          <p:cNvPr id="23" name="TextBox 22"/>
+          <p:cNvPr id="22" name="TextBox 21"/>
           <p:cNvSpPr txBox="1"/>
           <p:nvPr/>
         </p:nvSpPr>
@@ -18142,7 +17937,7 @@
       </p:sp>
       <p:sp>
         <p:nvSpPr>
-          <p:cNvPr id="24" name="TextBox 23"/>
+          <p:cNvPr id="23" name="TextBox 22"/>
           <p:cNvSpPr txBox="1"/>
           <p:nvPr/>
         </p:nvSpPr>
@@ -18183,7 +17978,7 @@
       </p:sp>
       <p:sp>
         <p:nvSpPr>
-          <p:cNvPr id="25" name="Freeform 24"/>
+          <p:cNvPr id="24" name="Freeform 23"/>
           <p:cNvSpPr/>
           <p:nvPr/>
         </p:nvSpPr>
@@ -18242,7 +18037,7 @@
       </p:sp>
       <p:sp>
         <p:nvSpPr>
-          <p:cNvPr id="26" name="Oval 25"/>
+          <p:cNvPr id="25" name="Oval 24"/>
           <p:cNvSpPr/>
           <p:nvPr/>
         </p:nvSpPr>
@@ -18286,7 +18081,7 @@
       </p:sp>
       <p:sp>
         <p:nvSpPr>
-          <p:cNvPr id="27" name="TextBox 26"/>
+          <p:cNvPr id="26" name="TextBox 25"/>
           <p:cNvSpPr txBox="1"/>
           <p:nvPr/>
         </p:nvSpPr>
@@ -18327,7 +18122,7 @@
       </p:sp>
       <p:sp>
         <p:nvSpPr>
-          <p:cNvPr id="28" name="Rounded Rectangle 27"/>
+          <p:cNvPr id="27" name="Rounded Rectangle 26"/>
           <p:cNvSpPr/>
           <p:nvPr/>
         </p:nvSpPr>
@@ -18373,7 +18168,7 @@
       </p:sp>
       <p:sp>
         <p:nvSpPr>
-          <p:cNvPr id="29" name="TextBox 28"/>
+          <p:cNvPr id="28" name="TextBox 27"/>
           <p:cNvSpPr txBox="1"/>
           <p:nvPr/>
         </p:nvSpPr>
@@ -18414,7 +18209,7 @@
       </p:sp>
       <p:sp>
         <p:nvSpPr>
-          <p:cNvPr id="30" name="TextBox 29"/>
+          <p:cNvPr id="29" name="TextBox 28"/>
           <p:cNvSpPr txBox="1"/>
           <p:nvPr/>
         </p:nvSpPr>
@@ -18455,7 +18250,7 @@
       </p:sp>
       <p:sp>
         <p:nvSpPr>
-          <p:cNvPr id="31" name="TextBox 30"/>
+          <p:cNvPr id="30" name="TextBox 29"/>
           <p:cNvSpPr txBox="1"/>
           <p:nvPr/>
         </p:nvSpPr>
@@ -18496,7 +18291,7 @@
       </p:sp>
       <p:sp>
         <p:nvSpPr>
-          <p:cNvPr id="32" name="Freeform 31"/>
+          <p:cNvPr id="31" name="Freeform 30"/>
           <p:cNvSpPr/>
           <p:nvPr/>
         </p:nvSpPr>
@@ -18561,7 +18356,7 @@
       </p:sp>
       <p:sp>
         <p:nvSpPr>
-          <p:cNvPr id="33" name="TextBox 32"/>
+          <p:cNvPr id="32" name="TextBox 31"/>
           <p:cNvSpPr txBox="1"/>
           <p:nvPr/>
         </p:nvSpPr>
@@ -18602,7 +18397,7 @@
       </p:sp>
       <p:sp>
         <p:nvSpPr>
-          <p:cNvPr id="34" name="TextBox 33"/>
+          <p:cNvPr id="33" name="TextBox 32"/>
           <p:cNvSpPr txBox="1"/>
           <p:nvPr/>
         </p:nvSpPr>
@@ -18643,7 +18438,7 @@
       </p:sp>
       <p:sp>
         <p:nvSpPr>
-          <p:cNvPr id="35" name="TextBox 34"/>
+          <p:cNvPr id="34" name="TextBox 33"/>
           <p:cNvSpPr txBox="1"/>
           <p:nvPr/>
         </p:nvSpPr>
@@ -18684,7 +18479,7 @@
       </p:sp>
       <p:sp>
         <p:nvSpPr>
-          <p:cNvPr id="36" name="Freeform 35"/>
+          <p:cNvPr id="35" name="Freeform 34"/>
           <p:cNvSpPr/>
           <p:nvPr/>
         </p:nvSpPr>
@@ -18743,7 +18538,7 @@
       </p:sp>
       <p:sp>
         <p:nvSpPr>
-          <p:cNvPr id="37" name="Oval 36"/>
+          <p:cNvPr id="36" name="Oval 35"/>
           <p:cNvSpPr/>
           <p:nvPr/>
         </p:nvSpPr>
@@ -18787,7 +18582,7 @@
       </p:sp>
       <p:sp>
         <p:nvSpPr>
-          <p:cNvPr id="38" name="TextBox 37"/>
+          <p:cNvPr id="37" name="TextBox 36"/>
           <p:cNvSpPr txBox="1"/>
           <p:nvPr/>
         </p:nvSpPr>
@@ -18828,7 +18623,7 @@
       </p:sp>
       <p:sp>
         <p:nvSpPr>
-          <p:cNvPr id="39" name="Rounded Rectangle 38"/>
+          <p:cNvPr id="38" name="Rounded Rectangle 37"/>
           <p:cNvSpPr/>
           <p:nvPr/>
         </p:nvSpPr>
@@ -18874,7 +18669,7 @@
       </p:sp>
       <p:sp>
         <p:nvSpPr>
-          <p:cNvPr id="40" name="TextBox 39"/>
+          <p:cNvPr id="39" name="TextBox 38"/>
           <p:cNvSpPr txBox="1"/>
           <p:nvPr/>
         </p:nvSpPr>
@@ -18915,7 +18710,7 @@
       </p:sp>
       <p:sp>
         <p:nvSpPr>
-          <p:cNvPr id="41" name="TextBox 40"/>
+          <p:cNvPr id="40" name="TextBox 39"/>
           <p:cNvSpPr txBox="1"/>
           <p:nvPr/>
         </p:nvSpPr>
@@ -18956,7 +18751,7 @@
       </p:sp>
       <p:sp>
         <p:nvSpPr>
-          <p:cNvPr id="42" name="Freeform 41"/>
+          <p:cNvPr id="41" name="Freeform 40"/>
           <p:cNvSpPr/>
           <p:nvPr/>
         </p:nvSpPr>
@@ -19021,7 +18816,7 @@
       </p:sp>
       <p:sp>
         <p:nvSpPr>
-          <p:cNvPr id="43" name="TextBox 42"/>
+          <p:cNvPr id="42" name="TextBox 41"/>
           <p:cNvSpPr txBox="1"/>
           <p:nvPr/>
         </p:nvSpPr>
@@ -19062,7 +18857,7 @@
       </p:sp>
       <p:sp>
         <p:nvSpPr>
-          <p:cNvPr id="44" name="TextBox 43"/>
+          <p:cNvPr id="43" name="TextBox 42"/>
           <p:cNvSpPr txBox="1"/>
           <p:nvPr/>
         </p:nvSpPr>
@@ -19103,7 +18898,7 @@
       </p:sp>
       <p:sp>
         <p:nvSpPr>
-          <p:cNvPr id="45" name="TextBox 44"/>
+          <p:cNvPr id="44" name="TextBox 43"/>
           <p:cNvSpPr txBox="1"/>
           <p:nvPr/>
         </p:nvSpPr>
@@ -19144,7 +18939,7 @@
       </p:sp>
       <p:sp>
         <p:nvSpPr>
-          <p:cNvPr id="46" name="Freeform 45"/>
+          <p:cNvPr id="45" name="Freeform 44"/>
           <p:cNvSpPr/>
           <p:nvPr/>
         </p:nvSpPr>
@@ -19203,7 +18998,7 @@
       </p:sp>
       <p:sp>
         <p:nvSpPr>
-          <p:cNvPr id="47" name="Oval 46"/>
+          <p:cNvPr id="46" name="Oval 45"/>
           <p:cNvSpPr/>
           <p:nvPr/>
         </p:nvSpPr>
@@ -19247,7 +19042,7 @@
       </p:sp>
       <p:sp>
         <p:nvSpPr>
-          <p:cNvPr id="48" name="TextBox 47"/>
+          <p:cNvPr id="47" name="TextBox 46"/>
           <p:cNvSpPr txBox="1"/>
           <p:nvPr/>
         </p:nvSpPr>
@@ -19288,7 +19083,7 @@
       </p:sp>
       <p:sp>
         <p:nvSpPr>
-          <p:cNvPr id="49" name="Rounded Rectangle 48"/>
+          <p:cNvPr id="48" name="Rounded Rectangle 47"/>
           <p:cNvSpPr/>
           <p:nvPr/>
         </p:nvSpPr>
@@ -19334,7 +19129,7 @@
       </p:sp>
       <p:sp>
         <p:nvSpPr>
-          <p:cNvPr id="50" name="TextBox 49"/>
+          <p:cNvPr id="49" name="TextBox 48"/>
           <p:cNvSpPr txBox="1"/>
           <p:nvPr/>
         </p:nvSpPr>
@@ -19375,7 +19170,7 @@
       </p:sp>
       <p:sp>
         <p:nvSpPr>
-          <p:cNvPr id="51" name="TextBox 50"/>
+          <p:cNvPr id="50" name="TextBox 49"/>
           <p:cNvSpPr txBox="1"/>
           <p:nvPr/>
         </p:nvSpPr>
@@ -19416,7 +19211,7 @@
       </p:sp>
       <p:sp>
         <p:nvSpPr>
-          <p:cNvPr id="52" name="TextBox 51"/>
+          <p:cNvPr id="51" name="TextBox 50"/>
           <p:cNvSpPr txBox="1"/>
           <p:nvPr/>
         </p:nvSpPr>
@@ -19653,48 +19448,7 @@
       </p:sp>
       <p:sp>
         <p:nvSpPr>
-          <p:cNvPr id="6" name="TextBox 5"/>
-          <p:cNvSpPr txBox="1"/>
-          <p:nvPr/>
-        </p:nvSpPr>
-        <p:spPr>
-          <a:xfrm>
-            <a:off x="10312400" y="254000"/>
-            <a:ext cx="1270000" cy="558800"/>
-          </a:xfrm>
-          <a:prstGeom prst="rect">
-            <a:avLst/>
-          </a:prstGeom>
-          <a:noFill/>
-        </p:spPr>
-        <p:txBody>
-          <a:bodyPr wrap="square" lIns="0" rIns="0" tIns="0" bIns="0" anchor="t">
-            <a:noAutofit/>
-          </a:bodyPr>
-          <a:lstStyle/>
-          <a:p>
-            <a:pPr algn="r">
-              <a:lnSpc>
-                <a:spcPct val="100000"/>
-              </a:lnSpc>
-            </a:pPr>
-            <a:r>
-              <a:rPr sz="3000" b="1" i="0">
-                <a:solidFill>
-                  <a:srgbClr val="E3EAF2"/>
-                </a:solidFill>
-                <a:latin typeface="Arial"/>
-                <a:ea typeface="Microsoft YaHei"/>
-                <a:cs typeface="Arial"/>
-              </a:rPr>
-              <a:t>07</a:t>
-            </a:r>
-          </a:p>
-        </p:txBody>
-      </p:sp>
-      <p:sp>
-        <p:nvSpPr>
-          <p:cNvPr id="7" name="Freeform 6"/>
+          <p:cNvPr id="6" name="Freeform 5"/>
           <p:cNvSpPr/>
           <p:nvPr/>
         </p:nvSpPr>
@@ -19752,7 +19506,7 @@
       </p:sp>
       <p:sp>
         <p:nvSpPr>
-          <p:cNvPr id="8" name="Freeform 7"/>
+          <p:cNvPr id="7" name="Freeform 6"/>
           <p:cNvSpPr/>
           <p:nvPr/>
         </p:nvSpPr>
@@ -19810,7 +19564,7 @@
       </p:sp>
       <p:sp>
         <p:nvSpPr>
-          <p:cNvPr id="9" name="TextBox 8"/>
+          <p:cNvPr id="8" name="TextBox 7"/>
           <p:cNvSpPr txBox="1"/>
           <p:nvPr/>
         </p:nvSpPr>
@@ -19851,7 +19605,7 @@
       </p:sp>
       <p:sp>
         <p:nvSpPr>
-          <p:cNvPr id="10" name="TextBox 9"/>
+          <p:cNvPr id="9" name="TextBox 8"/>
           <p:cNvSpPr txBox="1"/>
           <p:nvPr/>
         </p:nvSpPr>
@@ -19892,7 +19646,7 @@
       </p:sp>
       <p:sp>
         <p:nvSpPr>
-          <p:cNvPr id="11" name="Rounded Rectangle 10"/>
+          <p:cNvPr id="10" name="Rounded Rectangle 9"/>
           <p:cNvSpPr/>
           <p:nvPr/>
         </p:nvSpPr>
@@ -19940,7 +19694,7 @@
       </p:sp>
       <p:sp>
         <p:nvSpPr>
-          <p:cNvPr id="12" name="Rounded Rectangle 11"/>
+          <p:cNvPr id="11" name="Rounded Rectangle 10"/>
           <p:cNvSpPr/>
           <p:nvPr/>
         </p:nvSpPr>
@@ -19986,7 +19740,7 @@
       </p:sp>
       <p:sp>
         <p:nvSpPr>
-          <p:cNvPr id="13" name="TextBox 12"/>
+          <p:cNvPr id="12" name="TextBox 11"/>
           <p:cNvSpPr txBox="1"/>
           <p:nvPr/>
         </p:nvSpPr>
@@ -20060,7 +19814,7 @@
       </p:sp>
       <p:sp>
         <p:nvSpPr>
-          <p:cNvPr id="14" name="Rounded Rectangle 13"/>
+          <p:cNvPr id="13" name="Rounded Rectangle 12"/>
           <p:cNvSpPr/>
           <p:nvPr/>
         </p:nvSpPr>
@@ -20114,7 +19868,7 @@
       </p:sp>
       <p:sp>
         <p:nvSpPr>
-          <p:cNvPr id="15" name="Rounded Rectangle 14"/>
+          <p:cNvPr id="14" name="Rounded Rectangle 13"/>
           <p:cNvSpPr/>
           <p:nvPr/>
         </p:nvSpPr>
@@ -20160,7 +19914,7 @@
       </p:sp>
       <p:sp>
         <p:nvSpPr>
-          <p:cNvPr id="16" name="Rounded Rectangle 15"/>
+          <p:cNvPr id="15" name="Rounded Rectangle 14"/>
           <p:cNvSpPr/>
           <p:nvPr/>
         </p:nvSpPr>
@@ -20206,7 +19960,7 @@
       </p:sp>
       <p:sp>
         <p:nvSpPr>
-          <p:cNvPr id="17" name="Freeform 16"/>
+          <p:cNvPr id="16" name="Freeform 15"/>
           <p:cNvSpPr/>
           <p:nvPr/>
         </p:nvSpPr>
@@ -20276,7 +20030,7 @@
       </p:sp>
       <p:sp>
         <p:nvSpPr>
-          <p:cNvPr id="18" name="Freeform 17"/>
+          <p:cNvPr id="17" name="Freeform 16"/>
           <p:cNvSpPr/>
           <p:nvPr/>
         </p:nvSpPr>
@@ -20334,7 +20088,7 @@
       </p:sp>
       <p:sp>
         <p:nvSpPr>
-          <p:cNvPr id="19" name="Freeform 18"/>
+          <p:cNvPr id="18" name="Freeform 17"/>
           <p:cNvSpPr/>
           <p:nvPr/>
         </p:nvSpPr>
@@ -20392,7 +20146,7 @@
       </p:sp>
       <p:sp>
         <p:nvSpPr>
-          <p:cNvPr id="20" name="Oval 19"/>
+          <p:cNvPr id="19" name="Oval 18"/>
           <p:cNvSpPr/>
           <p:nvPr/>
         </p:nvSpPr>
@@ -20436,7 +20190,7 @@
       </p:sp>
       <p:sp>
         <p:nvSpPr>
-          <p:cNvPr id="21" name="TextBox 20"/>
+          <p:cNvPr id="20" name="TextBox 19"/>
           <p:cNvSpPr txBox="1"/>
           <p:nvPr/>
         </p:nvSpPr>
@@ -20477,7 +20231,7 @@
       </p:sp>
       <p:sp>
         <p:nvSpPr>
-          <p:cNvPr id="22" name="Rounded Rectangle 21"/>
+          <p:cNvPr id="21" name="Rounded Rectangle 20"/>
           <p:cNvSpPr/>
           <p:nvPr/>
         </p:nvSpPr>
@@ -20523,7 +20277,7 @@
       </p:sp>
       <p:sp>
         <p:nvSpPr>
-          <p:cNvPr id="23" name="TextBox 22"/>
+          <p:cNvPr id="22" name="TextBox 21"/>
           <p:cNvSpPr txBox="1"/>
           <p:nvPr/>
         </p:nvSpPr>
@@ -20564,7 +20318,7 @@
       </p:sp>
       <p:sp>
         <p:nvSpPr>
-          <p:cNvPr id="24" name="TextBox 23"/>
+          <p:cNvPr id="23" name="TextBox 22"/>
           <p:cNvSpPr txBox="1"/>
           <p:nvPr/>
         </p:nvSpPr>
@@ -20654,7 +20408,7 @@
       </p:sp>
       <p:sp>
         <p:nvSpPr>
-          <p:cNvPr id="25" name="Rounded Rectangle 24"/>
+          <p:cNvPr id="24" name="Rounded Rectangle 23"/>
           <p:cNvSpPr/>
           <p:nvPr/>
         </p:nvSpPr>
@@ -20708,7 +20462,7 @@
       </p:sp>
       <p:sp>
         <p:nvSpPr>
-          <p:cNvPr id="26" name="Rounded Rectangle 25"/>
+          <p:cNvPr id="25" name="Rounded Rectangle 24"/>
           <p:cNvSpPr/>
           <p:nvPr/>
         </p:nvSpPr>
@@ -20754,7 +20508,7 @@
       </p:sp>
       <p:sp>
         <p:nvSpPr>
-          <p:cNvPr id="27" name="Rounded Rectangle 26"/>
+          <p:cNvPr id="26" name="Rounded Rectangle 25"/>
           <p:cNvSpPr/>
           <p:nvPr/>
         </p:nvSpPr>
@@ -20800,7 +20554,7 @@
       </p:sp>
       <p:sp>
         <p:nvSpPr>
-          <p:cNvPr id="28" name="Freeform 27"/>
+          <p:cNvPr id="27" name="Freeform 26"/>
           <p:cNvSpPr/>
           <p:nvPr/>
         </p:nvSpPr>
@@ -20873,7 +20627,7 @@
       </p:sp>
       <p:sp>
         <p:nvSpPr>
-          <p:cNvPr id="29" name="Oval 28"/>
+          <p:cNvPr id="28" name="Oval 27"/>
           <p:cNvSpPr/>
           <p:nvPr/>
         </p:nvSpPr>
@@ -20917,7 +20671,7 @@
       </p:sp>
       <p:sp>
         <p:nvSpPr>
-          <p:cNvPr id="30" name="TextBox 29"/>
+          <p:cNvPr id="29" name="TextBox 28"/>
           <p:cNvSpPr txBox="1"/>
           <p:nvPr/>
         </p:nvSpPr>
@@ -20958,7 +20712,7 @@
       </p:sp>
       <p:sp>
         <p:nvSpPr>
-          <p:cNvPr id="31" name="Rounded Rectangle 30"/>
+          <p:cNvPr id="30" name="Rounded Rectangle 29"/>
           <p:cNvSpPr/>
           <p:nvPr/>
         </p:nvSpPr>
@@ -21004,7 +20758,7 @@
       </p:sp>
       <p:sp>
         <p:nvSpPr>
-          <p:cNvPr id="32" name="TextBox 31"/>
+          <p:cNvPr id="31" name="TextBox 30"/>
           <p:cNvSpPr txBox="1"/>
           <p:nvPr/>
         </p:nvSpPr>
@@ -21045,7 +20799,7 @@
       </p:sp>
       <p:sp>
         <p:nvSpPr>
-          <p:cNvPr id="33" name="TextBox 32"/>
+          <p:cNvPr id="32" name="TextBox 31"/>
           <p:cNvSpPr txBox="1"/>
           <p:nvPr/>
         </p:nvSpPr>
@@ -21183,7 +20937,7 @@
       </p:sp>
       <p:sp>
         <p:nvSpPr>
-          <p:cNvPr id="34" name="Rounded Rectangle 33"/>
+          <p:cNvPr id="33" name="Rounded Rectangle 32"/>
           <p:cNvSpPr/>
           <p:nvPr/>
         </p:nvSpPr>
@@ -21237,7 +20991,7 @@
       </p:sp>
       <p:sp>
         <p:nvSpPr>
-          <p:cNvPr id="35" name="Rounded Rectangle 34"/>
+          <p:cNvPr id="34" name="Rounded Rectangle 33"/>
           <p:cNvSpPr/>
           <p:nvPr/>
         </p:nvSpPr>
@@ -21283,7 +21037,7 @@
       </p:sp>
       <p:sp>
         <p:nvSpPr>
-          <p:cNvPr id="36" name="Rounded Rectangle 35"/>
+          <p:cNvPr id="35" name="Rounded Rectangle 34"/>
           <p:cNvSpPr/>
           <p:nvPr/>
         </p:nvSpPr>
@@ -21329,7 +21083,7 @@
       </p:sp>
       <p:sp>
         <p:nvSpPr>
-          <p:cNvPr id="37" name="Rounded Rectangle 36"/>
+          <p:cNvPr id="36" name="Rounded Rectangle 35"/>
           <p:cNvSpPr/>
           <p:nvPr/>
         </p:nvSpPr>
@@ -21375,7 +21129,7 @@
       </p:sp>
       <p:sp>
         <p:nvSpPr>
-          <p:cNvPr id="38" name="Oval 37"/>
+          <p:cNvPr id="37" name="Oval 36"/>
           <p:cNvSpPr/>
           <p:nvPr/>
         </p:nvSpPr>
@@ -21419,7 +21173,7 @@
       </p:sp>
       <p:sp>
         <p:nvSpPr>
-          <p:cNvPr id="39" name="Freeform 38"/>
+          <p:cNvPr id="38" name="Freeform 37"/>
           <p:cNvSpPr/>
           <p:nvPr/>
         </p:nvSpPr>
@@ -21477,7 +21231,7 @@
       </p:sp>
       <p:sp>
         <p:nvSpPr>
-          <p:cNvPr id="40" name="Freeform 39"/>
+          <p:cNvPr id="39" name="Freeform 38"/>
           <p:cNvSpPr/>
           <p:nvPr/>
         </p:nvSpPr>
@@ -21535,7 +21289,7 @@
       </p:sp>
       <p:sp>
         <p:nvSpPr>
-          <p:cNvPr id="41" name="Freeform 40"/>
+          <p:cNvPr id="40" name="Freeform 39"/>
           <p:cNvSpPr/>
           <p:nvPr/>
         </p:nvSpPr>
@@ -21593,7 +21347,7 @@
       </p:sp>
       <p:sp>
         <p:nvSpPr>
-          <p:cNvPr id="42" name="Freeform 41"/>
+          <p:cNvPr id="41" name="Freeform 40"/>
           <p:cNvSpPr/>
           <p:nvPr/>
         </p:nvSpPr>
@@ -21651,7 +21405,7 @@
       </p:sp>
       <p:sp>
         <p:nvSpPr>
-          <p:cNvPr id="43" name="TextBox 42"/>
+          <p:cNvPr id="42" name="TextBox 41"/>
           <p:cNvSpPr txBox="1"/>
           <p:nvPr/>
         </p:nvSpPr>
@@ -21692,7 +21446,7 @@
       </p:sp>
       <p:sp>
         <p:nvSpPr>
-          <p:cNvPr id="44" name="Rounded Rectangle 43"/>
+          <p:cNvPr id="43" name="Rounded Rectangle 42"/>
           <p:cNvSpPr/>
           <p:nvPr/>
         </p:nvSpPr>
@@ -21738,7 +21492,7 @@
       </p:sp>
       <p:sp>
         <p:nvSpPr>
-          <p:cNvPr id="45" name="TextBox 44"/>
+          <p:cNvPr id="44" name="TextBox 43"/>
           <p:cNvSpPr txBox="1"/>
           <p:nvPr/>
         </p:nvSpPr>
@@ -21779,7 +21533,7 @@
       </p:sp>
       <p:sp>
         <p:nvSpPr>
-          <p:cNvPr id="46" name="TextBox 45"/>
+          <p:cNvPr id="45" name="TextBox 44"/>
           <p:cNvSpPr txBox="1"/>
           <p:nvPr/>
         </p:nvSpPr>
@@ -21858,7 +21612,7 @@
       </p:sp>
       <p:sp>
         <p:nvSpPr>
-          <p:cNvPr id="47" name="Rounded Rectangle 46"/>
+          <p:cNvPr id="46" name="Rounded Rectangle 45"/>
           <p:cNvSpPr/>
           <p:nvPr/>
         </p:nvSpPr>
@@ -21912,7 +21666,7 @@
       </p:sp>
       <p:sp>
         <p:nvSpPr>
-          <p:cNvPr id="48" name="TextBox 47"/>
+          <p:cNvPr id="47" name="TextBox 46"/>
           <p:cNvSpPr txBox="1"/>
           <p:nvPr/>
         </p:nvSpPr>
@@ -21953,7 +21707,7 @@
       </p:sp>
       <p:sp>
         <p:nvSpPr>
-          <p:cNvPr id="49" name="TextBox 48"/>
+          <p:cNvPr id="48" name="TextBox 47"/>
           <p:cNvSpPr txBox="1"/>
           <p:nvPr/>
         </p:nvSpPr>
@@ -21994,7 +21748,7 @@
       </p:sp>
       <p:sp>
         <p:nvSpPr>
-          <p:cNvPr id="50" name="Rounded Rectangle 49"/>
+          <p:cNvPr id="49" name="Rounded Rectangle 48"/>
           <p:cNvSpPr/>
           <p:nvPr/>
         </p:nvSpPr>
@@ -22042,7 +21796,7 @@
       </p:sp>
       <p:sp>
         <p:nvSpPr>
-          <p:cNvPr id="51" name="TextBox 50"/>
+          <p:cNvPr id="50" name="TextBox 49"/>
           <p:cNvSpPr txBox="1"/>
           <p:nvPr/>
         </p:nvSpPr>
@@ -22116,7 +21870,7 @@
       </p:sp>
       <p:sp>
         <p:nvSpPr>
-          <p:cNvPr id="52" name="TextBox 51"/>
+          <p:cNvPr id="51" name="TextBox 50"/>
           <p:cNvSpPr txBox="1"/>
           <p:nvPr/>
         </p:nvSpPr>
@@ -22157,7 +21911,7 @@
       </p:sp>
       <p:sp>
         <p:nvSpPr>
-          <p:cNvPr id="53" name="TextBox 52"/>
+          <p:cNvPr id="52" name="TextBox 51"/>
           <p:cNvSpPr txBox="1"/>
           <p:nvPr/>
         </p:nvSpPr>
@@ -22198,7 +21952,7 @@
       </p:sp>
       <p:sp>
         <p:nvSpPr>
-          <p:cNvPr id="54" name="Freeform 53"/>
+          <p:cNvPr id="53" name="Freeform 52"/>
           <p:cNvSpPr/>
           <p:nvPr/>
         </p:nvSpPr>
@@ -22256,7 +22010,7 @@
       </p:sp>
       <p:sp>
         <p:nvSpPr>
-          <p:cNvPr id="55" name="Oval 54"/>
+          <p:cNvPr id="54" name="Oval 53"/>
           <p:cNvSpPr/>
           <p:nvPr/>
         </p:nvSpPr>
@@ -22300,7 +22054,7 @@
       </p:sp>
       <p:sp>
         <p:nvSpPr>
-          <p:cNvPr id="56" name="Freeform 55"/>
+          <p:cNvPr id="55" name="Freeform 54"/>
           <p:cNvSpPr/>
           <p:nvPr/>
         </p:nvSpPr>
@@ -22358,7 +22112,7 @@
       </p:sp>
       <p:sp>
         <p:nvSpPr>
-          <p:cNvPr id="57" name="Freeform 56"/>
+          <p:cNvPr id="56" name="Freeform 55"/>
           <p:cNvSpPr/>
           <p:nvPr/>
         </p:nvSpPr>
@@ -22420,7 +22174,7 @@
       </p:sp>
       <p:sp>
         <p:nvSpPr>
-          <p:cNvPr id="58" name="Rounded Rectangle 57"/>
+          <p:cNvPr id="57" name="Rounded Rectangle 56"/>
           <p:cNvSpPr/>
           <p:nvPr/>
         </p:nvSpPr>
@@ -22468,7 +22222,7 @@
       </p:sp>
       <p:sp>
         <p:nvSpPr>
-          <p:cNvPr id="59" name="Rounded Rectangle 58"/>
+          <p:cNvPr id="58" name="Rounded Rectangle 57"/>
           <p:cNvSpPr/>
           <p:nvPr/>
         </p:nvSpPr>
@@ -22514,7 +22268,7 @@
       </p:sp>
       <p:sp>
         <p:nvSpPr>
-          <p:cNvPr id="60" name="TextBox 59"/>
+          <p:cNvPr id="59" name="TextBox 58"/>
           <p:cNvSpPr txBox="1"/>
           <p:nvPr/>
         </p:nvSpPr>
@@ -22555,7 +22309,7 @@
       </p:sp>
       <p:sp>
         <p:nvSpPr>
-          <p:cNvPr id="61" name="Freeform 60"/>
+          <p:cNvPr id="60" name="Freeform 59"/>
           <p:cNvSpPr/>
           <p:nvPr/>
         </p:nvSpPr>
@@ -22613,7 +22367,7 @@
       </p:sp>
       <p:sp>
         <p:nvSpPr>
-          <p:cNvPr id="62" name="TextBox 61"/>
+          <p:cNvPr id="61" name="TextBox 60"/>
           <p:cNvSpPr txBox="1"/>
           <p:nvPr/>
         </p:nvSpPr>
@@ -22654,7 +22408,7 @@
       </p:sp>
       <p:sp>
         <p:nvSpPr>
-          <p:cNvPr id="63" name="Freeform 62"/>
+          <p:cNvPr id="62" name="Freeform 61"/>
           <p:cNvSpPr/>
           <p:nvPr/>
         </p:nvSpPr>
@@ -22712,7 +22466,7 @@
       </p:sp>
       <p:sp>
         <p:nvSpPr>
-          <p:cNvPr id="64" name="Freeform 63"/>
+          <p:cNvPr id="63" name="Freeform 62"/>
           <p:cNvSpPr/>
           <p:nvPr/>
         </p:nvSpPr>
@@ -22774,7 +22528,7 @@
       </p:sp>
       <p:sp>
         <p:nvSpPr>
-          <p:cNvPr id="65" name="Rounded Rectangle 64"/>
+          <p:cNvPr id="64" name="Rounded Rectangle 63"/>
           <p:cNvSpPr/>
           <p:nvPr/>
         </p:nvSpPr>
@@ -22822,7 +22576,7 @@
       </p:sp>
       <p:sp>
         <p:nvSpPr>
-          <p:cNvPr id="66" name="Rounded Rectangle 65"/>
+          <p:cNvPr id="65" name="Rounded Rectangle 64"/>
           <p:cNvSpPr/>
           <p:nvPr/>
         </p:nvSpPr>
@@ -22868,7 +22622,7 @@
       </p:sp>
       <p:sp>
         <p:nvSpPr>
-          <p:cNvPr id="67" name="TextBox 66"/>
+          <p:cNvPr id="66" name="TextBox 65"/>
           <p:cNvSpPr txBox="1"/>
           <p:nvPr/>
         </p:nvSpPr>
@@ -22909,7 +22663,7 @@
       </p:sp>
       <p:sp>
         <p:nvSpPr>
-          <p:cNvPr id="68" name="Freeform 67"/>
+          <p:cNvPr id="67" name="Freeform 66"/>
           <p:cNvSpPr/>
           <p:nvPr/>
         </p:nvSpPr>
@@ -22967,7 +22721,7 @@
       </p:sp>
       <p:sp>
         <p:nvSpPr>
-          <p:cNvPr id="69" name="TextBox 68"/>
+          <p:cNvPr id="68" name="TextBox 67"/>
           <p:cNvSpPr txBox="1"/>
           <p:nvPr/>
         </p:nvSpPr>
@@ -23074,7 +22828,7 @@
       </p:sp>
       <p:sp>
         <p:nvSpPr>
-          <p:cNvPr id="70" name="Freeform 69"/>
+          <p:cNvPr id="69" name="Freeform 68"/>
           <p:cNvSpPr/>
           <p:nvPr/>
         </p:nvSpPr>
@@ -23132,7 +22886,7 @@
       </p:sp>
       <p:sp>
         <p:nvSpPr>
-          <p:cNvPr id="71" name="Freeform 70"/>
+          <p:cNvPr id="70" name="Freeform 69"/>
           <p:cNvSpPr/>
           <p:nvPr/>
         </p:nvSpPr>
@@ -23194,7 +22948,7 @@
       </p:sp>
       <p:sp>
         <p:nvSpPr>
-          <p:cNvPr id="72" name="Rounded Rectangle 71"/>
+          <p:cNvPr id="71" name="Rounded Rectangle 70"/>
           <p:cNvSpPr/>
           <p:nvPr/>
         </p:nvSpPr>
@@ -23242,7 +22996,7 @@
       </p:sp>
       <p:sp>
         <p:nvSpPr>
-          <p:cNvPr id="73" name="Rounded Rectangle 72"/>
+          <p:cNvPr id="72" name="Rounded Rectangle 71"/>
           <p:cNvSpPr/>
           <p:nvPr/>
         </p:nvSpPr>
@@ -23288,7 +23042,7 @@
       </p:sp>
       <p:sp>
         <p:nvSpPr>
-          <p:cNvPr id="74" name="TextBox 73"/>
+          <p:cNvPr id="73" name="TextBox 72"/>
           <p:cNvSpPr txBox="1"/>
           <p:nvPr/>
         </p:nvSpPr>
@@ -23329,7 +23083,7 @@
       </p:sp>
       <p:sp>
         <p:nvSpPr>
-          <p:cNvPr id="75" name="Freeform 74"/>
+          <p:cNvPr id="74" name="Freeform 73"/>
           <p:cNvSpPr/>
           <p:nvPr/>
         </p:nvSpPr>
@@ -23387,7 +23141,7 @@
       </p:sp>
       <p:sp>
         <p:nvSpPr>
-          <p:cNvPr id="76" name="TextBox 75"/>
+          <p:cNvPr id="75" name="TextBox 74"/>
           <p:cNvSpPr txBox="1"/>
           <p:nvPr/>
         </p:nvSpPr>
@@ -23646,48 +23400,7 @@
       </p:sp>
       <p:sp>
         <p:nvSpPr>
-          <p:cNvPr id="6" name="TextBox 5"/>
-          <p:cNvSpPr txBox="1"/>
-          <p:nvPr/>
-        </p:nvSpPr>
-        <p:spPr>
-          <a:xfrm>
-            <a:off x="10312400" y="254000"/>
-            <a:ext cx="1270000" cy="558800"/>
-          </a:xfrm>
-          <a:prstGeom prst="rect">
-            <a:avLst/>
-          </a:prstGeom>
-          <a:noFill/>
-        </p:spPr>
-        <p:txBody>
-          <a:bodyPr wrap="square" lIns="0" rIns="0" tIns="0" bIns="0" anchor="t">
-            <a:noAutofit/>
-          </a:bodyPr>
-          <a:lstStyle/>
-          <a:p>
-            <a:pPr algn="r">
-              <a:lnSpc>
-                <a:spcPct val="100000"/>
-              </a:lnSpc>
-            </a:pPr>
-            <a:r>
-              <a:rPr sz="3000" b="1" i="0">
-                <a:solidFill>
-                  <a:srgbClr val="E3EAF2"/>
-                </a:solidFill>
-                <a:latin typeface="Arial"/>
-                <a:ea typeface="Microsoft YaHei"/>
-                <a:cs typeface="Arial"/>
-              </a:rPr>
-              <a:t>08</a:t>
-            </a:r>
-          </a:p>
-        </p:txBody>
-      </p:sp>
-      <p:sp>
-        <p:nvSpPr>
-          <p:cNvPr id="7" name="Freeform 6"/>
+          <p:cNvPr id="6" name="Freeform 5"/>
           <p:cNvSpPr/>
           <p:nvPr/>
         </p:nvSpPr>
@@ -23745,7 +23458,7 @@
       </p:sp>
       <p:sp>
         <p:nvSpPr>
-          <p:cNvPr id="8" name="Freeform 7"/>
+          <p:cNvPr id="7" name="Freeform 6"/>
           <p:cNvSpPr/>
           <p:nvPr/>
         </p:nvSpPr>
@@ -23803,7 +23516,7 @@
       </p:sp>
       <p:sp>
         <p:nvSpPr>
-          <p:cNvPr id="9" name="TextBox 8"/>
+          <p:cNvPr id="8" name="TextBox 7"/>
           <p:cNvSpPr txBox="1"/>
           <p:nvPr/>
         </p:nvSpPr>
@@ -23844,7 +23557,7 @@
       </p:sp>
       <p:sp>
         <p:nvSpPr>
-          <p:cNvPr id="10" name="TextBox 9"/>
+          <p:cNvPr id="9" name="TextBox 8"/>
           <p:cNvSpPr txBox="1"/>
           <p:nvPr/>
         </p:nvSpPr>
@@ -23885,7 +23598,7 @@
       </p:sp>
       <p:sp>
         <p:nvSpPr>
-          <p:cNvPr id="11" name="Rounded Rectangle 10"/>
+          <p:cNvPr id="10" name="Rounded Rectangle 9"/>
           <p:cNvSpPr/>
           <p:nvPr/>
         </p:nvSpPr>
@@ -23939,7 +23652,7 @@
       </p:sp>
       <p:sp>
         <p:nvSpPr>
-          <p:cNvPr id="12" name="TextBox 11"/>
+          <p:cNvPr id="11" name="TextBox 10"/>
           <p:cNvSpPr txBox="1"/>
           <p:nvPr/>
         </p:nvSpPr>
@@ -23980,7 +23693,7 @@
       </p:sp>
       <p:sp>
         <p:nvSpPr>
-          <p:cNvPr id="13" name="TextBox 12"/>
+          <p:cNvPr id="12" name="TextBox 11"/>
           <p:cNvSpPr txBox="1"/>
           <p:nvPr/>
         </p:nvSpPr>
@@ -24021,7 +23734,7 @@
       </p:sp>
       <p:sp>
         <p:nvSpPr>
-          <p:cNvPr id="14" name="Rounded Rectangle 13"/>
+          <p:cNvPr id="13" name="Rounded Rectangle 12"/>
           <p:cNvSpPr/>
           <p:nvPr/>
         </p:nvSpPr>
@@ -24067,7 +23780,7 @@
       </p:sp>
       <p:sp>
         <p:nvSpPr>
-          <p:cNvPr id="15" name="TextBox 14"/>
+          <p:cNvPr id="14" name="TextBox 13"/>
           <p:cNvSpPr txBox="1"/>
           <p:nvPr/>
         </p:nvSpPr>
@@ -24108,7 +23821,7 @@
       </p:sp>
       <p:sp>
         <p:nvSpPr>
-          <p:cNvPr id="16" name="Freeform 15"/>
+          <p:cNvPr id="15" name="Freeform 14"/>
           <p:cNvSpPr/>
           <p:nvPr/>
         </p:nvSpPr>
@@ -24166,7 +23879,7 @@
       </p:sp>
       <p:sp>
         <p:nvSpPr>
-          <p:cNvPr id="17" name="Oval 16"/>
+          <p:cNvPr id="16" name="Oval 15"/>
           <p:cNvSpPr/>
           <p:nvPr/>
         </p:nvSpPr>
@@ -24212,7 +23925,7 @@
       </p:sp>
       <p:sp>
         <p:nvSpPr>
-          <p:cNvPr id="18" name="TextBox 17"/>
+          <p:cNvPr id="17" name="TextBox 16"/>
           <p:cNvSpPr txBox="1"/>
           <p:nvPr/>
         </p:nvSpPr>
@@ -24253,7 +23966,7 @@
       </p:sp>
       <p:sp>
         <p:nvSpPr>
-          <p:cNvPr id="19" name="Oval 18"/>
+          <p:cNvPr id="18" name="Oval 17"/>
           <p:cNvSpPr/>
           <p:nvPr/>
         </p:nvSpPr>
@@ -24299,7 +24012,7 @@
       </p:sp>
       <p:sp>
         <p:nvSpPr>
-          <p:cNvPr id="20" name="TextBox 19"/>
+          <p:cNvPr id="19" name="TextBox 18"/>
           <p:cNvSpPr txBox="1"/>
           <p:nvPr/>
         </p:nvSpPr>
@@ -24340,7 +24053,7 @@
       </p:sp>
       <p:sp>
         <p:nvSpPr>
-          <p:cNvPr id="21" name="Oval 20"/>
+          <p:cNvPr id="20" name="Oval 19"/>
           <p:cNvSpPr/>
           <p:nvPr/>
         </p:nvSpPr>
@@ -24386,7 +24099,7 @@
       </p:sp>
       <p:sp>
         <p:nvSpPr>
-          <p:cNvPr id="22" name="TextBox 21"/>
+          <p:cNvPr id="21" name="TextBox 20"/>
           <p:cNvSpPr txBox="1"/>
           <p:nvPr/>
         </p:nvSpPr>
@@ -24427,7 +24140,7 @@
       </p:sp>
       <p:sp>
         <p:nvSpPr>
-          <p:cNvPr id="23" name="Oval 22"/>
+          <p:cNvPr id="22" name="Oval 21"/>
           <p:cNvSpPr/>
           <p:nvPr/>
         </p:nvSpPr>
@@ -24473,7 +24186,7 @@
       </p:sp>
       <p:sp>
         <p:nvSpPr>
-          <p:cNvPr id="24" name="TextBox 23"/>
+          <p:cNvPr id="23" name="TextBox 22"/>
           <p:cNvSpPr txBox="1"/>
           <p:nvPr/>
         </p:nvSpPr>
@@ -24514,7 +24227,7 @@
       </p:sp>
       <p:sp>
         <p:nvSpPr>
-          <p:cNvPr id="25" name="Oval 24"/>
+          <p:cNvPr id="24" name="Oval 23"/>
           <p:cNvSpPr/>
           <p:nvPr/>
         </p:nvSpPr>
@@ -24560,7 +24273,7 @@
       </p:sp>
       <p:sp>
         <p:nvSpPr>
-          <p:cNvPr id="26" name="TextBox 25"/>
+          <p:cNvPr id="25" name="TextBox 24"/>
           <p:cNvSpPr txBox="1"/>
           <p:nvPr/>
         </p:nvSpPr>
@@ -24601,7 +24314,7 @@
       </p:sp>
       <p:sp>
         <p:nvSpPr>
-          <p:cNvPr id="27" name="Oval 26"/>
+          <p:cNvPr id="26" name="Oval 25"/>
           <p:cNvSpPr/>
           <p:nvPr/>
         </p:nvSpPr>
@@ -24647,7 +24360,7 @@
       </p:sp>
       <p:sp>
         <p:nvSpPr>
-          <p:cNvPr id="28" name="TextBox 27"/>
+          <p:cNvPr id="27" name="TextBox 26"/>
           <p:cNvSpPr txBox="1"/>
           <p:nvPr/>
         </p:nvSpPr>
@@ -24688,7 +24401,7 @@
       </p:sp>
       <p:sp>
         <p:nvSpPr>
-          <p:cNvPr id="29" name="Oval 28"/>
+          <p:cNvPr id="28" name="Oval 27"/>
           <p:cNvSpPr/>
           <p:nvPr/>
         </p:nvSpPr>
@@ -24734,7 +24447,7 @@
       </p:sp>
       <p:sp>
         <p:nvSpPr>
-          <p:cNvPr id="30" name="TextBox 29"/>
+          <p:cNvPr id="29" name="TextBox 28"/>
           <p:cNvSpPr txBox="1"/>
           <p:nvPr/>
         </p:nvSpPr>
@@ -24775,7 +24488,7 @@
       </p:sp>
       <p:sp>
         <p:nvSpPr>
-          <p:cNvPr id="31" name="TextBox 30"/>
+          <p:cNvPr id="30" name="TextBox 29"/>
           <p:cNvSpPr txBox="1"/>
           <p:nvPr/>
         </p:nvSpPr>
@@ -24816,7 +24529,7 @@
       </p:sp>
       <p:sp>
         <p:nvSpPr>
-          <p:cNvPr id="32" name="Freeform 31"/>
+          <p:cNvPr id="31" name="Freeform 30"/>
           <p:cNvSpPr/>
           <p:nvPr/>
         </p:nvSpPr>
@@ -24874,7 +24587,7 @@
       </p:sp>
       <p:sp>
         <p:nvSpPr>
-          <p:cNvPr id="33" name="Freeform 32"/>
+          <p:cNvPr id="32" name="Freeform 31"/>
           <p:cNvSpPr/>
           <p:nvPr/>
         </p:nvSpPr>
@@ -24936,7 +24649,7 @@
       </p:sp>
       <p:sp>
         <p:nvSpPr>
-          <p:cNvPr id="34" name="Rounded Rectangle 33"/>
+          <p:cNvPr id="33" name="Rounded Rectangle 32"/>
           <p:cNvSpPr/>
           <p:nvPr/>
         </p:nvSpPr>
@@ -24990,7 +24703,7 @@
       </p:sp>
       <p:sp>
         <p:nvSpPr>
-          <p:cNvPr id="35" name="Rounded Rectangle 34"/>
+          <p:cNvPr id="34" name="Rounded Rectangle 33"/>
           <p:cNvSpPr/>
           <p:nvPr/>
         </p:nvSpPr>
@@ -25036,7 +24749,7 @@
       </p:sp>
       <p:sp>
         <p:nvSpPr>
-          <p:cNvPr id="36" name="Rounded Rectangle 35"/>
+          <p:cNvPr id="35" name="Rounded Rectangle 34"/>
           <p:cNvSpPr/>
           <p:nvPr/>
         </p:nvSpPr>
@@ -25082,7 +24795,7 @@
       </p:sp>
       <p:sp>
         <p:nvSpPr>
-          <p:cNvPr id="37" name="TextBox 36"/>
+          <p:cNvPr id="36" name="TextBox 35"/>
           <p:cNvSpPr txBox="1"/>
           <p:nvPr/>
         </p:nvSpPr>
@@ -25123,7 +24836,7 @@
       </p:sp>
       <p:sp>
         <p:nvSpPr>
-          <p:cNvPr id="38" name="TextBox 37"/>
+          <p:cNvPr id="37" name="TextBox 36"/>
           <p:cNvSpPr txBox="1"/>
           <p:nvPr/>
         </p:nvSpPr>
@@ -25197,7 +24910,7 @@
       </p:sp>
       <p:sp>
         <p:nvSpPr>
-          <p:cNvPr id="39" name="TextBox 38"/>
+          <p:cNvPr id="38" name="TextBox 37"/>
           <p:cNvSpPr txBox="1"/>
           <p:nvPr/>
         </p:nvSpPr>
@@ -25238,7 +24951,7 @@
       </p:sp>
       <p:sp>
         <p:nvSpPr>
-          <p:cNvPr id="40" name="Freeform 39"/>
+          <p:cNvPr id="39" name="Freeform 38"/>
           <p:cNvSpPr/>
           <p:nvPr/>
         </p:nvSpPr>
@@ -25296,7 +25009,7 @@
       </p:sp>
       <p:sp>
         <p:nvSpPr>
-          <p:cNvPr id="41" name="TextBox 40"/>
+          <p:cNvPr id="40" name="TextBox 39"/>
           <p:cNvSpPr txBox="1"/>
           <p:nvPr/>
         </p:nvSpPr>
@@ -25337,7 +25050,7 @@
       </p:sp>
       <p:sp>
         <p:nvSpPr>
-          <p:cNvPr id="42" name="Rounded Rectangle 41"/>
+          <p:cNvPr id="41" name="Rounded Rectangle 40"/>
           <p:cNvSpPr/>
           <p:nvPr/>
         </p:nvSpPr>
@@ -25383,7 +25096,7 @@
       </p:sp>
       <p:sp>
         <p:nvSpPr>
-          <p:cNvPr id="43" name="TextBox 42"/>
+          <p:cNvPr id="42" name="TextBox 41"/>
           <p:cNvSpPr txBox="1"/>
           <p:nvPr/>
         </p:nvSpPr>
@@ -25424,7 +25137,7 @@
       </p:sp>
       <p:sp>
         <p:nvSpPr>
-          <p:cNvPr id="44" name="Rounded Rectangle 43"/>
+          <p:cNvPr id="43" name="Rounded Rectangle 42"/>
           <p:cNvSpPr/>
           <p:nvPr/>
         </p:nvSpPr>
@@ -25478,7 +25191,7 @@
       </p:sp>
       <p:sp>
         <p:nvSpPr>
-          <p:cNvPr id="45" name="Rounded Rectangle 44"/>
+          <p:cNvPr id="44" name="Rounded Rectangle 43"/>
           <p:cNvSpPr/>
           <p:nvPr/>
         </p:nvSpPr>
@@ -25524,7 +25237,7 @@
       </p:sp>
       <p:sp>
         <p:nvSpPr>
-          <p:cNvPr id="46" name="Rounded Rectangle 45"/>
+          <p:cNvPr id="45" name="Rounded Rectangle 44"/>
           <p:cNvSpPr/>
           <p:nvPr/>
         </p:nvSpPr>
@@ -25570,7 +25283,7 @@
       </p:sp>
       <p:sp>
         <p:nvSpPr>
-          <p:cNvPr id="47" name="TextBox 46"/>
+          <p:cNvPr id="46" name="TextBox 45"/>
           <p:cNvSpPr txBox="1"/>
           <p:nvPr/>
         </p:nvSpPr>
@@ -25611,7 +25324,7 @@
       </p:sp>
       <p:sp>
         <p:nvSpPr>
-          <p:cNvPr id="48" name="TextBox 47"/>
+          <p:cNvPr id="47" name="TextBox 46"/>
           <p:cNvSpPr txBox="1"/>
           <p:nvPr/>
         </p:nvSpPr>
@@ -25685,7 +25398,7 @@
       </p:sp>
       <p:sp>
         <p:nvSpPr>
-          <p:cNvPr id="49" name="TextBox 48"/>
+          <p:cNvPr id="48" name="TextBox 47"/>
           <p:cNvSpPr txBox="1"/>
           <p:nvPr/>
         </p:nvSpPr>
@@ -25726,7 +25439,7 @@
       </p:sp>
       <p:sp>
         <p:nvSpPr>
-          <p:cNvPr id="50" name="Freeform 49"/>
+          <p:cNvPr id="49" name="Freeform 48"/>
           <p:cNvSpPr/>
           <p:nvPr/>
         </p:nvSpPr>
@@ -25784,7 +25497,7 @@
       </p:sp>
       <p:sp>
         <p:nvSpPr>
-          <p:cNvPr id="51" name="TextBox 50"/>
+          <p:cNvPr id="50" name="TextBox 49"/>
           <p:cNvSpPr txBox="1"/>
           <p:nvPr/>
         </p:nvSpPr>
@@ -25825,7 +25538,7 @@
       </p:sp>
       <p:sp>
         <p:nvSpPr>
-          <p:cNvPr id="52" name="Rounded Rectangle 51"/>
+          <p:cNvPr id="51" name="Rounded Rectangle 50"/>
           <p:cNvSpPr/>
           <p:nvPr/>
         </p:nvSpPr>
@@ -25871,7 +25584,7 @@
       </p:sp>
       <p:sp>
         <p:nvSpPr>
-          <p:cNvPr id="53" name="TextBox 52"/>
+          <p:cNvPr id="52" name="TextBox 51"/>
           <p:cNvSpPr txBox="1"/>
           <p:nvPr/>
         </p:nvSpPr>
@@ -25912,7 +25625,7 @@
       </p:sp>
       <p:sp>
         <p:nvSpPr>
-          <p:cNvPr id="54" name="Rounded Rectangle 53"/>
+          <p:cNvPr id="53" name="Rounded Rectangle 52"/>
           <p:cNvSpPr/>
           <p:nvPr/>
         </p:nvSpPr>
@@ -25966,7 +25679,7 @@
       </p:sp>
       <p:sp>
         <p:nvSpPr>
-          <p:cNvPr id="55" name="Rounded Rectangle 54"/>
+          <p:cNvPr id="54" name="Rounded Rectangle 53"/>
           <p:cNvSpPr/>
           <p:nvPr/>
         </p:nvSpPr>
@@ -26012,7 +25725,7 @@
       </p:sp>
       <p:sp>
         <p:nvSpPr>
-          <p:cNvPr id="56" name="Rounded Rectangle 55"/>
+          <p:cNvPr id="55" name="Rounded Rectangle 54"/>
           <p:cNvSpPr/>
           <p:nvPr/>
         </p:nvSpPr>
@@ -26058,7 +25771,7 @@
       </p:sp>
       <p:sp>
         <p:nvSpPr>
-          <p:cNvPr id="57" name="TextBox 56"/>
+          <p:cNvPr id="56" name="TextBox 55"/>
           <p:cNvSpPr txBox="1"/>
           <p:nvPr/>
         </p:nvSpPr>
@@ -26099,7 +25812,7 @@
       </p:sp>
       <p:sp>
         <p:nvSpPr>
-          <p:cNvPr id="58" name="TextBox 57"/>
+          <p:cNvPr id="57" name="TextBox 56"/>
           <p:cNvSpPr txBox="1"/>
           <p:nvPr/>
         </p:nvSpPr>
@@ -26173,7 +25886,7 @@
       </p:sp>
       <p:sp>
         <p:nvSpPr>
-          <p:cNvPr id="59" name="TextBox 58"/>
+          <p:cNvPr id="58" name="TextBox 57"/>
           <p:cNvSpPr txBox="1"/>
           <p:nvPr/>
         </p:nvSpPr>
@@ -26214,7 +25927,7 @@
       </p:sp>
       <p:sp>
         <p:nvSpPr>
-          <p:cNvPr id="60" name="Freeform 59"/>
+          <p:cNvPr id="59" name="Freeform 58"/>
           <p:cNvSpPr/>
           <p:nvPr/>
         </p:nvSpPr>
@@ -26272,7 +25985,7 @@
       </p:sp>
       <p:sp>
         <p:nvSpPr>
-          <p:cNvPr id="61" name="TextBox 60"/>
+          <p:cNvPr id="60" name="TextBox 59"/>
           <p:cNvSpPr txBox="1"/>
           <p:nvPr/>
         </p:nvSpPr>
@@ -26313,7 +26026,7 @@
       </p:sp>
       <p:sp>
         <p:nvSpPr>
-          <p:cNvPr id="62" name="Rounded Rectangle 61"/>
+          <p:cNvPr id="61" name="Rounded Rectangle 60"/>
           <p:cNvSpPr/>
           <p:nvPr/>
         </p:nvSpPr>
@@ -26359,7 +26072,7 @@
       </p:sp>
       <p:sp>
         <p:nvSpPr>
-          <p:cNvPr id="63" name="TextBox 62"/>
+          <p:cNvPr id="62" name="TextBox 61"/>
           <p:cNvSpPr txBox="1"/>
           <p:nvPr/>
         </p:nvSpPr>
@@ -26400,7 +26113,7 @@
       </p:sp>
       <p:sp>
         <p:nvSpPr>
-          <p:cNvPr id="64" name="Rounded Rectangle 63"/>
+          <p:cNvPr id="63" name="Rounded Rectangle 62"/>
           <p:cNvSpPr/>
           <p:nvPr/>
         </p:nvSpPr>
@@ -26454,7 +26167,7 @@
       </p:sp>
       <p:sp>
         <p:nvSpPr>
-          <p:cNvPr id="65" name="Rounded Rectangle 64"/>
+          <p:cNvPr id="64" name="Rounded Rectangle 63"/>
           <p:cNvSpPr/>
           <p:nvPr/>
         </p:nvSpPr>
@@ -26500,7 +26213,7 @@
       </p:sp>
       <p:sp>
         <p:nvSpPr>
-          <p:cNvPr id="66" name="Rounded Rectangle 65"/>
+          <p:cNvPr id="65" name="Rounded Rectangle 64"/>
           <p:cNvSpPr/>
           <p:nvPr/>
         </p:nvSpPr>
@@ -26546,7 +26259,7 @@
       </p:sp>
       <p:sp>
         <p:nvSpPr>
-          <p:cNvPr id="67" name="TextBox 66"/>
+          <p:cNvPr id="66" name="TextBox 65"/>
           <p:cNvSpPr txBox="1"/>
           <p:nvPr/>
         </p:nvSpPr>
@@ -26587,7 +26300,7 @@
       </p:sp>
       <p:sp>
         <p:nvSpPr>
-          <p:cNvPr id="68" name="TextBox 67"/>
+          <p:cNvPr id="67" name="TextBox 66"/>
           <p:cNvSpPr txBox="1"/>
           <p:nvPr/>
         </p:nvSpPr>
@@ -26628,7 +26341,7 @@
       </p:sp>
       <p:sp>
         <p:nvSpPr>
-          <p:cNvPr id="69" name="TextBox 68"/>
+          <p:cNvPr id="68" name="TextBox 67"/>
           <p:cNvSpPr txBox="1"/>
           <p:nvPr/>
         </p:nvSpPr>
@@ -26669,7 +26382,7 @@
       </p:sp>
       <p:sp>
         <p:nvSpPr>
-          <p:cNvPr id="70" name="Freeform 69"/>
+          <p:cNvPr id="69" name="Freeform 68"/>
           <p:cNvSpPr/>
           <p:nvPr/>
         </p:nvSpPr>
@@ -26727,7 +26440,7 @@
       </p:sp>
       <p:sp>
         <p:nvSpPr>
-          <p:cNvPr id="71" name="TextBox 70"/>
+          <p:cNvPr id="70" name="TextBox 69"/>
           <p:cNvSpPr txBox="1"/>
           <p:nvPr/>
         </p:nvSpPr>
@@ -26768,7 +26481,7 @@
       </p:sp>
       <p:sp>
         <p:nvSpPr>
-          <p:cNvPr id="72" name="Rounded Rectangle 71"/>
+          <p:cNvPr id="71" name="Rounded Rectangle 70"/>
           <p:cNvSpPr/>
           <p:nvPr/>
         </p:nvSpPr>
@@ -26814,7 +26527,7 @@
       </p:sp>
       <p:sp>
         <p:nvSpPr>
-          <p:cNvPr id="73" name="TextBox 72"/>
+          <p:cNvPr id="72" name="TextBox 71"/>
           <p:cNvSpPr txBox="1"/>
           <p:nvPr/>
         </p:nvSpPr>
@@ -26855,7 +26568,7 @@
       </p:sp>
       <p:sp>
         <p:nvSpPr>
-          <p:cNvPr id="74" name="Rounded Rectangle 73"/>
+          <p:cNvPr id="73" name="Rounded Rectangle 72"/>
           <p:cNvSpPr/>
           <p:nvPr/>
         </p:nvSpPr>
@@ -26903,7 +26616,7 @@
       </p:sp>
       <p:sp>
         <p:nvSpPr>
-          <p:cNvPr id="75" name="Rounded Rectangle 74"/>
+          <p:cNvPr id="74" name="Rounded Rectangle 73"/>
           <p:cNvSpPr/>
           <p:nvPr/>
         </p:nvSpPr>
@@ -26949,7 +26662,7 @@
       </p:sp>
       <p:sp>
         <p:nvSpPr>
-          <p:cNvPr id="76" name="TextBox 75"/>
+          <p:cNvPr id="75" name="TextBox 74"/>
           <p:cNvSpPr txBox="1"/>
           <p:nvPr/>
         </p:nvSpPr>
@@ -27263,48 +26976,7 @@
       </p:sp>
       <p:sp>
         <p:nvSpPr>
-          <p:cNvPr id="6" name="TextBox 5"/>
-          <p:cNvSpPr txBox="1"/>
-          <p:nvPr/>
-        </p:nvSpPr>
-        <p:spPr>
-          <a:xfrm>
-            <a:off x="10312400" y="254000"/>
-            <a:ext cx="1270000" cy="558800"/>
-          </a:xfrm>
-          <a:prstGeom prst="rect">
-            <a:avLst/>
-          </a:prstGeom>
-          <a:noFill/>
-        </p:spPr>
-        <p:txBody>
-          <a:bodyPr wrap="square" lIns="0" rIns="0" tIns="0" bIns="0" anchor="t">
-            <a:noAutofit/>
-          </a:bodyPr>
-          <a:lstStyle/>
-          <a:p>
-            <a:pPr algn="r">
-              <a:lnSpc>
-                <a:spcPct val="100000"/>
-              </a:lnSpc>
-            </a:pPr>
-            <a:r>
-              <a:rPr sz="3000" b="1" i="0">
-                <a:solidFill>
-                  <a:srgbClr val="E3EAF2"/>
-                </a:solidFill>
-                <a:latin typeface="Arial"/>
-                <a:ea typeface="Microsoft YaHei"/>
-                <a:cs typeface="Arial"/>
-              </a:rPr>
-              <a:t>09</a:t>
-            </a:r>
-          </a:p>
-        </p:txBody>
-      </p:sp>
-      <p:sp>
-        <p:nvSpPr>
-          <p:cNvPr id="7" name="Freeform 6"/>
+          <p:cNvPr id="6" name="Freeform 5"/>
           <p:cNvSpPr/>
           <p:nvPr/>
         </p:nvSpPr>
@@ -27362,7 +27034,7 @@
       </p:sp>
       <p:sp>
         <p:nvSpPr>
-          <p:cNvPr id="8" name="Freeform 7"/>
+          <p:cNvPr id="7" name="Freeform 6"/>
           <p:cNvSpPr/>
           <p:nvPr/>
         </p:nvSpPr>
@@ -27420,7 +27092,7 @@
       </p:sp>
       <p:sp>
         <p:nvSpPr>
-          <p:cNvPr id="9" name="TextBox 8"/>
+          <p:cNvPr id="8" name="TextBox 7"/>
           <p:cNvSpPr txBox="1"/>
           <p:nvPr/>
         </p:nvSpPr>
@@ -27461,7 +27133,7 @@
       </p:sp>
       <p:sp>
         <p:nvSpPr>
-          <p:cNvPr id="10" name="TextBox 9"/>
+          <p:cNvPr id="9" name="TextBox 8"/>
           <p:cNvSpPr txBox="1"/>
           <p:nvPr/>
         </p:nvSpPr>
@@ -27502,7 +27174,7 @@
       </p:sp>
       <p:sp>
         <p:nvSpPr>
-          <p:cNvPr id="11" name="Rounded Rectangle 10"/>
+          <p:cNvPr id="10" name="Rounded Rectangle 9"/>
           <p:cNvSpPr/>
           <p:nvPr/>
         </p:nvSpPr>
@@ -27556,7 +27228,7 @@
       </p:sp>
       <p:sp>
         <p:nvSpPr>
-          <p:cNvPr id="12" name="TextBox 11"/>
+          <p:cNvPr id="11" name="TextBox 10"/>
           <p:cNvSpPr txBox="1"/>
           <p:nvPr/>
         </p:nvSpPr>
@@ -27597,7 +27269,7 @@
       </p:sp>
       <p:sp>
         <p:nvSpPr>
-          <p:cNvPr id="13" name="Rectangle 12"/>
+          <p:cNvPr id="12" name="Rectangle 11"/>
           <p:cNvSpPr/>
           <p:nvPr/>
         </p:nvSpPr>
@@ -27641,7 +27313,7 @@
       </p:sp>
       <p:sp>
         <p:nvSpPr>
-          <p:cNvPr id="14" name="TextBox 13"/>
+          <p:cNvPr id="13" name="TextBox 12"/>
           <p:cNvSpPr txBox="1"/>
           <p:nvPr/>
         </p:nvSpPr>
@@ -27735,7 +27407,7 @@
       </p:sp>
       <p:sp>
         <p:nvSpPr>
-          <p:cNvPr id="15" name="Rounded Rectangle 14"/>
+          <p:cNvPr id="14" name="Rounded Rectangle 13"/>
           <p:cNvSpPr/>
           <p:nvPr/>
         </p:nvSpPr>
@@ -27781,7 +27453,7 @@
       </p:sp>
       <p:sp>
         <p:nvSpPr>
-          <p:cNvPr id="16" name="Freeform 15"/>
+          <p:cNvPr id="15" name="Freeform 14"/>
           <p:cNvSpPr/>
           <p:nvPr/>
         </p:nvSpPr>
@@ -27839,7 +27511,7 @@
       </p:sp>
       <p:sp>
         <p:nvSpPr>
-          <p:cNvPr id="17" name="TextBox 16"/>
+          <p:cNvPr id="16" name="TextBox 15"/>
           <p:cNvSpPr txBox="1"/>
           <p:nvPr/>
         </p:nvSpPr>
@@ -27880,7 +27552,7 @@
       </p:sp>
       <p:sp>
         <p:nvSpPr>
-          <p:cNvPr id="18" name="Freeform 17"/>
+          <p:cNvPr id="17" name="Freeform 16"/>
           <p:cNvSpPr/>
           <p:nvPr/>
         </p:nvSpPr>
@@ -27938,7 +27610,7 @@
       </p:sp>
       <p:sp>
         <p:nvSpPr>
-          <p:cNvPr id="19" name="TextBox 18"/>
+          <p:cNvPr id="18" name="TextBox 17"/>
           <p:cNvSpPr txBox="1"/>
           <p:nvPr/>
         </p:nvSpPr>
@@ -27979,7 +27651,7 @@
       </p:sp>
       <p:sp>
         <p:nvSpPr>
-          <p:cNvPr id="20" name="Freeform 19"/>
+          <p:cNvPr id="19" name="Freeform 18"/>
           <p:cNvSpPr/>
           <p:nvPr/>
         </p:nvSpPr>
@@ -28037,7 +27709,7 @@
       </p:sp>
       <p:sp>
         <p:nvSpPr>
-          <p:cNvPr id="21" name="TextBox 20"/>
+          <p:cNvPr id="20" name="TextBox 19"/>
           <p:cNvSpPr txBox="1"/>
           <p:nvPr/>
         </p:nvSpPr>
@@ -28078,7 +27750,7 @@
       </p:sp>
       <p:sp>
         <p:nvSpPr>
-          <p:cNvPr id="22" name="Freeform 21"/>
+          <p:cNvPr id="21" name="Freeform 20"/>
           <p:cNvSpPr/>
           <p:nvPr/>
         </p:nvSpPr>
@@ -28136,7 +27808,7 @@
       </p:sp>
       <p:sp>
         <p:nvSpPr>
-          <p:cNvPr id="23" name="TextBox 22"/>
+          <p:cNvPr id="22" name="TextBox 21"/>
           <p:cNvSpPr txBox="1"/>
           <p:nvPr/>
         </p:nvSpPr>
@@ -28177,7 +27849,7 @@
       </p:sp>
       <p:sp>
         <p:nvSpPr>
-          <p:cNvPr id="24" name="Freeform 23"/>
+          <p:cNvPr id="23" name="Freeform 22"/>
           <p:cNvSpPr/>
           <p:nvPr/>
         </p:nvSpPr>
@@ -28235,7 +27907,7 @@
       </p:sp>
       <p:sp>
         <p:nvSpPr>
-          <p:cNvPr id="25" name="Freeform 24"/>
+          <p:cNvPr id="24" name="Freeform 23"/>
           <p:cNvSpPr/>
           <p:nvPr/>
         </p:nvSpPr>
@@ -28293,7 +27965,7 @@
       </p:sp>
       <p:sp>
         <p:nvSpPr>
-          <p:cNvPr id="26" name="Freeform 25"/>
+          <p:cNvPr id="25" name="Freeform 24"/>
           <p:cNvSpPr/>
           <p:nvPr/>
         </p:nvSpPr>
@@ -28351,7 +28023,7 @@
       </p:sp>
       <p:sp>
         <p:nvSpPr>
-          <p:cNvPr id="27" name="Freeform 26"/>
+          <p:cNvPr id="26" name="Freeform 25"/>
           <p:cNvSpPr/>
           <p:nvPr/>
         </p:nvSpPr>
@@ -28413,7 +28085,7 @@
       </p:sp>
       <p:sp>
         <p:nvSpPr>
-          <p:cNvPr id="28" name="Freeform 27"/>
+          <p:cNvPr id="27" name="Freeform 26"/>
           <p:cNvSpPr/>
           <p:nvPr/>
         </p:nvSpPr>
@@ -28471,7 +28143,7 @@
       </p:sp>
       <p:sp>
         <p:nvSpPr>
-          <p:cNvPr id="29" name="Freeform 28"/>
+          <p:cNvPr id="28" name="Freeform 27"/>
           <p:cNvSpPr/>
           <p:nvPr/>
         </p:nvSpPr>
@@ -28533,7 +28205,7 @@
       </p:sp>
       <p:sp>
         <p:nvSpPr>
-          <p:cNvPr id="30" name="TextBox 29"/>
+          <p:cNvPr id="29" name="TextBox 28"/>
           <p:cNvSpPr txBox="1"/>
           <p:nvPr/>
         </p:nvSpPr>
@@ -28574,7 +28246,7 @@
       </p:sp>
       <p:sp>
         <p:nvSpPr>
-          <p:cNvPr id="31" name="TextBox 30"/>
+          <p:cNvPr id="30" name="TextBox 29"/>
           <p:cNvSpPr txBox="1"/>
           <p:nvPr/>
         </p:nvSpPr>
@@ -28615,7 +28287,7 @@
       </p:sp>
       <p:sp>
         <p:nvSpPr>
-          <p:cNvPr id="32" name="Freeform 31"/>
+          <p:cNvPr id="31" name="Freeform 30"/>
           <p:cNvSpPr/>
           <p:nvPr/>
         </p:nvSpPr>
@@ -28673,7 +28345,7 @@
       </p:sp>
       <p:sp>
         <p:nvSpPr>
-          <p:cNvPr id="33" name="TextBox 32"/>
+          <p:cNvPr id="32" name="TextBox 31"/>
           <p:cNvSpPr txBox="1"/>
           <p:nvPr/>
         </p:nvSpPr>
@@ -28714,7 +28386,7 @@
       </p:sp>
       <p:sp>
         <p:nvSpPr>
-          <p:cNvPr id="34" name="Freeform 33"/>
+          <p:cNvPr id="33" name="Freeform 32"/>
           <p:cNvSpPr/>
           <p:nvPr/>
         </p:nvSpPr>
@@ -28772,7 +28444,7 @@
       </p:sp>
       <p:sp>
         <p:nvSpPr>
-          <p:cNvPr id="35" name="TextBox 34"/>
+          <p:cNvPr id="34" name="TextBox 33"/>
           <p:cNvSpPr txBox="1"/>
           <p:nvPr/>
         </p:nvSpPr>
@@ -28813,7 +28485,7 @@
       </p:sp>
       <p:sp>
         <p:nvSpPr>
-          <p:cNvPr id="36" name="Freeform 35"/>
+          <p:cNvPr id="35" name="Freeform 34"/>
           <p:cNvSpPr/>
           <p:nvPr/>
         </p:nvSpPr>
@@ -28871,7 +28543,7 @@
       </p:sp>
       <p:sp>
         <p:nvSpPr>
-          <p:cNvPr id="37" name="TextBox 36"/>
+          <p:cNvPr id="36" name="TextBox 35"/>
           <p:cNvSpPr txBox="1"/>
           <p:nvPr/>
         </p:nvSpPr>
@@ -28912,7 +28584,7 @@
       </p:sp>
       <p:sp>
         <p:nvSpPr>
-          <p:cNvPr id="38" name="Freeform 37"/>
+          <p:cNvPr id="37" name="Freeform 36"/>
           <p:cNvSpPr/>
           <p:nvPr/>
         </p:nvSpPr>
@@ -28970,7 +28642,7 @@
       </p:sp>
       <p:sp>
         <p:nvSpPr>
-          <p:cNvPr id="39" name="TextBox 38"/>
+          <p:cNvPr id="38" name="TextBox 37"/>
           <p:cNvSpPr txBox="1"/>
           <p:nvPr/>
         </p:nvSpPr>
@@ -29011,7 +28683,7 @@
       </p:sp>
       <p:sp>
         <p:nvSpPr>
-          <p:cNvPr id="40" name="Freeform 39"/>
+          <p:cNvPr id="39" name="Freeform 38"/>
           <p:cNvSpPr/>
           <p:nvPr/>
         </p:nvSpPr>
@@ -29258,7 +28930,7 @@
       </p:sp>
       <p:sp>
         <p:nvSpPr>
-          <p:cNvPr id="41" name="Freeform 40"/>
+          <p:cNvPr id="40" name="Freeform 39"/>
           <p:cNvSpPr/>
           <p:nvPr/>
         </p:nvSpPr>
@@ -29457,7 +29129,7 @@
       </p:sp>
       <p:sp>
         <p:nvSpPr>
-          <p:cNvPr id="42" name="Freeform 41"/>
+          <p:cNvPr id="41" name="Freeform 40"/>
           <p:cNvSpPr/>
           <p:nvPr/>
         </p:nvSpPr>
@@ -29656,7 +29328,7 @@
       </p:sp>
       <p:sp>
         <p:nvSpPr>
-          <p:cNvPr id="43" name="Freeform 42"/>
+          <p:cNvPr id="42" name="Freeform 41"/>
           <p:cNvSpPr/>
           <p:nvPr/>
         </p:nvSpPr>
@@ -29903,7 +29575,7 @@
       </p:sp>
       <p:sp>
         <p:nvSpPr>
-          <p:cNvPr id="44" name="TextBox 43"/>
+          <p:cNvPr id="43" name="TextBox 42"/>
           <p:cNvSpPr txBox="1"/>
           <p:nvPr/>
         </p:nvSpPr>
@@ -29944,7 +29616,7 @@
       </p:sp>
       <p:sp>
         <p:nvSpPr>
-          <p:cNvPr id="45" name="Rounded Rectangle 44"/>
+          <p:cNvPr id="44" name="Rounded Rectangle 43"/>
           <p:cNvSpPr/>
           <p:nvPr/>
         </p:nvSpPr>
@@ -29998,7 +29670,7 @@
       </p:sp>
       <p:sp>
         <p:nvSpPr>
-          <p:cNvPr id="46" name="TextBox 45"/>
+          <p:cNvPr id="45" name="TextBox 44"/>
           <p:cNvSpPr txBox="1"/>
           <p:nvPr/>
         </p:nvSpPr>
@@ -30039,7 +29711,7 @@
       </p:sp>
       <p:sp>
         <p:nvSpPr>
-          <p:cNvPr id="47" name="Rectangle 46"/>
+          <p:cNvPr id="46" name="Rectangle 45"/>
           <p:cNvSpPr/>
           <p:nvPr/>
         </p:nvSpPr>
@@ -30083,7 +29755,7 @@
       </p:sp>
       <p:sp>
         <p:nvSpPr>
-          <p:cNvPr id="48" name="Rounded Rectangle 47"/>
+          <p:cNvPr id="47" name="Rounded Rectangle 46"/>
           <p:cNvSpPr/>
           <p:nvPr/>
         </p:nvSpPr>
@@ -30129,7 +29801,7 @@
       </p:sp>
       <p:sp>
         <p:nvSpPr>
-          <p:cNvPr id="49" name="Rounded Rectangle 48"/>
+          <p:cNvPr id="48" name="Rounded Rectangle 47"/>
           <p:cNvSpPr/>
           <p:nvPr/>
         </p:nvSpPr>
@@ -30175,7 +29847,7 @@
       </p:sp>
       <p:sp>
         <p:nvSpPr>
-          <p:cNvPr id="50" name="Oval 49"/>
+          <p:cNvPr id="49" name="Oval 48"/>
           <p:cNvSpPr/>
           <p:nvPr/>
         </p:nvSpPr>
@@ -30219,7 +29891,7 @@
       </p:sp>
       <p:sp>
         <p:nvSpPr>
-          <p:cNvPr id="51" name="TextBox 50"/>
+          <p:cNvPr id="50" name="TextBox 49"/>
           <p:cNvSpPr txBox="1"/>
           <p:nvPr/>
         </p:nvSpPr>
@@ -30260,7 +29932,7 @@
       </p:sp>
       <p:sp>
         <p:nvSpPr>
-          <p:cNvPr id="52" name="TextBox 51"/>
+          <p:cNvPr id="51" name="TextBox 50"/>
           <p:cNvSpPr txBox="1"/>
           <p:nvPr/>
         </p:nvSpPr>
@@ -30301,7 +29973,7 @@
       </p:sp>
       <p:sp>
         <p:nvSpPr>
-          <p:cNvPr id="53" name="TextBox 52"/>
+          <p:cNvPr id="52" name="TextBox 51"/>
           <p:cNvSpPr txBox="1"/>
           <p:nvPr/>
         </p:nvSpPr>
@@ -30342,7 +30014,7 @@
       </p:sp>
       <p:sp>
         <p:nvSpPr>
-          <p:cNvPr id="54" name="TextBox 53"/>
+          <p:cNvPr id="53" name="TextBox 52"/>
           <p:cNvSpPr txBox="1"/>
           <p:nvPr/>
         </p:nvSpPr>
@@ -30383,7 +30055,7 @@
       </p:sp>
       <p:sp>
         <p:nvSpPr>
-          <p:cNvPr id="55" name="Oval 54"/>
+          <p:cNvPr id="54" name="Oval 53"/>
           <p:cNvSpPr/>
           <p:nvPr/>
         </p:nvSpPr>
@@ -30427,7 +30099,7 @@
       </p:sp>
       <p:sp>
         <p:nvSpPr>
-          <p:cNvPr id="56" name="Oval 55"/>
+          <p:cNvPr id="55" name="Oval 54"/>
           <p:cNvSpPr/>
           <p:nvPr/>
         </p:nvSpPr>
@@ -30471,7 +30143,7 @@
       </p:sp>
       <p:sp>
         <p:nvSpPr>
-          <p:cNvPr id="57" name="Oval 56"/>
+          <p:cNvPr id="56" name="Oval 55"/>
           <p:cNvSpPr/>
           <p:nvPr/>
         </p:nvSpPr>
@@ -30515,7 +30187,7 @@
       </p:sp>
       <p:sp>
         <p:nvSpPr>
-          <p:cNvPr id="58" name="Freeform 57"/>
+          <p:cNvPr id="57" name="Freeform 56"/>
           <p:cNvSpPr/>
           <p:nvPr/>
         </p:nvSpPr>
@@ -30573,7 +30245,7 @@
       </p:sp>
       <p:sp>
         <p:nvSpPr>
-          <p:cNvPr id="59" name="Freeform 58"/>
+          <p:cNvPr id="58" name="Freeform 57"/>
           <p:cNvSpPr/>
           <p:nvPr/>
         </p:nvSpPr>
@@ -30635,7 +30307,7 @@
       </p:sp>
       <p:sp>
         <p:nvSpPr>
-          <p:cNvPr id="60" name="Rounded Rectangle 59"/>
+          <p:cNvPr id="59" name="Rounded Rectangle 58"/>
           <p:cNvSpPr/>
           <p:nvPr/>
         </p:nvSpPr>
@@ -30681,7 +30353,7 @@
       </p:sp>
       <p:sp>
         <p:nvSpPr>
-          <p:cNvPr id="61" name="Rounded Rectangle 60"/>
+          <p:cNvPr id="60" name="Rounded Rectangle 59"/>
           <p:cNvSpPr/>
           <p:nvPr/>
         </p:nvSpPr>
@@ -30727,7 +30399,7 @@
       </p:sp>
       <p:sp>
         <p:nvSpPr>
-          <p:cNvPr id="62" name="Oval 61"/>
+          <p:cNvPr id="61" name="Oval 60"/>
           <p:cNvSpPr/>
           <p:nvPr/>
         </p:nvSpPr>
@@ -30771,7 +30443,7 @@
       </p:sp>
       <p:sp>
         <p:nvSpPr>
-          <p:cNvPr id="63" name="TextBox 62"/>
+          <p:cNvPr id="62" name="TextBox 61"/>
           <p:cNvSpPr txBox="1"/>
           <p:nvPr/>
         </p:nvSpPr>
@@ -30812,7 +30484,7 @@
       </p:sp>
       <p:sp>
         <p:nvSpPr>
-          <p:cNvPr id="64" name="TextBox 63"/>
+          <p:cNvPr id="63" name="TextBox 62"/>
           <p:cNvSpPr txBox="1"/>
           <p:nvPr/>
         </p:nvSpPr>
@@ -30853,7 +30525,7 @@
       </p:sp>
       <p:sp>
         <p:nvSpPr>
-          <p:cNvPr id="65" name="TextBox 64"/>
+          <p:cNvPr id="64" name="TextBox 63"/>
           <p:cNvSpPr txBox="1"/>
           <p:nvPr/>
         </p:nvSpPr>
@@ -30894,7 +30566,7 @@
       </p:sp>
       <p:sp>
         <p:nvSpPr>
-          <p:cNvPr id="66" name="TextBox 65"/>
+          <p:cNvPr id="65" name="TextBox 64"/>
           <p:cNvSpPr txBox="1"/>
           <p:nvPr/>
         </p:nvSpPr>
@@ -30935,7 +30607,7 @@
       </p:sp>
       <p:sp>
         <p:nvSpPr>
-          <p:cNvPr id="67" name="Freeform 66"/>
+          <p:cNvPr id="66" name="Freeform 65"/>
           <p:cNvSpPr/>
           <p:nvPr/>
         </p:nvSpPr>
@@ -31062,7 +30734,7 @@
       </p:sp>
       <p:sp>
         <p:nvSpPr>
-          <p:cNvPr id="68" name="Freeform 67"/>
+          <p:cNvPr id="67" name="Freeform 66"/>
           <p:cNvSpPr/>
           <p:nvPr/>
         </p:nvSpPr>
@@ -31189,7 +30861,7 @@
       </p:sp>
       <p:sp>
         <p:nvSpPr>
-          <p:cNvPr id="69" name="Freeform 68"/>
+          <p:cNvPr id="68" name="Freeform 67"/>
           <p:cNvSpPr/>
           <p:nvPr/>
         </p:nvSpPr>
@@ -31247,7 +30919,7 @@
       </p:sp>
       <p:sp>
         <p:nvSpPr>
-          <p:cNvPr id="70" name="Freeform 69"/>
+          <p:cNvPr id="69" name="Freeform 68"/>
           <p:cNvSpPr/>
           <p:nvPr/>
         </p:nvSpPr>
@@ -31305,7 +30977,7 @@
       </p:sp>
       <p:sp>
         <p:nvSpPr>
-          <p:cNvPr id="71" name="Freeform 70"/>
+          <p:cNvPr id="70" name="Freeform 69"/>
           <p:cNvSpPr/>
           <p:nvPr/>
         </p:nvSpPr>
@@ -31363,7 +31035,7 @@
       </p:sp>
       <p:sp>
         <p:nvSpPr>
-          <p:cNvPr id="72" name="Freeform 71"/>
+          <p:cNvPr id="71" name="Freeform 70"/>
           <p:cNvSpPr/>
           <p:nvPr/>
         </p:nvSpPr>
@@ -31421,7 +31093,7 @@
       </p:sp>
       <p:sp>
         <p:nvSpPr>
-          <p:cNvPr id="73" name="Freeform 72"/>
+          <p:cNvPr id="72" name="Freeform 71"/>
           <p:cNvSpPr/>
           <p:nvPr/>
         </p:nvSpPr>
@@ -31483,7 +31155,7 @@
       </p:sp>
       <p:sp>
         <p:nvSpPr>
-          <p:cNvPr id="74" name="Rounded Rectangle 73"/>
+          <p:cNvPr id="73" name="Rounded Rectangle 72"/>
           <p:cNvSpPr/>
           <p:nvPr/>
         </p:nvSpPr>
@@ -31529,7 +31201,7 @@
       </p:sp>
       <p:sp>
         <p:nvSpPr>
-          <p:cNvPr id="75" name="Rounded Rectangle 74"/>
+          <p:cNvPr id="74" name="Rounded Rectangle 73"/>
           <p:cNvSpPr/>
           <p:nvPr/>
         </p:nvSpPr>
@@ -31575,7 +31247,7 @@
       </p:sp>
       <p:sp>
         <p:nvSpPr>
-          <p:cNvPr id="76" name="Oval 75"/>
+          <p:cNvPr id="75" name="Oval 74"/>
           <p:cNvSpPr/>
           <p:nvPr/>
         </p:nvSpPr>
@@ -31619,7 +31291,7 @@
       </p:sp>
       <p:sp>
         <p:nvSpPr>
-          <p:cNvPr id="77" name="TextBox 76"/>
+          <p:cNvPr id="76" name="TextBox 75"/>
           <p:cNvSpPr txBox="1"/>
           <p:nvPr/>
         </p:nvSpPr>
@@ -31660,7 +31332,7 @@
       </p:sp>
       <p:sp>
         <p:nvSpPr>
-          <p:cNvPr id="78" name="TextBox 77"/>
+          <p:cNvPr id="77" name="TextBox 76"/>
           <p:cNvSpPr txBox="1"/>
           <p:nvPr/>
         </p:nvSpPr>
@@ -31701,7 +31373,7 @@
       </p:sp>
       <p:sp>
         <p:nvSpPr>
-          <p:cNvPr id="79" name="TextBox 78"/>
+          <p:cNvPr id="78" name="TextBox 77"/>
           <p:cNvSpPr txBox="1"/>
           <p:nvPr/>
         </p:nvSpPr>
@@ -31742,7 +31414,7 @@
       </p:sp>
       <p:sp>
         <p:nvSpPr>
-          <p:cNvPr id="80" name="TextBox 79"/>
+          <p:cNvPr id="79" name="TextBox 78"/>
           <p:cNvSpPr txBox="1"/>
           <p:nvPr/>
         </p:nvSpPr>
@@ -31783,7 +31455,7 @@
       </p:sp>
       <p:sp>
         <p:nvSpPr>
-          <p:cNvPr id="81" name="Freeform 80"/>
+          <p:cNvPr id="80" name="Freeform 79"/>
           <p:cNvSpPr/>
           <p:nvPr/>
         </p:nvSpPr>
@@ -31853,7 +31525,7 @@
       </p:sp>
       <p:sp>
         <p:nvSpPr>
-          <p:cNvPr id="82" name="Freeform 81"/>
+          <p:cNvPr id="81" name="Freeform 80"/>
           <p:cNvSpPr/>
           <p:nvPr/>
         </p:nvSpPr>
@@ -31911,7 +31583,7 @@
       </p:sp>
       <p:sp>
         <p:nvSpPr>
-          <p:cNvPr id="83" name="Freeform 82"/>
+          <p:cNvPr id="82" name="Freeform 81"/>
           <p:cNvSpPr/>
           <p:nvPr/>
         </p:nvSpPr>
@@ -31969,7 +31641,7 @@
       </p:sp>
       <p:sp>
         <p:nvSpPr>
-          <p:cNvPr id="84" name="Oval 83"/>
+          <p:cNvPr id="83" name="Oval 82"/>
           <p:cNvSpPr/>
           <p:nvPr/>
         </p:nvSpPr>

</xml_diff>

<commit_message>
Fallback to ghost page number when lab logo absent; rebuild deck
Co-authored-by: arena-agent <297053741+arena-agent@users.noreply.github.com>
</commit_message>
<xml_diff>
--- a/hn-ad-seminar/output/组会汇报_高效好氧降氨菌的筛选机制解析及堆肥应用.pptx
+++ b/hn-ad-seminar/output/组会汇报_高效好氧降氨菌的筛选机制解析及堆肥应用.pptx
@@ -5445,7 +5445,48 @@
       </p:sp>
       <p:sp>
         <p:nvSpPr>
-          <p:cNvPr id="6" name="Freeform 5"/>
+          <p:cNvPr id="6" name="TextBox 5"/>
+          <p:cNvSpPr txBox="1"/>
+          <p:nvPr/>
+        </p:nvSpPr>
+        <p:spPr>
+          <a:xfrm>
+            <a:off x="10312400" y="254000"/>
+            <a:ext cx="1270000" cy="558800"/>
+          </a:xfrm>
+          <a:prstGeom prst="rect">
+            <a:avLst/>
+          </a:prstGeom>
+          <a:noFill/>
+        </p:spPr>
+        <p:txBody>
+          <a:bodyPr wrap="square" lIns="0" rIns="0" tIns="0" bIns="0" anchor="t">
+            <a:noAutofit/>
+          </a:bodyPr>
+          <a:lstStyle/>
+          <a:p>
+            <a:pPr algn="r">
+              <a:lnSpc>
+                <a:spcPct val="100000"/>
+              </a:lnSpc>
+            </a:pPr>
+            <a:r>
+              <a:rPr sz="3000" b="1" i="0">
+                <a:solidFill>
+                  <a:srgbClr val="E3EAF2"/>
+                </a:solidFill>
+                <a:latin typeface="Arial"/>
+                <a:ea typeface="Microsoft YaHei"/>
+                <a:cs typeface="Arial"/>
+              </a:rPr>
+              <a:t>02</a:t>
+            </a:r>
+          </a:p>
+        </p:txBody>
+      </p:sp>
+      <p:sp>
+        <p:nvSpPr>
+          <p:cNvPr id="7" name="Freeform 6"/>
           <p:cNvSpPr/>
           <p:nvPr/>
         </p:nvSpPr>
@@ -5503,7 +5544,7 @@
       </p:sp>
       <p:sp>
         <p:nvSpPr>
-          <p:cNvPr id="7" name="Freeform 6"/>
+          <p:cNvPr id="8" name="Freeform 7"/>
           <p:cNvSpPr/>
           <p:nvPr/>
         </p:nvSpPr>
@@ -5561,7 +5602,7 @@
       </p:sp>
       <p:sp>
         <p:nvSpPr>
-          <p:cNvPr id="8" name="TextBox 7"/>
+          <p:cNvPr id="9" name="TextBox 8"/>
           <p:cNvSpPr txBox="1"/>
           <p:nvPr/>
         </p:nvSpPr>
@@ -5602,7 +5643,7 @@
       </p:sp>
       <p:sp>
         <p:nvSpPr>
-          <p:cNvPr id="9" name="TextBox 8"/>
+          <p:cNvPr id="10" name="TextBox 9"/>
           <p:cNvSpPr txBox="1"/>
           <p:nvPr/>
         </p:nvSpPr>
@@ -5643,7 +5684,7 @@
       </p:sp>
       <p:sp>
         <p:nvSpPr>
-          <p:cNvPr id="10" name="Rounded Rectangle 9"/>
+          <p:cNvPr id="11" name="Rounded Rectangle 10"/>
           <p:cNvSpPr/>
           <p:nvPr/>
         </p:nvSpPr>
@@ -5697,7 +5738,7 @@
       </p:sp>
       <p:sp>
         <p:nvSpPr>
-          <p:cNvPr id="11" name="Rounded Rectangle 10"/>
+          <p:cNvPr id="12" name="Rounded Rectangle 11"/>
           <p:cNvSpPr/>
           <p:nvPr/>
         </p:nvSpPr>
@@ -5743,7 +5784,7 @@
       </p:sp>
       <p:sp>
         <p:nvSpPr>
-          <p:cNvPr id="12" name="TextBox 11"/>
+          <p:cNvPr id="13" name="TextBox 12"/>
           <p:cNvSpPr txBox="1"/>
           <p:nvPr/>
         </p:nvSpPr>
@@ -5784,7 +5825,7 @@
       </p:sp>
       <p:sp>
         <p:nvSpPr>
-          <p:cNvPr id="13" name="Freeform 12"/>
+          <p:cNvPr id="14" name="Freeform 13"/>
           <p:cNvSpPr/>
           <p:nvPr/>
         </p:nvSpPr>
@@ -5842,7 +5883,7 @@
       </p:sp>
       <p:sp>
         <p:nvSpPr>
-          <p:cNvPr id="14" name="TextBox 13"/>
+          <p:cNvPr id="15" name="TextBox 14"/>
           <p:cNvSpPr txBox="1"/>
           <p:nvPr/>
         </p:nvSpPr>
@@ -5883,7 +5924,7 @@
       </p:sp>
       <p:sp>
         <p:nvSpPr>
-          <p:cNvPr id="15" name="TextBox 14"/>
+          <p:cNvPr id="16" name="TextBox 15"/>
           <p:cNvSpPr txBox="1"/>
           <p:nvPr/>
         </p:nvSpPr>
@@ -5924,7 +5965,7 @@
       </p:sp>
       <p:sp>
         <p:nvSpPr>
-          <p:cNvPr id="16" name="Oval 15"/>
+          <p:cNvPr id="17" name="Oval 16"/>
           <p:cNvSpPr/>
           <p:nvPr/>
         </p:nvSpPr>
@@ -5970,7 +6011,7 @@
       </p:sp>
       <p:sp>
         <p:nvSpPr>
-          <p:cNvPr id="17" name="TextBox 16"/>
+          <p:cNvPr id="18" name="TextBox 17"/>
           <p:cNvSpPr txBox="1"/>
           <p:nvPr/>
         </p:nvSpPr>
@@ -6011,7 +6052,7 @@
       </p:sp>
       <p:sp>
         <p:nvSpPr>
-          <p:cNvPr id="18" name="TextBox 17"/>
+          <p:cNvPr id="19" name="TextBox 18"/>
           <p:cNvSpPr txBox="1"/>
           <p:nvPr/>
         </p:nvSpPr>
@@ -6052,7 +6093,7 @@
       </p:sp>
       <p:sp>
         <p:nvSpPr>
-          <p:cNvPr id="19" name="Oval 18"/>
+          <p:cNvPr id="20" name="Oval 19"/>
           <p:cNvSpPr/>
           <p:nvPr/>
         </p:nvSpPr>
@@ -6098,7 +6139,7 @@
       </p:sp>
       <p:sp>
         <p:nvSpPr>
-          <p:cNvPr id="20" name="TextBox 19"/>
+          <p:cNvPr id="21" name="TextBox 20"/>
           <p:cNvSpPr txBox="1"/>
           <p:nvPr/>
         </p:nvSpPr>
@@ -6139,7 +6180,7 @@
       </p:sp>
       <p:sp>
         <p:nvSpPr>
-          <p:cNvPr id="21" name="TextBox 20"/>
+          <p:cNvPr id="22" name="TextBox 21"/>
           <p:cNvSpPr txBox="1"/>
           <p:nvPr/>
         </p:nvSpPr>
@@ -6180,7 +6221,7 @@
       </p:sp>
       <p:sp>
         <p:nvSpPr>
-          <p:cNvPr id="22" name="Oval 21"/>
+          <p:cNvPr id="23" name="Oval 22"/>
           <p:cNvSpPr/>
           <p:nvPr/>
         </p:nvSpPr>
@@ -6226,7 +6267,7 @@
       </p:sp>
       <p:sp>
         <p:nvSpPr>
-          <p:cNvPr id="23" name="TextBox 22"/>
+          <p:cNvPr id="24" name="TextBox 23"/>
           <p:cNvSpPr txBox="1"/>
           <p:nvPr/>
         </p:nvSpPr>
@@ -6267,7 +6308,7 @@
       </p:sp>
       <p:sp>
         <p:nvSpPr>
-          <p:cNvPr id="24" name="TextBox 23"/>
+          <p:cNvPr id="25" name="TextBox 24"/>
           <p:cNvSpPr txBox="1"/>
           <p:nvPr/>
         </p:nvSpPr>
@@ -6308,7 +6349,7 @@
       </p:sp>
       <p:sp>
         <p:nvSpPr>
-          <p:cNvPr id="25" name="Freeform 24"/>
+          <p:cNvPr id="26" name="Freeform 25"/>
           <p:cNvSpPr/>
           <p:nvPr/>
         </p:nvSpPr>
@@ -6366,7 +6407,7 @@
       </p:sp>
       <p:sp>
         <p:nvSpPr>
-          <p:cNvPr id="26" name="TextBox 25"/>
+          <p:cNvPr id="27" name="TextBox 26"/>
           <p:cNvSpPr txBox="1"/>
           <p:nvPr/>
         </p:nvSpPr>
@@ -6407,7 +6448,7 @@
       </p:sp>
       <p:sp>
         <p:nvSpPr>
-          <p:cNvPr id="27" name="Rounded Rectangle 26"/>
+          <p:cNvPr id="28" name="Rounded Rectangle 27"/>
           <p:cNvSpPr/>
           <p:nvPr/>
         </p:nvSpPr>
@@ -6461,7 +6502,7 @@
       </p:sp>
       <p:sp>
         <p:nvSpPr>
-          <p:cNvPr id="28" name="Rounded Rectangle 27"/>
+          <p:cNvPr id="29" name="Rounded Rectangle 28"/>
           <p:cNvSpPr/>
           <p:nvPr/>
         </p:nvSpPr>
@@ -6507,7 +6548,7 @@
       </p:sp>
       <p:sp>
         <p:nvSpPr>
-          <p:cNvPr id="29" name="TextBox 28"/>
+          <p:cNvPr id="30" name="TextBox 29"/>
           <p:cNvSpPr txBox="1"/>
           <p:nvPr/>
         </p:nvSpPr>
@@ -6548,7 +6589,7 @@
       </p:sp>
       <p:sp>
         <p:nvSpPr>
-          <p:cNvPr id="30" name="Freeform 29"/>
+          <p:cNvPr id="31" name="Freeform 30"/>
           <p:cNvSpPr/>
           <p:nvPr/>
         </p:nvSpPr>
@@ -6606,7 +6647,7 @@
       </p:sp>
       <p:sp>
         <p:nvSpPr>
-          <p:cNvPr id="31" name="TextBox 30"/>
+          <p:cNvPr id="32" name="TextBox 31"/>
           <p:cNvSpPr txBox="1"/>
           <p:nvPr/>
         </p:nvSpPr>
@@ -6647,7 +6688,7 @@
       </p:sp>
       <p:sp>
         <p:nvSpPr>
-          <p:cNvPr id="32" name="TextBox 31"/>
+          <p:cNvPr id="33" name="TextBox 32"/>
           <p:cNvSpPr txBox="1"/>
           <p:nvPr/>
         </p:nvSpPr>
@@ -6688,7 +6729,7 @@
       </p:sp>
       <p:sp>
         <p:nvSpPr>
-          <p:cNvPr id="33" name="Oval 32"/>
+          <p:cNvPr id="34" name="Oval 33"/>
           <p:cNvSpPr/>
           <p:nvPr/>
         </p:nvSpPr>
@@ -6734,7 +6775,7 @@
       </p:sp>
       <p:sp>
         <p:nvSpPr>
-          <p:cNvPr id="34" name="TextBox 33"/>
+          <p:cNvPr id="35" name="TextBox 34"/>
           <p:cNvSpPr txBox="1"/>
           <p:nvPr/>
         </p:nvSpPr>
@@ -6775,7 +6816,7 @@
       </p:sp>
       <p:sp>
         <p:nvSpPr>
-          <p:cNvPr id="35" name="TextBox 34"/>
+          <p:cNvPr id="36" name="TextBox 35"/>
           <p:cNvSpPr txBox="1"/>
           <p:nvPr/>
         </p:nvSpPr>
@@ -6816,7 +6857,7 @@
       </p:sp>
       <p:sp>
         <p:nvSpPr>
-          <p:cNvPr id="36" name="Oval 35"/>
+          <p:cNvPr id="37" name="Oval 36"/>
           <p:cNvSpPr/>
           <p:nvPr/>
         </p:nvSpPr>
@@ -6862,7 +6903,7 @@
       </p:sp>
       <p:sp>
         <p:nvSpPr>
-          <p:cNvPr id="37" name="TextBox 36"/>
+          <p:cNvPr id="38" name="TextBox 37"/>
           <p:cNvSpPr txBox="1"/>
           <p:nvPr/>
         </p:nvSpPr>
@@ -6903,7 +6944,7 @@
       </p:sp>
       <p:sp>
         <p:nvSpPr>
-          <p:cNvPr id="38" name="TextBox 37"/>
+          <p:cNvPr id="39" name="TextBox 38"/>
           <p:cNvSpPr txBox="1"/>
           <p:nvPr/>
         </p:nvSpPr>
@@ -6944,7 +6985,7 @@
       </p:sp>
       <p:sp>
         <p:nvSpPr>
-          <p:cNvPr id="39" name="Oval 38"/>
+          <p:cNvPr id="40" name="Oval 39"/>
           <p:cNvSpPr/>
           <p:nvPr/>
         </p:nvSpPr>
@@ -6990,7 +7031,7 @@
       </p:sp>
       <p:sp>
         <p:nvSpPr>
-          <p:cNvPr id="40" name="TextBox 39"/>
+          <p:cNvPr id="41" name="TextBox 40"/>
           <p:cNvSpPr txBox="1"/>
           <p:nvPr/>
         </p:nvSpPr>
@@ -7031,7 +7072,7 @@
       </p:sp>
       <p:sp>
         <p:nvSpPr>
-          <p:cNvPr id="41" name="TextBox 40"/>
+          <p:cNvPr id="42" name="TextBox 41"/>
           <p:cNvSpPr txBox="1"/>
           <p:nvPr/>
         </p:nvSpPr>
@@ -7072,7 +7113,7 @@
       </p:sp>
       <p:sp>
         <p:nvSpPr>
-          <p:cNvPr id="42" name="Oval 41"/>
+          <p:cNvPr id="43" name="Oval 42"/>
           <p:cNvSpPr/>
           <p:nvPr/>
         </p:nvSpPr>
@@ -7118,7 +7159,7 @@
       </p:sp>
       <p:sp>
         <p:nvSpPr>
-          <p:cNvPr id="43" name="TextBox 42"/>
+          <p:cNvPr id="44" name="TextBox 43"/>
           <p:cNvSpPr txBox="1"/>
           <p:nvPr/>
         </p:nvSpPr>
@@ -7159,7 +7200,7 @@
       </p:sp>
       <p:sp>
         <p:nvSpPr>
-          <p:cNvPr id="44" name="TextBox 43"/>
+          <p:cNvPr id="45" name="TextBox 44"/>
           <p:cNvSpPr txBox="1"/>
           <p:nvPr/>
         </p:nvSpPr>
@@ -7200,7 +7241,7 @@
       </p:sp>
       <p:sp>
         <p:nvSpPr>
-          <p:cNvPr id="45" name="Freeform 44"/>
+          <p:cNvPr id="46" name="Freeform 45"/>
           <p:cNvSpPr/>
           <p:nvPr/>
         </p:nvSpPr>
@@ -7258,7 +7299,7 @@
       </p:sp>
       <p:sp>
         <p:nvSpPr>
-          <p:cNvPr id="46" name="TextBox 45"/>
+          <p:cNvPr id="47" name="TextBox 46"/>
           <p:cNvSpPr txBox="1"/>
           <p:nvPr/>
         </p:nvSpPr>
@@ -7495,7 +7536,48 @@
       </p:sp>
       <p:sp>
         <p:nvSpPr>
-          <p:cNvPr id="6" name="Freeform 5"/>
+          <p:cNvPr id="6" name="TextBox 5"/>
+          <p:cNvSpPr txBox="1"/>
+          <p:nvPr/>
+        </p:nvSpPr>
+        <p:spPr>
+          <a:xfrm>
+            <a:off x="10312400" y="254000"/>
+            <a:ext cx="1270000" cy="558800"/>
+          </a:xfrm>
+          <a:prstGeom prst="rect">
+            <a:avLst/>
+          </a:prstGeom>
+          <a:noFill/>
+        </p:spPr>
+        <p:txBody>
+          <a:bodyPr wrap="square" lIns="0" rIns="0" tIns="0" bIns="0" anchor="t">
+            <a:noAutofit/>
+          </a:bodyPr>
+          <a:lstStyle/>
+          <a:p>
+            <a:pPr algn="r">
+              <a:lnSpc>
+                <a:spcPct val="100000"/>
+              </a:lnSpc>
+            </a:pPr>
+            <a:r>
+              <a:rPr sz="3000" b="1" i="0">
+                <a:solidFill>
+                  <a:srgbClr val="E3EAF2"/>
+                </a:solidFill>
+                <a:latin typeface="Arial"/>
+                <a:ea typeface="Microsoft YaHei"/>
+                <a:cs typeface="Arial"/>
+              </a:rPr>
+              <a:t>03</a:t>
+            </a:r>
+          </a:p>
+        </p:txBody>
+      </p:sp>
+      <p:sp>
+        <p:nvSpPr>
+          <p:cNvPr id="7" name="Freeform 6"/>
           <p:cNvSpPr/>
           <p:nvPr/>
         </p:nvSpPr>
@@ -7553,7 +7635,7 @@
       </p:sp>
       <p:sp>
         <p:nvSpPr>
-          <p:cNvPr id="7" name="Freeform 6"/>
+          <p:cNvPr id="8" name="Freeform 7"/>
           <p:cNvSpPr/>
           <p:nvPr/>
         </p:nvSpPr>
@@ -7611,7 +7693,7 @@
       </p:sp>
       <p:sp>
         <p:nvSpPr>
-          <p:cNvPr id="8" name="TextBox 7"/>
+          <p:cNvPr id="9" name="TextBox 8"/>
           <p:cNvSpPr txBox="1"/>
           <p:nvPr/>
         </p:nvSpPr>
@@ -7652,7 +7734,7 @@
       </p:sp>
       <p:sp>
         <p:nvSpPr>
-          <p:cNvPr id="9" name="TextBox 8"/>
+          <p:cNvPr id="10" name="TextBox 9"/>
           <p:cNvSpPr txBox="1"/>
           <p:nvPr/>
         </p:nvSpPr>
@@ -7693,7 +7775,7 @@
       </p:sp>
       <p:sp>
         <p:nvSpPr>
-          <p:cNvPr id="10" name="Rounded Rectangle 9"/>
+          <p:cNvPr id="11" name="Rounded Rectangle 10"/>
           <p:cNvSpPr/>
           <p:nvPr/>
         </p:nvSpPr>
@@ -7741,7 +7823,7 @@
       </p:sp>
       <p:sp>
         <p:nvSpPr>
-          <p:cNvPr id="11" name="Rounded Rectangle 10"/>
+          <p:cNvPr id="12" name="Rounded Rectangle 11"/>
           <p:cNvSpPr/>
           <p:nvPr/>
         </p:nvSpPr>
@@ -7787,7 +7869,7 @@
       </p:sp>
       <p:sp>
         <p:nvSpPr>
-          <p:cNvPr id="12" name="TextBox 11"/>
+          <p:cNvPr id="13" name="TextBox 12"/>
           <p:cNvSpPr txBox="1"/>
           <p:nvPr/>
         </p:nvSpPr>
@@ -7839,7 +7921,7 @@
       </p:sp>
       <p:sp>
         <p:nvSpPr>
-          <p:cNvPr id="13" name="Rounded Rectangle 12"/>
+          <p:cNvPr id="14" name="Rounded Rectangle 13"/>
           <p:cNvSpPr/>
           <p:nvPr/>
         </p:nvSpPr>
@@ -7893,7 +7975,7 @@
       </p:sp>
       <p:sp>
         <p:nvSpPr>
-          <p:cNvPr id="14" name="Rounded Rectangle 13"/>
+          <p:cNvPr id="15" name="Rounded Rectangle 14"/>
           <p:cNvSpPr/>
           <p:nvPr/>
         </p:nvSpPr>
@@ -7939,7 +8021,7 @@
       </p:sp>
       <p:sp>
         <p:nvSpPr>
-          <p:cNvPr id="15" name="Rounded Rectangle 14"/>
+          <p:cNvPr id="16" name="Rounded Rectangle 15"/>
           <p:cNvSpPr/>
           <p:nvPr/>
         </p:nvSpPr>
@@ -7985,7 +8067,7 @@
       </p:sp>
       <p:sp>
         <p:nvSpPr>
-          <p:cNvPr id="16" name="TextBox 15"/>
+          <p:cNvPr id="17" name="TextBox 16"/>
           <p:cNvSpPr txBox="1"/>
           <p:nvPr/>
         </p:nvSpPr>
@@ -8026,7 +8108,7 @@
       </p:sp>
       <p:sp>
         <p:nvSpPr>
-          <p:cNvPr id="17" name="TextBox 16"/>
+          <p:cNvPr id="18" name="TextBox 17"/>
           <p:cNvSpPr txBox="1"/>
           <p:nvPr/>
         </p:nvSpPr>
@@ -8067,7 +8149,7 @@
       </p:sp>
       <p:sp>
         <p:nvSpPr>
-          <p:cNvPr id="18" name="TextBox 17"/>
+          <p:cNvPr id="19" name="TextBox 18"/>
           <p:cNvSpPr txBox="1"/>
           <p:nvPr/>
         </p:nvSpPr>
@@ -8238,7 +8320,7 @@
       </p:sp>
       <p:sp>
         <p:nvSpPr>
-          <p:cNvPr id="19" name="Rounded Rectangle 18"/>
+          <p:cNvPr id="20" name="Rounded Rectangle 19"/>
           <p:cNvSpPr/>
           <p:nvPr/>
         </p:nvSpPr>
@@ -8292,7 +8374,7 @@
       </p:sp>
       <p:sp>
         <p:nvSpPr>
-          <p:cNvPr id="20" name="Rounded Rectangle 19"/>
+          <p:cNvPr id="21" name="Rounded Rectangle 20"/>
           <p:cNvSpPr/>
           <p:nvPr/>
         </p:nvSpPr>
@@ -8338,7 +8420,7 @@
       </p:sp>
       <p:sp>
         <p:nvSpPr>
-          <p:cNvPr id="21" name="Rounded Rectangle 20"/>
+          <p:cNvPr id="22" name="Rounded Rectangle 21"/>
           <p:cNvSpPr/>
           <p:nvPr/>
         </p:nvSpPr>
@@ -8384,7 +8466,7 @@
       </p:sp>
       <p:sp>
         <p:nvSpPr>
-          <p:cNvPr id="22" name="TextBox 21"/>
+          <p:cNvPr id="23" name="TextBox 22"/>
           <p:cNvSpPr txBox="1"/>
           <p:nvPr/>
         </p:nvSpPr>
@@ -8425,7 +8507,7 @@
       </p:sp>
       <p:sp>
         <p:nvSpPr>
-          <p:cNvPr id="23" name="TextBox 22"/>
+          <p:cNvPr id="24" name="TextBox 23"/>
           <p:cNvSpPr txBox="1"/>
           <p:nvPr/>
         </p:nvSpPr>
@@ -8466,7 +8548,7 @@
       </p:sp>
       <p:sp>
         <p:nvSpPr>
-          <p:cNvPr id="24" name="TextBox 23"/>
+          <p:cNvPr id="25" name="TextBox 24"/>
           <p:cNvSpPr txBox="1"/>
           <p:nvPr/>
         </p:nvSpPr>
@@ -8534,7 +8616,7 @@
       </p:sp>
       <p:sp>
         <p:nvSpPr>
-          <p:cNvPr id="25" name="Freeform 24"/>
+          <p:cNvPr id="26" name="Freeform 25"/>
           <p:cNvSpPr/>
           <p:nvPr/>
         </p:nvSpPr>
@@ -8592,7 +8674,7 @@
       </p:sp>
       <p:sp>
         <p:nvSpPr>
-          <p:cNvPr id="26" name="TextBox 25"/>
+          <p:cNvPr id="27" name="TextBox 26"/>
           <p:cNvSpPr txBox="1"/>
           <p:nvPr/>
         </p:nvSpPr>
@@ -8633,7 +8715,7 @@
       </p:sp>
       <p:sp>
         <p:nvSpPr>
-          <p:cNvPr id="27" name="TextBox 26"/>
+          <p:cNvPr id="28" name="TextBox 27"/>
           <p:cNvSpPr txBox="1"/>
           <p:nvPr/>
         </p:nvSpPr>
@@ -8674,7 +8756,7 @@
       </p:sp>
       <p:sp>
         <p:nvSpPr>
-          <p:cNvPr id="28" name="TextBox 27"/>
+          <p:cNvPr id="29" name="TextBox 28"/>
           <p:cNvSpPr txBox="1"/>
           <p:nvPr/>
         </p:nvSpPr>
@@ -8715,7 +8797,7 @@
       </p:sp>
       <p:sp>
         <p:nvSpPr>
-          <p:cNvPr id="29" name="Rounded Rectangle 28"/>
+          <p:cNvPr id="30" name="Rounded Rectangle 29"/>
           <p:cNvSpPr/>
           <p:nvPr/>
         </p:nvSpPr>
@@ -8769,7 +8851,7 @@
       </p:sp>
       <p:sp>
         <p:nvSpPr>
-          <p:cNvPr id="30" name="TextBox 29"/>
+          <p:cNvPr id="31" name="TextBox 30"/>
           <p:cNvSpPr txBox="1"/>
           <p:nvPr/>
         </p:nvSpPr>
@@ -8810,7 +8892,7 @@
       </p:sp>
       <p:sp>
         <p:nvSpPr>
-          <p:cNvPr id="31" name="Rounded Rectangle 30"/>
+          <p:cNvPr id="32" name="Rounded Rectangle 31"/>
           <p:cNvSpPr/>
           <p:nvPr/>
         </p:nvSpPr>
@@ -8856,7 +8938,7 @@
       </p:sp>
       <p:sp>
         <p:nvSpPr>
-          <p:cNvPr id="32" name="TextBox 31"/>
+          <p:cNvPr id="33" name="TextBox 32"/>
           <p:cNvSpPr txBox="1"/>
           <p:nvPr/>
         </p:nvSpPr>
@@ -8897,7 +8979,7 @@
       </p:sp>
       <p:sp>
         <p:nvSpPr>
-          <p:cNvPr id="33" name="Rounded Rectangle 32"/>
+          <p:cNvPr id="34" name="Rounded Rectangle 33"/>
           <p:cNvSpPr/>
           <p:nvPr/>
         </p:nvSpPr>
@@ -8943,7 +9025,7 @@
       </p:sp>
       <p:sp>
         <p:nvSpPr>
-          <p:cNvPr id="34" name="TextBox 33"/>
+          <p:cNvPr id="35" name="TextBox 34"/>
           <p:cNvSpPr txBox="1"/>
           <p:nvPr/>
         </p:nvSpPr>
@@ -8984,7 +9066,7 @@
       </p:sp>
       <p:sp>
         <p:nvSpPr>
-          <p:cNvPr id="35" name="Freeform 34"/>
+          <p:cNvPr id="36" name="Freeform 35"/>
           <p:cNvSpPr/>
           <p:nvPr/>
         </p:nvSpPr>
@@ -9049,7 +9131,7 @@
       </p:sp>
       <p:sp>
         <p:nvSpPr>
-          <p:cNvPr id="36" name="Freeform 35"/>
+          <p:cNvPr id="37" name="Freeform 36"/>
           <p:cNvSpPr/>
           <p:nvPr/>
         </p:nvSpPr>
@@ -9114,7 +9196,7 @@
       </p:sp>
       <p:sp>
         <p:nvSpPr>
-          <p:cNvPr id="37" name="Oval 36"/>
+          <p:cNvPr id="38" name="Oval 37"/>
           <p:cNvSpPr/>
           <p:nvPr/>
         </p:nvSpPr>
@@ -9160,7 +9242,7 @@
       </p:sp>
       <p:sp>
         <p:nvSpPr>
-          <p:cNvPr id="38" name="Oval 37"/>
+          <p:cNvPr id="39" name="Oval 38"/>
           <p:cNvSpPr/>
           <p:nvPr/>
         </p:nvSpPr>
@@ -9206,7 +9288,7 @@
       </p:sp>
       <p:sp>
         <p:nvSpPr>
-          <p:cNvPr id="39" name="Oval 38"/>
+          <p:cNvPr id="40" name="Oval 39"/>
           <p:cNvSpPr/>
           <p:nvPr/>
         </p:nvSpPr>
@@ -9252,7 +9334,7 @@
       </p:sp>
       <p:sp>
         <p:nvSpPr>
-          <p:cNvPr id="40" name="Oval 39"/>
+          <p:cNvPr id="41" name="Oval 40"/>
           <p:cNvSpPr/>
           <p:nvPr/>
         </p:nvSpPr>
@@ -9298,7 +9380,7 @@
       </p:sp>
       <p:sp>
         <p:nvSpPr>
-          <p:cNvPr id="41" name="Oval 40"/>
+          <p:cNvPr id="42" name="Oval 41"/>
           <p:cNvSpPr/>
           <p:nvPr/>
         </p:nvSpPr>
@@ -9344,7 +9426,7 @@
       </p:sp>
       <p:sp>
         <p:nvSpPr>
-          <p:cNvPr id="42" name="TextBox 41"/>
+          <p:cNvPr id="43" name="TextBox 42"/>
           <p:cNvSpPr txBox="1"/>
           <p:nvPr/>
         </p:nvSpPr>
@@ -9385,7 +9467,7 @@
       </p:sp>
       <p:sp>
         <p:nvSpPr>
-          <p:cNvPr id="43" name="Freeform 42"/>
+          <p:cNvPr id="44" name="Freeform 43"/>
           <p:cNvSpPr/>
           <p:nvPr/>
         </p:nvSpPr>
@@ -9443,7 +9525,7 @@
       </p:sp>
       <p:sp>
         <p:nvSpPr>
-          <p:cNvPr id="44" name="Freeform 43"/>
+          <p:cNvPr id="45" name="Freeform 44"/>
           <p:cNvSpPr/>
           <p:nvPr/>
         </p:nvSpPr>
@@ -9505,7 +9587,7 @@
       </p:sp>
       <p:sp>
         <p:nvSpPr>
-          <p:cNvPr id="45" name="TextBox 44"/>
+          <p:cNvPr id="46" name="TextBox 45"/>
           <p:cNvSpPr txBox="1"/>
           <p:nvPr/>
         </p:nvSpPr>
@@ -9546,7 +9628,7 @@
       </p:sp>
       <p:sp>
         <p:nvSpPr>
-          <p:cNvPr id="46" name="Freeform 45"/>
+          <p:cNvPr id="47" name="Freeform 46"/>
           <p:cNvSpPr/>
           <p:nvPr/>
         </p:nvSpPr>
@@ -9604,7 +9686,7 @@
       </p:sp>
       <p:sp>
         <p:nvSpPr>
-          <p:cNvPr id="47" name="Freeform 46"/>
+          <p:cNvPr id="48" name="Freeform 47"/>
           <p:cNvSpPr/>
           <p:nvPr/>
         </p:nvSpPr>
@@ -9666,7 +9748,7 @@
       </p:sp>
       <p:sp>
         <p:nvSpPr>
-          <p:cNvPr id="48" name="Freeform 47"/>
+          <p:cNvPr id="49" name="Freeform 48"/>
           <p:cNvSpPr/>
           <p:nvPr/>
         </p:nvSpPr>
@@ -9724,7 +9806,7 @@
       </p:sp>
       <p:sp>
         <p:nvSpPr>
-          <p:cNvPr id="49" name="Freeform 48"/>
+          <p:cNvPr id="50" name="Freeform 49"/>
           <p:cNvSpPr/>
           <p:nvPr/>
         </p:nvSpPr>
@@ -9786,7 +9868,7 @@
       </p:sp>
       <p:sp>
         <p:nvSpPr>
-          <p:cNvPr id="50" name="Freeform 49"/>
+          <p:cNvPr id="51" name="Freeform 50"/>
           <p:cNvSpPr/>
           <p:nvPr/>
         </p:nvSpPr>
@@ -9844,7 +9926,7 @@
       </p:sp>
       <p:sp>
         <p:nvSpPr>
-          <p:cNvPr id="51" name="Freeform 50"/>
+          <p:cNvPr id="52" name="Freeform 51"/>
           <p:cNvSpPr/>
           <p:nvPr/>
         </p:nvSpPr>
@@ -10102,7 +10184,48 @@
       </p:sp>
       <p:sp>
         <p:nvSpPr>
-          <p:cNvPr id="6" name="Freeform 5"/>
+          <p:cNvPr id="6" name="TextBox 5"/>
+          <p:cNvSpPr txBox="1"/>
+          <p:nvPr/>
+        </p:nvSpPr>
+        <p:spPr>
+          <a:xfrm>
+            <a:off x="10312400" y="254000"/>
+            <a:ext cx="1270000" cy="558800"/>
+          </a:xfrm>
+          <a:prstGeom prst="rect">
+            <a:avLst/>
+          </a:prstGeom>
+          <a:noFill/>
+        </p:spPr>
+        <p:txBody>
+          <a:bodyPr wrap="square" lIns="0" rIns="0" tIns="0" bIns="0" anchor="t">
+            <a:noAutofit/>
+          </a:bodyPr>
+          <a:lstStyle/>
+          <a:p>
+            <a:pPr algn="r">
+              <a:lnSpc>
+                <a:spcPct val="100000"/>
+              </a:lnSpc>
+            </a:pPr>
+            <a:r>
+              <a:rPr sz="3000" b="1" i="0">
+                <a:solidFill>
+                  <a:srgbClr val="E3EAF2"/>
+                </a:solidFill>
+                <a:latin typeface="Arial"/>
+                <a:ea typeface="Microsoft YaHei"/>
+                <a:cs typeface="Arial"/>
+              </a:rPr>
+              <a:t>04</a:t>
+            </a:r>
+          </a:p>
+        </p:txBody>
+      </p:sp>
+      <p:sp>
+        <p:nvSpPr>
+          <p:cNvPr id="7" name="Freeform 6"/>
           <p:cNvSpPr/>
           <p:nvPr/>
         </p:nvSpPr>
@@ -10160,7 +10283,7 @@
       </p:sp>
       <p:sp>
         <p:nvSpPr>
-          <p:cNvPr id="7" name="Freeform 6"/>
+          <p:cNvPr id="8" name="Freeform 7"/>
           <p:cNvSpPr/>
           <p:nvPr/>
         </p:nvSpPr>
@@ -10218,7 +10341,7 @@
       </p:sp>
       <p:sp>
         <p:nvSpPr>
-          <p:cNvPr id="8" name="TextBox 7"/>
+          <p:cNvPr id="9" name="TextBox 8"/>
           <p:cNvSpPr txBox="1"/>
           <p:nvPr/>
         </p:nvSpPr>
@@ -10259,7 +10382,7 @@
       </p:sp>
       <p:sp>
         <p:nvSpPr>
-          <p:cNvPr id="9" name="TextBox 8"/>
+          <p:cNvPr id="10" name="TextBox 9"/>
           <p:cNvSpPr txBox="1"/>
           <p:nvPr/>
         </p:nvSpPr>
@@ -10300,7 +10423,7 @@
       </p:sp>
       <p:sp>
         <p:nvSpPr>
-          <p:cNvPr id="10" name="Rounded Rectangle 9"/>
+          <p:cNvPr id="11" name="Rounded Rectangle 10"/>
           <p:cNvSpPr/>
           <p:nvPr/>
         </p:nvSpPr>
@@ -10354,7 +10477,7 @@
       </p:sp>
       <p:sp>
         <p:nvSpPr>
-          <p:cNvPr id="11" name="Rounded Rectangle 10"/>
+          <p:cNvPr id="12" name="Rounded Rectangle 11"/>
           <p:cNvSpPr/>
           <p:nvPr/>
         </p:nvSpPr>
@@ -10400,7 +10523,7 @@
       </p:sp>
       <p:sp>
         <p:nvSpPr>
-          <p:cNvPr id="12" name="Rounded Rectangle 11"/>
+          <p:cNvPr id="13" name="Rounded Rectangle 12"/>
           <p:cNvSpPr/>
           <p:nvPr/>
         </p:nvSpPr>
@@ -10446,7 +10569,7 @@
       </p:sp>
       <p:sp>
         <p:nvSpPr>
-          <p:cNvPr id="13" name="Oval 12"/>
+          <p:cNvPr id="14" name="Oval 13"/>
           <p:cNvSpPr/>
           <p:nvPr/>
         </p:nvSpPr>
@@ -10490,7 +10613,7 @@
       </p:sp>
       <p:sp>
         <p:nvSpPr>
-          <p:cNvPr id="14" name="Freeform 13"/>
+          <p:cNvPr id="15" name="Freeform 14"/>
           <p:cNvSpPr/>
           <p:nvPr/>
         </p:nvSpPr>
@@ -10548,7 +10671,7 @@
       </p:sp>
       <p:sp>
         <p:nvSpPr>
-          <p:cNvPr id="15" name="Rounded Rectangle 14"/>
+          <p:cNvPr id="16" name="Rounded Rectangle 15"/>
           <p:cNvSpPr/>
           <p:nvPr/>
         </p:nvSpPr>
@@ -10594,7 +10717,7 @@
       </p:sp>
       <p:sp>
         <p:nvSpPr>
-          <p:cNvPr id="16" name="TextBox 15"/>
+          <p:cNvPr id="17" name="TextBox 16"/>
           <p:cNvSpPr txBox="1"/>
           <p:nvPr/>
         </p:nvSpPr>
@@ -10635,7 +10758,7 @@
       </p:sp>
       <p:sp>
         <p:nvSpPr>
-          <p:cNvPr id="17" name="TextBox 16"/>
+          <p:cNvPr id="18" name="TextBox 17"/>
           <p:cNvSpPr txBox="1"/>
           <p:nvPr/>
         </p:nvSpPr>
@@ -10676,7 +10799,7 @@
       </p:sp>
       <p:sp>
         <p:nvSpPr>
-          <p:cNvPr id="18" name="TextBox 17"/>
+          <p:cNvPr id="19" name="TextBox 18"/>
           <p:cNvSpPr txBox="1"/>
           <p:nvPr/>
         </p:nvSpPr>
@@ -10744,7 +10867,7 @@
       </p:sp>
       <p:sp>
         <p:nvSpPr>
-          <p:cNvPr id="19" name="Rounded Rectangle 18"/>
+          <p:cNvPr id="20" name="Rounded Rectangle 19"/>
           <p:cNvSpPr/>
           <p:nvPr/>
         </p:nvSpPr>
@@ -10798,7 +10921,7 @@
       </p:sp>
       <p:sp>
         <p:nvSpPr>
-          <p:cNvPr id="20" name="Rounded Rectangle 19"/>
+          <p:cNvPr id="21" name="Rounded Rectangle 20"/>
           <p:cNvSpPr/>
           <p:nvPr/>
         </p:nvSpPr>
@@ -10844,7 +10967,7 @@
       </p:sp>
       <p:sp>
         <p:nvSpPr>
-          <p:cNvPr id="21" name="Rounded Rectangle 20"/>
+          <p:cNvPr id="22" name="Rounded Rectangle 21"/>
           <p:cNvSpPr/>
           <p:nvPr/>
         </p:nvSpPr>
@@ -10890,7 +11013,7 @@
       </p:sp>
       <p:sp>
         <p:nvSpPr>
-          <p:cNvPr id="22" name="Freeform 21"/>
+          <p:cNvPr id="23" name="Freeform 22"/>
           <p:cNvSpPr/>
           <p:nvPr/>
         </p:nvSpPr>
@@ -11089,7 +11212,7 @@
       </p:sp>
       <p:sp>
         <p:nvSpPr>
-          <p:cNvPr id="23" name="Freeform 22"/>
+          <p:cNvPr id="24" name="Freeform 23"/>
           <p:cNvSpPr/>
           <p:nvPr/>
         </p:nvSpPr>
@@ -11288,7 +11411,7 @@
       </p:sp>
       <p:sp>
         <p:nvSpPr>
-          <p:cNvPr id="24" name="Freeform 23"/>
+          <p:cNvPr id="25" name="Freeform 24"/>
           <p:cNvSpPr/>
           <p:nvPr/>
         </p:nvSpPr>
@@ -11487,7 +11610,7 @@
       </p:sp>
       <p:sp>
         <p:nvSpPr>
-          <p:cNvPr id="25" name="Rounded Rectangle 24"/>
+          <p:cNvPr id="26" name="Rounded Rectangle 25"/>
           <p:cNvSpPr/>
           <p:nvPr/>
         </p:nvSpPr>
@@ -11533,7 +11656,7 @@
       </p:sp>
       <p:sp>
         <p:nvSpPr>
-          <p:cNvPr id="26" name="TextBox 25"/>
+          <p:cNvPr id="27" name="TextBox 26"/>
           <p:cNvSpPr txBox="1"/>
           <p:nvPr/>
         </p:nvSpPr>
@@ -11574,7 +11697,7 @@
       </p:sp>
       <p:sp>
         <p:nvSpPr>
-          <p:cNvPr id="27" name="TextBox 26"/>
+          <p:cNvPr id="28" name="TextBox 27"/>
           <p:cNvSpPr txBox="1"/>
           <p:nvPr/>
         </p:nvSpPr>
@@ -11615,7 +11738,7 @@
       </p:sp>
       <p:sp>
         <p:nvSpPr>
-          <p:cNvPr id="28" name="TextBox 27"/>
+          <p:cNvPr id="29" name="TextBox 28"/>
           <p:cNvSpPr txBox="1"/>
           <p:nvPr/>
         </p:nvSpPr>
@@ -11683,7 +11806,7 @@
       </p:sp>
       <p:sp>
         <p:nvSpPr>
-          <p:cNvPr id="29" name="Oval 28"/>
+          <p:cNvPr id="30" name="Oval 29"/>
           <p:cNvSpPr/>
           <p:nvPr/>
         </p:nvSpPr>
@@ -11729,7 +11852,7 @@
       </p:sp>
       <p:sp>
         <p:nvSpPr>
-          <p:cNvPr id="30" name="TextBox 29"/>
+          <p:cNvPr id="31" name="TextBox 30"/>
           <p:cNvSpPr txBox="1"/>
           <p:nvPr/>
         </p:nvSpPr>
@@ -11770,7 +11893,7 @@
       </p:sp>
       <p:sp>
         <p:nvSpPr>
-          <p:cNvPr id="31" name="Freeform 30"/>
+          <p:cNvPr id="32" name="Freeform 31"/>
           <p:cNvSpPr/>
           <p:nvPr/>
         </p:nvSpPr>
@@ -11828,7 +11951,7 @@
       </p:sp>
       <p:sp>
         <p:nvSpPr>
-          <p:cNvPr id="32" name="Freeform 31"/>
+          <p:cNvPr id="33" name="Freeform 32"/>
           <p:cNvSpPr/>
           <p:nvPr/>
         </p:nvSpPr>
@@ -11890,7 +12013,7 @@
       </p:sp>
       <p:sp>
         <p:nvSpPr>
-          <p:cNvPr id="33" name="Freeform 32"/>
+          <p:cNvPr id="34" name="Freeform 33"/>
           <p:cNvSpPr/>
           <p:nvPr/>
         </p:nvSpPr>
@@ -11948,7 +12071,7 @@
       </p:sp>
       <p:sp>
         <p:nvSpPr>
-          <p:cNvPr id="34" name="Freeform 33"/>
+          <p:cNvPr id="35" name="Freeform 34"/>
           <p:cNvSpPr/>
           <p:nvPr/>
         </p:nvSpPr>
@@ -12010,7 +12133,7 @@
       </p:sp>
       <p:sp>
         <p:nvSpPr>
-          <p:cNvPr id="35" name="Rounded Rectangle 34"/>
+          <p:cNvPr id="36" name="Rounded Rectangle 35"/>
           <p:cNvSpPr/>
           <p:nvPr/>
         </p:nvSpPr>
@@ -12056,7 +12179,7 @@
       </p:sp>
       <p:sp>
         <p:nvSpPr>
-          <p:cNvPr id="36" name="Rounded Rectangle 35"/>
+          <p:cNvPr id="37" name="Rounded Rectangle 36"/>
           <p:cNvSpPr/>
           <p:nvPr/>
         </p:nvSpPr>
@@ -12102,7 +12225,7 @@
       </p:sp>
       <p:sp>
         <p:nvSpPr>
-          <p:cNvPr id="37" name="TextBox 36"/>
+          <p:cNvPr id="38" name="TextBox 37"/>
           <p:cNvSpPr txBox="1"/>
           <p:nvPr/>
         </p:nvSpPr>
@@ -12176,7 +12299,7 @@
       </p:sp>
       <p:sp>
         <p:nvSpPr>
-          <p:cNvPr id="38" name="Freeform 37"/>
+          <p:cNvPr id="39" name="Freeform 38"/>
           <p:cNvSpPr/>
           <p:nvPr/>
         </p:nvSpPr>
@@ -12234,7 +12357,7 @@
       </p:sp>
       <p:sp>
         <p:nvSpPr>
-          <p:cNvPr id="39" name="Freeform 38"/>
+          <p:cNvPr id="40" name="Freeform 39"/>
           <p:cNvSpPr/>
           <p:nvPr/>
         </p:nvSpPr>
@@ -12296,7 +12419,7 @@
       </p:sp>
       <p:sp>
         <p:nvSpPr>
-          <p:cNvPr id="40" name="Rounded Rectangle 39"/>
+          <p:cNvPr id="41" name="Rounded Rectangle 40"/>
           <p:cNvSpPr/>
           <p:nvPr/>
         </p:nvSpPr>
@@ -12342,7 +12465,7 @@
       </p:sp>
       <p:sp>
         <p:nvSpPr>
-          <p:cNvPr id="41" name="Rounded Rectangle 40"/>
+          <p:cNvPr id="42" name="Rounded Rectangle 41"/>
           <p:cNvSpPr/>
           <p:nvPr/>
         </p:nvSpPr>
@@ -12388,7 +12511,7 @@
       </p:sp>
       <p:sp>
         <p:nvSpPr>
-          <p:cNvPr id="42" name="TextBox 41"/>
+          <p:cNvPr id="43" name="TextBox 42"/>
           <p:cNvSpPr txBox="1"/>
           <p:nvPr/>
         </p:nvSpPr>
@@ -12484,7 +12607,7 @@
       </p:sp>
       <p:sp>
         <p:nvSpPr>
-          <p:cNvPr id="43" name="Rounded Rectangle 42"/>
+          <p:cNvPr id="44" name="Rounded Rectangle 43"/>
           <p:cNvSpPr/>
           <p:nvPr/>
         </p:nvSpPr>
@@ -12530,7 +12653,7 @@
       </p:sp>
       <p:sp>
         <p:nvSpPr>
-          <p:cNvPr id="44" name="TextBox 43"/>
+          <p:cNvPr id="45" name="TextBox 44"/>
           <p:cNvSpPr txBox="1"/>
           <p:nvPr/>
         </p:nvSpPr>
@@ -12767,7 +12890,48 @@
       </p:sp>
       <p:sp>
         <p:nvSpPr>
-          <p:cNvPr id="6" name="Freeform 5"/>
+          <p:cNvPr id="6" name="TextBox 5"/>
+          <p:cNvSpPr txBox="1"/>
+          <p:nvPr/>
+        </p:nvSpPr>
+        <p:spPr>
+          <a:xfrm>
+            <a:off x="10312400" y="254000"/>
+            <a:ext cx="1270000" cy="558800"/>
+          </a:xfrm>
+          <a:prstGeom prst="rect">
+            <a:avLst/>
+          </a:prstGeom>
+          <a:noFill/>
+        </p:spPr>
+        <p:txBody>
+          <a:bodyPr wrap="square" lIns="0" rIns="0" tIns="0" bIns="0" anchor="t">
+            <a:noAutofit/>
+          </a:bodyPr>
+          <a:lstStyle/>
+          <a:p>
+            <a:pPr algn="r">
+              <a:lnSpc>
+                <a:spcPct val="100000"/>
+              </a:lnSpc>
+            </a:pPr>
+            <a:r>
+              <a:rPr sz="3000" b="1" i="0">
+                <a:solidFill>
+                  <a:srgbClr val="E3EAF2"/>
+                </a:solidFill>
+                <a:latin typeface="Arial"/>
+                <a:ea typeface="Microsoft YaHei"/>
+                <a:cs typeface="Arial"/>
+              </a:rPr>
+              <a:t>05</a:t>
+            </a:r>
+          </a:p>
+        </p:txBody>
+      </p:sp>
+      <p:sp>
+        <p:nvSpPr>
+          <p:cNvPr id="7" name="Freeform 6"/>
           <p:cNvSpPr/>
           <p:nvPr/>
         </p:nvSpPr>
@@ -12825,7 +12989,7 @@
       </p:sp>
       <p:sp>
         <p:nvSpPr>
-          <p:cNvPr id="7" name="Freeform 6"/>
+          <p:cNvPr id="8" name="Freeform 7"/>
           <p:cNvSpPr/>
           <p:nvPr/>
         </p:nvSpPr>
@@ -12883,7 +13047,7 @@
       </p:sp>
       <p:sp>
         <p:nvSpPr>
-          <p:cNvPr id="8" name="TextBox 7"/>
+          <p:cNvPr id="9" name="TextBox 8"/>
           <p:cNvSpPr txBox="1"/>
           <p:nvPr/>
         </p:nvSpPr>
@@ -12924,7 +13088,7 @@
       </p:sp>
       <p:sp>
         <p:nvSpPr>
-          <p:cNvPr id="9" name="TextBox 8"/>
+          <p:cNvPr id="10" name="TextBox 9"/>
           <p:cNvSpPr txBox="1"/>
           <p:nvPr/>
         </p:nvSpPr>
@@ -12965,7 +13129,7 @@
       </p:sp>
       <p:sp>
         <p:nvSpPr>
-          <p:cNvPr id="10" name="Rounded Rectangle 9"/>
+          <p:cNvPr id="11" name="Rounded Rectangle 10"/>
           <p:cNvSpPr/>
           <p:nvPr/>
         </p:nvSpPr>
@@ -13019,7 +13183,7 @@
       </p:sp>
       <p:sp>
         <p:nvSpPr>
-          <p:cNvPr id="11" name="TextBox 10"/>
+          <p:cNvPr id="12" name="TextBox 11"/>
           <p:cNvSpPr txBox="1"/>
           <p:nvPr/>
         </p:nvSpPr>
@@ -13060,7 +13224,7 @@
       </p:sp>
       <p:sp>
         <p:nvSpPr>
-          <p:cNvPr id="12" name="Rounded Rectangle 11"/>
+          <p:cNvPr id="13" name="Rounded Rectangle 12"/>
           <p:cNvSpPr/>
           <p:nvPr/>
         </p:nvSpPr>
@@ -13106,7 +13270,7 @@
       </p:sp>
       <p:sp>
         <p:nvSpPr>
-          <p:cNvPr id="13" name="TextBox 12"/>
+          <p:cNvPr id="14" name="TextBox 13"/>
           <p:cNvSpPr txBox="1"/>
           <p:nvPr/>
         </p:nvSpPr>
@@ -13147,7 +13311,7 @@
       </p:sp>
       <p:sp>
         <p:nvSpPr>
-          <p:cNvPr id="14" name="Rounded Rectangle 13"/>
+          <p:cNvPr id="15" name="Rounded Rectangle 14"/>
           <p:cNvSpPr/>
           <p:nvPr/>
         </p:nvSpPr>
@@ -13193,7 +13357,7 @@
       </p:sp>
       <p:sp>
         <p:nvSpPr>
-          <p:cNvPr id="15" name="TextBox 14"/>
+          <p:cNvPr id="16" name="TextBox 15"/>
           <p:cNvSpPr txBox="1"/>
           <p:nvPr/>
         </p:nvSpPr>
@@ -13234,7 +13398,7 @@
       </p:sp>
       <p:sp>
         <p:nvSpPr>
-          <p:cNvPr id="16" name="Rounded Rectangle 15"/>
+          <p:cNvPr id="17" name="Rounded Rectangle 16"/>
           <p:cNvSpPr/>
           <p:nvPr/>
         </p:nvSpPr>
@@ -13288,7 +13452,7 @@
       </p:sp>
       <p:sp>
         <p:nvSpPr>
-          <p:cNvPr id="17" name="Rounded Rectangle 16"/>
+          <p:cNvPr id="18" name="Rounded Rectangle 17"/>
           <p:cNvSpPr/>
           <p:nvPr/>
         </p:nvSpPr>
@@ -13334,7 +13498,7 @@
       </p:sp>
       <p:sp>
         <p:nvSpPr>
-          <p:cNvPr id="18" name="TextBox 17"/>
+          <p:cNvPr id="19" name="TextBox 18"/>
           <p:cNvSpPr txBox="1"/>
           <p:nvPr/>
         </p:nvSpPr>
@@ -13408,7 +13572,7 @@
       </p:sp>
       <p:sp>
         <p:nvSpPr>
-          <p:cNvPr id="19" name="TextBox 18"/>
+          <p:cNvPr id="20" name="TextBox 19"/>
           <p:cNvSpPr txBox="1"/>
           <p:nvPr/>
         </p:nvSpPr>
@@ -13449,7 +13613,7 @@
       </p:sp>
       <p:sp>
         <p:nvSpPr>
-          <p:cNvPr id="20" name="Rounded Rectangle 19"/>
+          <p:cNvPr id="21" name="Rounded Rectangle 20"/>
           <p:cNvSpPr/>
           <p:nvPr/>
         </p:nvSpPr>
@@ -13503,7 +13667,7 @@
       </p:sp>
       <p:sp>
         <p:nvSpPr>
-          <p:cNvPr id="21" name="Rounded Rectangle 20"/>
+          <p:cNvPr id="22" name="Rounded Rectangle 21"/>
           <p:cNvSpPr/>
           <p:nvPr/>
         </p:nvSpPr>
@@ -13549,7 +13713,7 @@
       </p:sp>
       <p:sp>
         <p:nvSpPr>
-          <p:cNvPr id="22" name="TextBox 21"/>
+          <p:cNvPr id="23" name="TextBox 22"/>
           <p:cNvSpPr txBox="1"/>
           <p:nvPr/>
         </p:nvSpPr>
@@ -13623,7 +13787,7 @@
       </p:sp>
       <p:sp>
         <p:nvSpPr>
-          <p:cNvPr id="23" name="TextBox 22"/>
+          <p:cNvPr id="24" name="TextBox 23"/>
           <p:cNvSpPr txBox="1"/>
           <p:nvPr/>
         </p:nvSpPr>
@@ -13664,7 +13828,7 @@
       </p:sp>
       <p:sp>
         <p:nvSpPr>
-          <p:cNvPr id="24" name="Rounded Rectangle 23"/>
+          <p:cNvPr id="25" name="Rounded Rectangle 24"/>
           <p:cNvSpPr/>
           <p:nvPr/>
         </p:nvSpPr>
@@ -13718,7 +13882,7 @@
       </p:sp>
       <p:sp>
         <p:nvSpPr>
-          <p:cNvPr id="25" name="Rounded Rectangle 24"/>
+          <p:cNvPr id="26" name="Rounded Rectangle 25"/>
           <p:cNvSpPr/>
           <p:nvPr/>
         </p:nvSpPr>
@@ -13764,7 +13928,7 @@
       </p:sp>
       <p:sp>
         <p:nvSpPr>
-          <p:cNvPr id="26" name="TextBox 25"/>
+          <p:cNvPr id="27" name="TextBox 26"/>
           <p:cNvSpPr txBox="1"/>
           <p:nvPr/>
         </p:nvSpPr>
@@ -13838,7 +14002,7 @@
       </p:sp>
       <p:sp>
         <p:nvSpPr>
-          <p:cNvPr id="27" name="TextBox 26"/>
+          <p:cNvPr id="28" name="TextBox 27"/>
           <p:cNvSpPr txBox="1"/>
           <p:nvPr/>
         </p:nvSpPr>
@@ -13879,7 +14043,7 @@
       </p:sp>
       <p:sp>
         <p:nvSpPr>
-          <p:cNvPr id="28" name="Rounded Rectangle 27"/>
+          <p:cNvPr id="29" name="Rounded Rectangle 28"/>
           <p:cNvSpPr/>
           <p:nvPr/>
         </p:nvSpPr>
@@ -13933,7 +14097,7 @@
       </p:sp>
       <p:sp>
         <p:nvSpPr>
-          <p:cNvPr id="29" name="Rounded Rectangle 28"/>
+          <p:cNvPr id="30" name="Rounded Rectangle 29"/>
           <p:cNvSpPr/>
           <p:nvPr/>
         </p:nvSpPr>
@@ -13979,7 +14143,7 @@
       </p:sp>
       <p:sp>
         <p:nvSpPr>
-          <p:cNvPr id="30" name="TextBox 29"/>
+          <p:cNvPr id="31" name="TextBox 30"/>
           <p:cNvSpPr txBox="1"/>
           <p:nvPr/>
         </p:nvSpPr>
@@ -14042,7 +14206,7 @@
       </p:sp>
       <p:sp>
         <p:nvSpPr>
-          <p:cNvPr id="31" name="TextBox 30"/>
+          <p:cNvPr id="32" name="TextBox 31"/>
           <p:cNvSpPr txBox="1"/>
           <p:nvPr/>
         </p:nvSpPr>
@@ -14083,7 +14247,7 @@
       </p:sp>
       <p:sp>
         <p:nvSpPr>
-          <p:cNvPr id="32" name="Freeform 31"/>
+          <p:cNvPr id="33" name="Freeform 32"/>
           <p:cNvSpPr/>
           <p:nvPr/>
         </p:nvSpPr>
@@ -14141,7 +14305,7 @@
       </p:sp>
       <p:sp>
         <p:nvSpPr>
-          <p:cNvPr id="33" name="Freeform 32"/>
+          <p:cNvPr id="34" name="Freeform 33"/>
           <p:cNvSpPr/>
           <p:nvPr/>
         </p:nvSpPr>
@@ -14203,7 +14367,7 @@
       </p:sp>
       <p:sp>
         <p:nvSpPr>
-          <p:cNvPr id="34" name="TextBox 33"/>
+          <p:cNvPr id="35" name="TextBox 34"/>
           <p:cNvSpPr txBox="1"/>
           <p:nvPr/>
         </p:nvSpPr>
@@ -14244,7 +14408,7 @@
       </p:sp>
       <p:sp>
         <p:nvSpPr>
-          <p:cNvPr id="35" name="Freeform 34"/>
+          <p:cNvPr id="36" name="Freeform 35"/>
           <p:cNvSpPr/>
           <p:nvPr/>
         </p:nvSpPr>
@@ -14302,7 +14466,7 @@
       </p:sp>
       <p:sp>
         <p:nvSpPr>
-          <p:cNvPr id="36" name="Freeform 35"/>
+          <p:cNvPr id="37" name="Freeform 36"/>
           <p:cNvSpPr/>
           <p:nvPr/>
         </p:nvSpPr>
@@ -14364,7 +14528,7 @@
       </p:sp>
       <p:sp>
         <p:nvSpPr>
-          <p:cNvPr id="37" name="TextBox 36"/>
+          <p:cNvPr id="38" name="TextBox 37"/>
           <p:cNvSpPr txBox="1"/>
           <p:nvPr/>
         </p:nvSpPr>
@@ -14405,7 +14569,7 @@
       </p:sp>
       <p:sp>
         <p:nvSpPr>
-          <p:cNvPr id="38" name="Freeform 37"/>
+          <p:cNvPr id="39" name="Freeform 38"/>
           <p:cNvSpPr/>
           <p:nvPr/>
         </p:nvSpPr>
@@ -14463,7 +14627,7 @@
       </p:sp>
       <p:sp>
         <p:nvSpPr>
-          <p:cNvPr id="39" name="Freeform 38"/>
+          <p:cNvPr id="40" name="Freeform 39"/>
           <p:cNvSpPr/>
           <p:nvPr/>
         </p:nvSpPr>
@@ -14525,7 +14689,7 @@
       </p:sp>
       <p:sp>
         <p:nvSpPr>
-          <p:cNvPr id="40" name="TextBox 39"/>
+          <p:cNvPr id="41" name="TextBox 40"/>
           <p:cNvSpPr txBox="1"/>
           <p:nvPr/>
         </p:nvSpPr>
@@ -14566,7 +14730,7 @@
       </p:sp>
       <p:sp>
         <p:nvSpPr>
-          <p:cNvPr id="41" name="Freeform 40"/>
+          <p:cNvPr id="42" name="Freeform 41"/>
           <p:cNvSpPr/>
           <p:nvPr/>
         </p:nvSpPr>
@@ -14624,7 +14788,7 @@
       </p:sp>
       <p:sp>
         <p:nvSpPr>
-          <p:cNvPr id="42" name="Freeform 41"/>
+          <p:cNvPr id="43" name="Freeform 42"/>
           <p:cNvSpPr/>
           <p:nvPr/>
         </p:nvSpPr>
@@ -14686,7 +14850,7 @@
       </p:sp>
       <p:sp>
         <p:nvSpPr>
-          <p:cNvPr id="43" name="Rounded Rectangle 42"/>
+          <p:cNvPr id="44" name="Rounded Rectangle 43"/>
           <p:cNvSpPr/>
           <p:nvPr/>
         </p:nvSpPr>
@@ -14734,7 +14898,7 @@
       </p:sp>
       <p:sp>
         <p:nvSpPr>
-          <p:cNvPr id="44" name="TextBox 43"/>
+          <p:cNvPr id="45" name="TextBox 44"/>
           <p:cNvSpPr txBox="1"/>
           <p:nvPr/>
         </p:nvSpPr>
@@ -14775,7 +14939,7 @@
       </p:sp>
       <p:sp>
         <p:nvSpPr>
-          <p:cNvPr id="45" name="Rounded Rectangle 44"/>
+          <p:cNvPr id="46" name="Rounded Rectangle 45"/>
           <p:cNvSpPr/>
           <p:nvPr/>
         </p:nvSpPr>
@@ -14829,7 +14993,7 @@
       </p:sp>
       <p:sp>
         <p:nvSpPr>
-          <p:cNvPr id="46" name="Rounded Rectangle 45"/>
+          <p:cNvPr id="47" name="Rounded Rectangle 46"/>
           <p:cNvSpPr/>
           <p:nvPr/>
         </p:nvSpPr>
@@ -14875,7 +15039,7 @@
       </p:sp>
       <p:sp>
         <p:nvSpPr>
-          <p:cNvPr id="47" name="Rounded Rectangle 46"/>
+          <p:cNvPr id="48" name="Rounded Rectangle 47"/>
           <p:cNvSpPr/>
           <p:nvPr/>
         </p:nvSpPr>
@@ -14921,7 +15085,7 @@
       </p:sp>
       <p:sp>
         <p:nvSpPr>
-          <p:cNvPr id="48" name="Oval 47"/>
+          <p:cNvPr id="49" name="Oval 48"/>
           <p:cNvSpPr/>
           <p:nvPr/>
         </p:nvSpPr>
@@ -14965,7 +15129,7 @@
       </p:sp>
       <p:sp>
         <p:nvSpPr>
-          <p:cNvPr id="49" name="Oval 48"/>
+          <p:cNvPr id="50" name="Oval 49"/>
           <p:cNvSpPr/>
           <p:nvPr/>
         </p:nvSpPr>
@@ -15009,7 +15173,7 @@
       </p:sp>
       <p:sp>
         <p:nvSpPr>
-          <p:cNvPr id="50" name="Oval 49"/>
+          <p:cNvPr id="51" name="Oval 50"/>
           <p:cNvSpPr/>
           <p:nvPr/>
         </p:nvSpPr>
@@ -15053,7 +15217,7 @@
       </p:sp>
       <p:sp>
         <p:nvSpPr>
-          <p:cNvPr id="51" name="TextBox 50"/>
+          <p:cNvPr id="52" name="TextBox 51"/>
           <p:cNvSpPr txBox="1"/>
           <p:nvPr/>
         </p:nvSpPr>
@@ -15094,7 +15258,7 @@
       </p:sp>
       <p:sp>
         <p:nvSpPr>
-          <p:cNvPr id="52" name="Freeform 51"/>
+          <p:cNvPr id="53" name="Freeform 52"/>
           <p:cNvSpPr/>
           <p:nvPr/>
         </p:nvSpPr>
@@ -15152,7 +15316,7 @@
       </p:sp>
       <p:sp>
         <p:nvSpPr>
-          <p:cNvPr id="53" name="TextBox 52"/>
+          <p:cNvPr id="54" name="TextBox 53"/>
           <p:cNvSpPr txBox="1"/>
           <p:nvPr/>
         </p:nvSpPr>
@@ -15215,7 +15379,7 @@
       </p:sp>
       <p:sp>
         <p:nvSpPr>
-          <p:cNvPr id="54" name="Rounded Rectangle 53"/>
+          <p:cNvPr id="55" name="Rounded Rectangle 54"/>
           <p:cNvSpPr/>
           <p:nvPr/>
         </p:nvSpPr>
@@ -15269,7 +15433,7 @@
       </p:sp>
       <p:sp>
         <p:nvSpPr>
-          <p:cNvPr id="55" name="Rounded Rectangle 54"/>
+          <p:cNvPr id="56" name="Rounded Rectangle 55"/>
           <p:cNvSpPr/>
           <p:nvPr/>
         </p:nvSpPr>
@@ -15315,7 +15479,7 @@
       </p:sp>
       <p:sp>
         <p:nvSpPr>
-          <p:cNvPr id="56" name="Rounded Rectangle 55"/>
+          <p:cNvPr id="57" name="Rounded Rectangle 56"/>
           <p:cNvSpPr/>
           <p:nvPr/>
         </p:nvSpPr>
@@ -15361,7 +15525,7 @@
       </p:sp>
       <p:sp>
         <p:nvSpPr>
-          <p:cNvPr id="57" name="Freeform 56"/>
+          <p:cNvPr id="58" name="Freeform 57"/>
           <p:cNvSpPr/>
           <p:nvPr/>
         </p:nvSpPr>
@@ -15560,7 +15724,7 @@
       </p:sp>
       <p:sp>
         <p:nvSpPr>
-          <p:cNvPr id="58" name="Freeform 57"/>
+          <p:cNvPr id="59" name="Freeform 58"/>
           <p:cNvSpPr/>
           <p:nvPr/>
         </p:nvSpPr>
@@ -15759,7 +15923,7 @@
       </p:sp>
       <p:sp>
         <p:nvSpPr>
-          <p:cNvPr id="59" name="Freeform 58"/>
+          <p:cNvPr id="60" name="Freeform 59"/>
           <p:cNvSpPr/>
           <p:nvPr/>
         </p:nvSpPr>
@@ -15958,7 +16122,7 @@
       </p:sp>
       <p:sp>
         <p:nvSpPr>
-          <p:cNvPr id="60" name="TextBox 59"/>
+          <p:cNvPr id="61" name="TextBox 60"/>
           <p:cNvSpPr txBox="1"/>
           <p:nvPr/>
         </p:nvSpPr>
@@ -15999,7 +16163,7 @@
       </p:sp>
       <p:sp>
         <p:nvSpPr>
-          <p:cNvPr id="61" name="Freeform 60"/>
+          <p:cNvPr id="62" name="Freeform 61"/>
           <p:cNvSpPr/>
           <p:nvPr/>
         </p:nvSpPr>
@@ -16057,7 +16221,7 @@
       </p:sp>
       <p:sp>
         <p:nvSpPr>
-          <p:cNvPr id="62" name="TextBox 61"/>
+          <p:cNvPr id="63" name="TextBox 62"/>
           <p:cNvSpPr txBox="1"/>
           <p:nvPr/>
         </p:nvSpPr>
@@ -16120,7 +16284,7 @@
       </p:sp>
       <p:sp>
         <p:nvSpPr>
-          <p:cNvPr id="63" name="Rounded Rectangle 62"/>
+          <p:cNvPr id="64" name="Rounded Rectangle 63"/>
           <p:cNvSpPr/>
           <p:nvPr/>
         </p:nvSpPr>
@@ -16174,7 +16338,7 @@
       </p:sp>
       <p:sp>
         <p:nvSpPr>
-          <p:cNvPr id="64" name="Rounded Rectangle 63"/>
+          <p:cNvPr id="65" name="Rounded Rectangle 64"/>
           <p:cNvSpPr/>
           <p:nvPr/>
         </p:nvSpPr>
@@ -16220,7 +16384,7 @@
       </p:sp>
       <p:sp>
         <p:nvSpPr>
-          <p:cNvPr id="65" name="Rounded Rectangle 64"/>
+          <p:cNvPr id="66" name="Rounded Rectangle 65"/>
           <p:cNvSpPr/>
           <p:nvPr/>
         </p:nvSpPr>
@@ -16266,7 +16430,7 @@
       </p:sp>
       <p:sp>
         <p:nvSpPr>
-          <p:cNvPr id="66" name="Freeform 65"/>
+          <p:cNvPr id="67" name="Freeform 66"/>
           <p:cNvSpPr/>
           <p:nvPr/>
         </p:nvSpPr>
@@ -16465,7 +16629,7 @@
       </p:sp>
       <p:sp>
         <p:nvSpPr>
-          <p:cNvPr id="67" name="Freeform 66"/>
+          <p:cNvPr id="68" name="Freeform 67"/>
           <p:cNvSpPr/>
           <p:nvPr/>
         </p:nvSpPr>
@@ -16664,7 +16828,7 @@
       </p:sp>
       <p:sp>
         <p:nvSpPr>
-          <p:cNvPr id="68" name="Freeform 67"/>
+          <p:cNvPr id="69" name="Freeform 68"/>
           <p:cNvSpPr/>
           <p:nvPr/>
         </p:nvSpPr>
@@ -16722,7 +16886,7 @@
       </p:sp>
       <p:sp>
         <p:nvSpPr>
-          <p:cNvPr id="69" name="TextBox 68"/>
+          <p:cNvPr id="70" name="TextBox 69"/>
           <p:cNvSpPr txBox="1"/>
           <p:nvPr/>
         </p:nvSpPr>
@@ -16763,7 +16927,7 @@
       </p:sp>
       <p:sp>
         <p:nvSpPr>
-          <p:cNvPr id="70" name="Freeform 69"/>
+          <p:cNvPr id="71" name="Freeform 70"/>
           <p:cNvSpPr/>
           <p:nvPr/>
         </p:nvSpPr>
@@ -16821,7 +16985,7 @@
       </p:sp>
       <p:sp>
         <p:nvSpPr>
-          <p:cNvPr id="71" name="TextBox 70"/>
+          <p:cNvPr id="72" name="TextBox 71"/>
           <p:cNvSpPr txBox="1"/>
           <p:nvPr/>
         </p:nvSpPr>
@@ -17102,7 +17266,48 @@
       </p:sp>
       <p:sp>
         <p:nvSpPr>
-          <p:cNvPr id="6" name="Freeform 5"/>
+          <p:cNvPr id="6" name="TextBox 5"/>
+          <p:cNvSpPr txBox="1"/>
+          <p:nvPr/>
+        </p:nvSpPr>
+        <p:spPr>
+          <a:xfrm>
+            <a:off x="10312400" y="254000"/>
+            <a:ext cx="1270000" cy="558800"/>
+          </a:xfrm>
+          <a:prstGeom prst="rect">
+            <a:avLst/>
+          </a:prstGeom>
+          <a:noFill/>
+        </p:spPr>
+        <p:txBody>
+          <a:bodyPr wrap="square" lIns="0" rIns="0" tIns="0" bIns="0" anchor="t">
+            <a:noAutofit/>
+          </a:bodyPr>
+          <a:lstStyle/>
+          <a:p>
+            <a:pPr algn="r">
+              <a:lnSpc>
+                <a:spcPct val="100000"/>
+              </a:lnSpc>
+            </a:pPr>
+            <a:r>
+              <a:rPr sz="3000" b="1" i="0">
+                <a:solidFill>
+                  <a:srgbClr val="E3EAF2"/>
+                </a:solidFill>
+                <a:latin typeface="Arial"/>
+                <a:ea typeface="Microsoft YaHei"/>
+                <a:cs typeface="Arial"/>
+              </a:rPr>
+              <a:t>06</a:t>
+            </a:r>
+          </a:p>
+        </p:txBody>
+      </p:sp>
+      <p:sp>
+        <p:nvSpPr>
+          <p:cNvPr id="7" name="Freeform 6"/>
           <p:cNvSpPr/>
           <p:nvPr/>
         </p:nvSpPr>
@@ -17160,7 +17365,7 @@
       </p:sp>
       <p:sp>
         <p:nvSpPr>
-          <p:cNvPr id="7" name="Freeform 6"/>
+          <p:cNvPr id="8" name="Freeform 7"/>
           <p:cNvSpPr/>
           <p:nvPr/>
         </p:nvSpPr>
@@ -17218,7 +17423,7 @@
       </p:sp>
       <p:sp>
         <p:nvSpPr>
-          <p:cNvPr id="8" name="TextBox 7"/>
+          <p:cNvPr id="9" name="TextBox 8"/>
           <p:cNvSpPr txBox="1"/>
           <p:nvPr/>
         </p:nvSpPr>
@@ -17259,7 +17464,7 @@
       </p:sp>
       <p:sp>
         <p:nvSpPr>
-          <p:cNvPr id="9" name="TextBox 8"/>
+          <p:cNvPr id="10" name="TextBox 9"/>
           <p:cNvSpPr txBox="1"/>
           <p:nvPr/>
         </p:nvSpPr>
@@ -17300,7 +17505,7 @@
       </p:sp>
       <p:sp>
         <p:nvSpPr>
-          <p:cNvPr id="10" name="Freeform 9"/>
+          <p:cNvPr id="11" name="Freeform 10"/>
           <p:cNvSpPr/>
           <p:nvPr/>
         </p:nvSpPr>
@@ -17365,7 +17570,7 @@
       </p:sp>
       <p:sp>
         <p:nvSpPr>
-          <p:cNvPr id="11" name="TextBox 10"/>
+          <p:cNvPr id="12" name="TextBox 11"/>
           <p:cNvSpPr txBox="1"/>
           <p:nvPr/>
         </p:nvSpPr>
@@ -17406,7 +17611,7 @@
       </p:sp>
       <p:sp>
         <p:nvSpPr>
-          <p:cNvPr id="12" name="TextBox 11"/>
+          <p:cNvPr id="13" name="TextBox 12"/>
           <p:cNvSpPr txBox="1"/>
           <p:nvPr/>
         </p:nvSpPr>
@@ -17447,7 +17652,7 @@
       </p:sp>
       <p:sp>
         <p:nvSpPr>
-          <p:cNvPr id="13" name="Freeform 12"/>
+          <p:cNvPr id="14" name="Freeform 13"/>
           <p:cNvSpPr/>
           <p:nvPr/>
         </p:nvSpPr>
@@ -17506,7 +17711,7 @@
       </p:sp>
       <p:sp>
         <p:nvSpPr>
-          <p:cNvPr id="14" name="Oval 13"/>
+          <p:cNvPr id="15" name="Oval 14"/>
           <p:cNvSpPr/>
           <p:nvPr/>
         </p:nvSpPr>
@@ -17550,7 +17755,7 @@
       </p:sp>
       <p:sp>
         <p:nvSpPr>
-          <p:cNvPr id="15" name="TextBox 14"/>
+          <p:cNvPr id="16" name="TextBox 15"/>
           <p:cNvSpPr txBox="1"/>
           <p:nvPr/>
         </p:nvSpPr>
@@ -17591,7 +17796,7 @@
       </p:sp>
       <p:sp>
         <p:nvSpPr>
-          <p:cNvPr id="16" name="Rounded Rectangle 15"/>
+          <p:cNvPr id="17" name="Rounded Rectangle 16"/>
           <p:cNvSpPr/>
           <p:nvPr/>
         </p:nvSpPr>
@@ -17637,7 +17842,7 @@
       </p:sp>
       <p:sp>
         <p:nvSpPr>
-          <p:cNvPr id="17" name="TextBox 16"/>
+          <p:cNvPr id="18" name="TextBox 17"/>
           <p:cNvSpPr txBox="1"/>
           <p:nvPr/>
         </p:nvSpPr>
@@ -17678,7 +17883,7 @@
       </p:sp>
       <p:sp>
         <p:nvSpPr>
-          <p:cNvPr id="18" name="TextBox 17"/>
+          <p:cNvPr id="19" name="TextBox 18"/>
           <p:cNvSpPr txBox="1"/>
           <p:nvPr/>
         </p:nvSpPr>
@@ -17719,7 +17924,7 @@
       </p:sp>
       <p:sp>
         <p:nvSpPr>
-          <p:cNvPr id="19" name="TextBox 18"/>
+          <p:cNvPr id="20" name="TextBox 19"/>
           <p:cNvSpPr txBox="1"/>
           <p:nvPr/>
         </p:nvSpPr>
@@ -17760,7 +17965,7 @@
       </p:sp>
       <p:sp>
         <p:nvSpPr>
-          <p:cNvPr id="20" name="Freeform 19"/>
+          <p:cNvPr id="21" name="Freeform 20"/>
           <p:cNvSpPr/>
           <p:nvPr/>
         </p:nvSpPr>
@@ -17831,7 +18036,7 @@
       </p:sp>
       <p:sp>
         <p:nvSpPr>
-          <p:cNvPr id="21" name="Freeform 20"/>
+          <p:cNvPr id="22" name="Freeform 21"/>
           <p:cNvSpPr/>
           <p:nvPr/>
         </p:nvSpPr>
@@ -17896,7 +18101,7 @@
       </p:sp>
       <p:sp>
         <p:nvSpPr>
-          <p:cNvPr id="22" name="TextBox 21"/>
+          <p:cNvPr id="23" name="TextBox 22"/>
           <p:cNvSpPr txBox="1"/>
           <p:nvPr/>
         </p:nvSpPr>
@@ -17937,7 +18142,7 @@
       </p:sp>
       <p:sp>
         <p:nvSpPr>
-          <p:cNvPr id="23" name="TextBox 22"/>
+          <p:cNvPr id="24" name="TextBox 23"/>
           <p:cNvSpPr txBox="1"/>
           <p:nvPr/>
         </p:nvSpPr>
@@ -17978,7 +18183,7 @@
       </p:sp>
       <p:sp>
         <p:nvSpPr>
-          <p:cNvPr id="24" name="Freeform 23"/>
+          <p:cNvPr id="25" name="Freeform 24"/>
           <p:cNvSpPr/>
           <p:nvPr/>
         </p:nvSpPr>
@@ -18037,7 +18242,7 @@
       </p:sp>
       <p:sp>
         <p:nvSpPr>
-          <p:cNvPr id="25" name="Oval 24"/>
+          <p:cNvPr id="26" name="Oval 25"/>
           <p:cNvSpPr/>
           <p:nvPr/>
         </p:nvSpPr>
@@ -18081,7 +18286,7 @@
       </p:sp>
       <p:sp>
         <p:nvSpPr>
-          <p:cNvPr id="26" name="TextBox 25"/>
+          <p:cNvPr id="27" name="TextBox 26"/>
           <p:cNvSpPr txBox="1"/>
           <p:nvPr/>
         </p:nvSpPr>
@@ -18122,7 +18327,7 @@
       </p:sp>
       <p:sp>
         <p:nvSpPr>
-          <p:cNvPr id="27" name="Rounded Rectangle 26"/>
+          <p:cNvPr id="28" name="Rounded Rectangle 27"/>
           <p:cNvSpPr/>
           <p:nvPr/>
         </p:nvSpPr>
@@ -18168,7 +18373,7 @@
       </p:sp>
       <p:sp>
         <p:nvSpPr>
-          <p:cNvPr id="28" name="TextBox 27"/>
+          <p:cNvPr id="29" name="TextBox 28"/>
           <p:cNvSpPr txBox="1"/>
           <p:nvPr/>
         </p:nvSpPr>
@@ -18209,7 +18414,7 @@
       </p:sp>
       <p:sp>
         <p:nvSpPr>
-          <p:cNvPr id="29" name="TextBox 28"/>
+          <p:cNvPr id="30" name="TextBox 29"/>
           <p:cNvSpPr txBox="1"/>
           <p:nvPr/>
         </p:nvSpPr>
@@ -18250,7 +18455,7 @@
       </p:sp>
       <p:sp>
         <p:nvSpPr>
-          <p:cNvPr id="30" name="TextBox 29"/>
+          <p:cNvPr id="31" name="TextBox 30"/>
           <p:cNvSpPr txBox="1"/>
           <p:nvPr/>
         </p:nvSpPr>
@@ -18291,7 +18496,7 @@
       </p:sp>
       <p:sp>
         <p:nvSpPr>
-          <p:cNvPr id="31" name="Freeform 30"/>
+          <p:cNvPr id="32" name="Freeform 31"/>
           <p:cNvSpPr/>
           <p:nvPr/>
         </p:nvSpPr>
@@ -18356,7 +18561,7 @@
       </p:sp>
       <p:sp>
         <p:nvSpPr>
-          <p:cNvPr id="32" name="TextBox 31"/>
+          <p:cNvPr id="33" name="TextBox 32"/>
           <p:cNvSpPr txBox="1"/>
           <p:nvPr/>
         </p:nvSpPr>
@@ -18397,7 +18602,7 @@
       </p:sp>
       <p:sp>
         <p:nvSpPr>
-          <p:cNvPr id="33" name="TextBox 32"/>
+          <p:cNvPr id="34" name="TextBox 33"/>
           <p:cNvSpPr txBox="1"/>
           <p:nvPr/>
         </p:nvSpPr>
@@ -18438,7 +18643,7 @@
       </p:sp>
       <p:sp>
         <p:nvSpPr>
-          <p:cNvPr id="34" name="TextBox 33"/>
+          <p:cNvPr id="35" name="TextBox 34"/>
           <p:cNvSpPr txBox="1"/>
           <p:nvPr/>
         </p:nvSpPr>
@@ -18479,7 +18684,7 @@
       </p:sp>
       <p:sp>
         <p:nvSpPr>
-          <p:cNvPr id="35" name="Freeform 34"/>
+          <p:cNvPr id="36" name="Freeform 35"/>
           <p:cNvSpPr/>
           <p:nvPr/>
         </p:nvSpPr>
@@ -18538,7 +18743,7 @@
       </p:sp>
       <p:sp>
         <p:nvSpPr>
-          <p:cNvPr id="36" name="Oval 35"/>
+          <p:cNvPr id="37" name="Oval 36"/>
           <p:cNvSpPr/>
           <p:nvPr/>
         </p:nvSpPr>
@@ -18582,7 +18787,7 @@
       </p:sp>
       <p:sp>
         <p:nvSpPr>
-          <p:cNvPr id="37" name="TextBox 36"/>
+          <p:cNvPr id="38" name="TextBox 37"/>
           <p:cNvSpPr txBox="1"/>
           <p:nvPr/>
         </p:nvSpPr>
@@ -18623,7 +18828,7 @@
       </p:sp>
       <p:sp>
         <p:nvSpPr>
-          <p:cNvPr id="38" name="Rounded Rectangle 37"/>
+          <p:cNvPr id="39" name="Rounded Rectangle 38"/>
           <p:cNvSpPr/>
           <p:nvPr/>
         </p:nvSpPr>
@@ -18669,7 +18874,7 @@
       </p:sp>
       <p:sp>
         <p:nvSpPr>
-          <p:cNvPr id="39" name="TextBox 38"/>
+          <p:cNvPr id="40" name="TextBox 39"/>
           <p:cNvSpPr txBox="1"/>
           <p:nvPr/>
         </p:nvSpPr>
@@ -18710,7 +18915,7 @@
       </p:sp>
       <p:sp>
         <p:nvSpPr>
-          <p:cNvPr id="40" name="TextBox 39"/>
+          <p:cNvPr id="41" name="TextBox 40"/>
           <p:cNvSpPr txBox="1"/>
           <p:nvPr/>
         </p:nvSpPr>
@@ -18751,7 +18956,7 @@
       </p:sp>
       <p:sp>
         <p:nvSpPr>
-          <p:cNvPr id="41" name="Freeform 40"/>
+          <p:cNvPr id="42" name="Freeform 41"/>
           <p:cNvSpPr/>
           <p:nvPr/>
         </p:nvSpPr>
@@ -18816,7 +19021,7 @@
       </p:sp>
       <p:sp>
         <p:nvSpPr>
-          <p:cNvPr id="42" name="TextBox 41"/>
+          <p:cNvPr id="43" name="TextBox 42"/>
           <p:cNvSpPr txBox="1"/>
           <p:nvPr/>
         </p:nvSpPr>
@@ -18857,7 +19062,7 @@
       </p:sp>
       <p:sp>
         <p:nvSpPr>
-          <p:cNvPr id="43" name="TextBox 42"/>
+          <p:cNvPr id="44" name="TextBox 43"/>
           <p:cNvSpPr txBox="1"/>
           <p:nvPr/>
         </p:nvSpPr>
@@ -18898,7 +19103,7 @@
       </p:sp>
       <p:sp>
         <p:nvSpPr>
-          <p:cNvPr id="44" name="TextBox 43"/>
+          <p:cNvPr id="45" name="TextBox 44"/>
           <p:cNvSpPr txBox="1"/>
           <p:nvPr/>
         </p:nvSpPr>
@@ -18939,7 +19144,7 @@
       </p:sp>
       <p:sp>
         <p:nvSpPr>
-          <p:cNvPr id="45" name="Freeform 44"/>
+          <p:cNvPr id="46" name="Freeform 45"/>
           <p:cNvSpPr/>
           <p:nvPr/>
         </p:nvSpPr>
@@ -18998,7 +19203,7 @@
       </p:sp>
       <p:sp>
         <p:nvSpPr>
-          <p:cNvPr id="46" name="Oval 45"/>
+          <p:cNvPr id="47" name="Oval 46"/>
           <p:cNvSpPr/>
           <p:nvPr/>
         </p:nvSpPr>
@@ -19042,7 +19247,7 @@
       </p:sp>
       <p:sp>
         <p:nvSpPr>
-          <p:cNvPr id="47" name="TextBox 46"/>
+          <p:cNvPr id="48" name="TextBox 47"/>
           <p:cNvSpPr txBox="1"/>
           <p:nvPr/>
         </p:nvSpPr>
@@ -19083,7 +19288,7 @@
       </p:sp>
       <p:sp>
         <p:nvSpPr>
-          <p:cNvPr id="48" name="Rounded Rectangle 47"/>
+          <p:cNvPr id="49" name="Rounded Rectangle 48"/>
           <p:cNvSpPr/>
           <p:nvPr/>
         </p:nvSpPr>
@@ -19129,7 +19334,7 @@
       </p:sp>
       <p:sp>
         <p:nvSpPr>
-          <p:cNvPr id="49" name="TextBox 48"/>
+          <p:cNvPr id="50" name="TextBox 49"/>
           <p:cNvSpPr txBox="1"/>
           <p:nvPr/>
         </p:nvSpPr>
@@ -19170,7 +19375,7 @@
       </p:sp>
       <p:sp>
         <p:nvSpPr>
-          <p:cNvPr id="50" name="TextBox 49"/>
+          <p:cNvPr id="51" name="TextBox 50"/>
           <p:cNvSpPr txBox="1"/>
           <p:nvPr/>
         </p:nvSpPr>
@@ -19211,7 +19416,7 @@
       </p:sp>
       <p:sp>
         <p:nvSpPr>
-          <p:cNvPr id="51" name="TextBox 50"/>
+          <p:cNvPr id="52" name="TextBox 51"/>
           <p:cNvSpPr txBox="1"/>
           <p:nvPr/>
         </p:nvSpPr>
@@ -19448,7 +19653,48 @@
       </p:sp>
       <p:sp>
         <p:nvSpPr>
-          <p:cNvPr id="6" name="Freeform 5"/>
+          <p:cNvPr id="6" name="TextBox 5"/>
+          <p:cNvSpPr txBox="1"/>
+          <p:nvPr/>
+        </p:nvSpPr>
+        <p:spPr>
+          <a:xfrm>
+            <a:off x="10312400" y="254000"/>
+            <a:ext cx="1270000" cy="558800"/>
+          </a:xfrm>
+          <a:prstGeom prst="rect">
+            <a:avLst/>
+          </a:prstGeom>
+          <a:noFill/>
+        </p:spPr>
+        <p:txBody>
+          <a:bodyPr wrap="square" lIns="0" rIns="0" tIns="0" bIns="0" anchor="t">
+            <a:noAutofit/>
+          </a:bodyPr>
+          <a:lstStyle/>
+          <a:p>
+            <a:pPr algn="r">
+              <a:lnSpc>
+                <a:spcPct val="100000"/>
+              </a:lnSpc>
+            </a:pPr>
+            <a:r>
+              <a:rPr sz="3000" b="1" i="0">
+                <a:solidFill>
+                  <a:srgbClr val="E3EAF2"/>
+                </a:solidFill>
+                <a:latin typeface="Arial"/>
+                <a:ea typeface="Microsoft YaHei"/>
+                <a:cs typeface="Arial"/>
+              </a:rPr>
+              <a:t>07</a:t>
+            </a:r>
+          </a:p>
+        </p:txBody>
+      </p:sp>
+      <p:sp>
+        <p:nvSpPr>
+          <p:cNvPr id="7" name="Freeform 6"/>
           <p:cNvSpPr/>
           <p:nvPr/>
         </p:nvSpPr>
@@ -19506,7 +19752,7 @@
       </p:sp>
       <p:sp>
         <p:nvSpPr>
-          <p:cNvPr id="7" name="Freeform 6"/>
+          <p:cNvPr id="8" name="Freeform 7"/>
           <p:cNvSpPr/>
           <p:nvPr/>
         </p:nvSpPr>
@@ -19564,7 +19810,7 @@
       </p:sp>
       <p:sp>
         <p:nvSpPr>
-          <p:cNvPr id="8" name="TextBox 7"/>
+          <p:cNvPr id="9" name="TextBox 8"/>
           <p:cNvSpPr txBox="1"/>
           <p:nvPr/>
         </p:nvSpPr>
@@ -19605,7 +19851,7 @@
       </p:sp>
       <p:sp>
         <p:nvSpPr>
-          <p:cNvPr id="9" name="TextBox 8"/>
+          <p:cNvPr id="10" name="TextBox 9"/>
           <p:cNvSpPr txBox="1"/>
           <p:nvPr/>
         </p:nvSpPr>
@@ -19646,7 +19892,7 @@
       </p:sp>
       <p:sp>
         <p:nvSpPr>
-          <p:cNvPr id="10" name="Rounded Rectangle 9"/>
+          <p:cNvPr id="11" name="Rounded Rectangle 10"/>
           <p:cNvSpPr/>
           <p:nvPr/>
         </p:nvSpPr>
@@ -19694,7 +19940,7 @@
       </p:sp>
       <p:sp>
         <p:nvSpPr>
-          <p:cNvPr id="11" name="Rounded Rectangle 10"/>
+          <p:cNvPr id="12" name="Rounded Rectangle 11"/>
           <p:cNvSpPr/>
           <p:nvPr/>
         </p:nvSpPr>
@@ -19740,7 +19986,7 @@
       </p:sp>
       <p:sp>
         <p:nvSpPr>
-          <p:cNvPr id="12" name="TextBox 11"/>
+          <p:cNvPr id="13" name="TextBox 12"/>
           <p:cNvSpPr txBox="1"/>
           <p:nvPr/>
         </p:nvSpPr>
@@ -19814,7 +20060,7 @@
       </p:sp>
       <p:sp>
         <p:nvSpPr>
-          <p:cNvPr id="13" name="Rounded Rectangle 12"/>
+          <p:cNvPr id="14" name="Rounded Rectangle 13"/>
           <p:cNvSpPr/>
           <p:nvPr/>
         </p:nvSpPr>
@@ -19868,7 +20114,7 @@
       </p:sp>
       <p:sp>
         <p:nvSpPr>
-          <p:cNvPr id="14" name="Rounded Rectangle 13"/>
+          <p:cNvPr id="15" name="Rounded Rectangle 14"/>
           <p:cNvSpPr/>
           <p:nvPr/>
         </p:nvSpPr>
@@ -19914,7 +20160,7 @@
       </p:sp>
       <p:sp>
         <p:nvSpPr>
-          <p:cNvPr id="15" name="Rounded Rectangle 14"/>
+          <p:cNvPr id="16" name="Rounded Rectangle 15"/>
           <p:cNvSpPr/>
           <p:nvPr/>
         </p:nvSpPr>
@@ -19960,7 +20206,7 @@
       </p:sp>
       <p:sp>
         <p:nvSpPr>
-          <p:cNvPr id="16" name="Freeform 15"/>
+          <p:cNvPr id="17" name="Freeform 16"/>
           <p:cNvSpPr/>
           <p:nvPr/>
         </p:nvSpPr>
@@ -20030,7 +20276,7 @@
       </p:sp>
       <p:sp>
         <p:nvSpPr>
-          <p:cNvPr id="17" name="Freeform 16"/>
+          <p:cNvPr id="18" name="Freeform 17"/>
           <p:cNvSpPr/>
           <p:nvPr/>
         </p:nvSpPr>
@@ -20088,7 +20334,7 @@
       </p:sp>
       <p:sp>
         <p:nvSpPr>
-          <p:cNvPr id="18" name="Freeform 17"/>
+          <p:cNvPr id="19" name="Freeform 18"/>
           <p:cNvSpPr/>
           <p:nvPr/>
         </p:nvSpPr>
@@ -20146,7 +20392,7 @@
       </p:sp>
       <p:sp>
         <p:nvSpPr>
-          <p:cNvPr id="19" name="Oval 18"/>
+          <p:cNvPr id="20" name="Oval 19"/>
           <p:cNvSpPr/>
           <p:nvPr/>
         </p:nvSpPr>
@@ -20190,7 +20436,7 @@
       </p:sp>
       <p:sp>
         <p:nvSpPr>
-          <p:cNvPr id="20" name="TextBox 19"/>
+          <p:cNvPr id="21" name="TextBox 20"/>
           <p:cNvSpPr txBox="1"/>
           <p:nvPr/>
         </p:nvSpPr>
@@ -20231,7 +20477,7 @@
       </p:sp>
       <p:sp>
         <p:nvSpPr>
-          <p:cNvPr id="21" name="Rounded Rectangle 20"/>
+          <p:cNvPr id="22" name="Rounded Rectangle 21"/>
           <p:cNvSpPr/>
           <p:nvPr/>
         </p:nvSpPr>
@@ -20277,7 +20523,7 @@
       </p:sp>
       <p:sp>
         <p:nvSpPr>
-          <p:cNvPr id="22" name="TextBox 21"/>
+          <p:cNvPr id="23" name="TextBox 22"/>
           <p:cNvSpPr txBox="1"/>
           <p:nvPr/>
         </p:nvSpPr>
@@ -20318,7 +20564,7 @@
       </p:sp>
       <p:sp>
         <p:nvSpPr>
-          <p:cNvPr id="23" name="TextBox 22"/>
+          <p:cNvPr id="24" name="TextBox 23"/>
           <p:cNvSpPr txBox="1"/>
           <p:nvPr/>
         </p:nvSpPr>
@@ -20408,7 +20654,7 @@
       </p:sp>
       <p:sp>
         <p:nvSpPr>
-          <p:cNvPr id="24" name="Rounded Rectangle 23"/>
+          <p:cNvPr id="25" name="Rounded Rectangle 24"/>
           <p:cNvSpPr/>
           <p:nvPr/>
         </p:nvSpPr>
@@ -20462,7 +20708,7 @@
       </p:sp>
       <p:sp>
         <p:nvSpPr>
-          <p:cNvPr id="25" name="Rounded Rectangle 24"/>
+          <p:cNvPr id="26" name="Rounded Rectangle 25"/>
           <p:cNvSpPr/>
           <p:nvPr/>
         </p:nvSpPr>
@@ -20508,7 +20754,7 @@
       </p:sp>
       <p:sp>
         <p:nvSpPr>
-          <p:cNvPr id="26" name="Rounded Rectangle 25"/>
+          <p:cNvPr id="27" name="Rounded Rectangle 26"/>
           <p:cNvSpPr/>
           <p:nvPr/>
         </p:nvSpPr>
@@ -20554,7 +20800,7 @@
       </p:sp>
       <p:sp>
         <p:nvSpPr>
-          <p:cNvPr id="27" name="Freeform 26"/>
+          <p:cNvPr id="28" name="Freeform 27"/>
           <p:cNvSpPr/>
           <p:nvPr/>
         </p:nvSpPr>
@@ -20627,7 +20873,7 @@
       </p:sp>
       <p:sp>
         <p:nvSpPr>
-          <p:cNvPr id="28" name="Oval 27"/>
+          <p:cNvPr id="29" name="Oval 28"/>
           <p:cNvSpPr/>
           <p:nvPr/>
         </p:nvSpPr>
@@ -20671,7 +20917,7 @@
       </p:sp>
       <p:sp>
         <p:nvSpPr>
-          <p:cNvPr id="29" name="TextBox 28"/>
+          <p:cNvPr id="30" name="TextBox 29"/>
           <p:cNvSpPr txBox="1"/>
           <p:nvPr/>
         </p:nvSpPr>
@@ -20712,7 +20958,7 @@
       </p:sp>
       <p:sp>
         <p:nvSpPr>
-          <p:cNvPr id="30" name="Rounded Rectangle 29"/>
+          <p:cNvPr id="31" name="Rounded Rectangle 30"/>
           <p:cNvSpPr/>
           <p:nvPr/>
         </p:nvSpPr>
@@ -20758,7 +21004,7 @@
       </p:sp>
       <p:sp>
         <p:nvSpPr>
-          <p:cNvPr id="31" name="TextBox 30"/>
+          <p:cNvPr id="32" name="TextBox 31"/>
           <p:cNvSpPr txBox="1"/>
           <p:nvPr/>
         </p:nvSpPr>
@@ -20799,7 +21045,7 @@
       </p:sp>
       <p:sp>
         <p:nvSpPr>
-          <p:cNvPr id="32" name="TextBox 31"/>
+          <p:cNvPr id="33" name="TextBox 32"/>
           <p:cNvSpPr txBox="1"/>
           <p:nvPr/>
         </p:nvSpPr>
@@ -20937,7 +21183,7 @@
       </p:sp>
       <p:sp>
         <p:nvSpPr>
-          <p:cNvPr id="33" name="Rounded Rectangle 32"/>
+          <p:cNvPr id="34" name="Rounded Rectangle 33"/>
           <p:cNvSpPr/>
           <p:nvPr/>
         </p:nvSpPr>
@@ -20991,7 +21237,7 @@
       </p:sp>
       <p:sp>
         <p:nvSpPr>
-          <p:cNvPr id="34" name="Rounded Rectangle 33"/>
+          <p:cNvPr id="35" name="Rounded Rectangle 34"/>
           <p:cNvSpPr/>
           <p:nvPr/>
         </p:nvSpPr>
@@ -21037,7 +21283,7 @@
       </p:sp>
       <p:sp>
         <p:nvSpPr>
-          <p:cNvPr id="35" name="Rounded Rectangle 34"/>
+          <p:cNvPr id="36" name="Rounded Rectangle 35"/>
           <p:cNvSpPr/>
           <p:nvPr/>
         </p:nvSpPr>
@@ -21083,7 +21329,7 @@
       </p:sp>
       <p:sp>
         <p:nvSpPr>
-          <p:cNvPr id="36" name="Rounded Rectangle 35"/>
+          <p:cNvPr id="37" name="Rounded Rectangle 36"/>
           <p:cNvSpPr/>
           <p:nvPr/>
         </p:nvSpPr>
@@ -21129,7 +21375,7 @@
       </p:sp>
       <p:sp>
         <p:nvSpPr>
-          <p:cNvPr id="37" name="Oval 36"/>
+          <p:cNvPr id="38" name="Oval 37"/>
           <p:cNvSpPr/>
           <p:nvPr/>
         </p:nvSpPr>
@@ -21173,7 +21419,7 @@
       </p:sp>
       <p:sp>
         <p:nvSpPr>
-          <p:cNvPr id="38" name="Freeform 37"/>
+          <p:cNvPr id="39" name="Freeform 38"/>
           <p:cNvSpPr/>
           <p:nvPr/>
         </p:nvSpPr>
@@ -21231,7 +21477,7 @@
       </p:sp>
       <p:sp>
         <p:nvSpPr>
-          <p:cNvPr id="39" name="Freeform 38"/>
+          <p:cNvPr id="40" name="Freeform 39"/>
           <p:cNvSpPr/>
           <p:nvPr/>
         </p:nvSpPr>
@@ -21289,7 +21535,7 @@
       </p:sp>
       <p:sp>
         <p:nvSpPr>
-          <p:cNvPr id="40" name="Freeform 39"/>
+          <p:cNvPr id="41" name="Freeform 40"/>
           <p:cNvSpPr/>
           <p:nvPr/>
         </p:nvSpPr>
@@ -21347,7 +21593,7 @@
       </p:sp>
       <p:sp>
         <p:nvSpPr>
-          <p:cNvPr id="41" name="Freeform 40"/>
+          <p:cNvPr id="42" name="Freeform 41"/>
           <p:cNvSpPr/>
           <p:nvPr/>
         </p:nvSpPr>
@@ -21405,7 +21651,7 @@
       </p:sp>
       <p:sp>
         <p:nvSpPr>
-          <p:cNvPr id="42" name="TextBox 41"/>
+          <p:cNvPr id="43" name="TextBox 42"/>
           <p:cNvSpPr txBox="1"/>
           <p:nvPr/>
         </p:nvSpPr>
@@ -21446,7 +21692,7 @@
       </p:sp>
       <p:sp>
         <p:nvSpPr>
-          <p:cNvPr id="43" name="Rounded Rectangle 42"/>
+          <p:cNvPr id="44" name="Rounded Rectangle 43"/>
           <p:cNvSpPr/>
           <p:nvPr/>
         </p:nvSpPr>
@@ -21492,7 +21738,7 @@
       </p:sp>
       <p:sp>
         <p:nvSpPr>
-          <p:cNvPr id="44" name="TextBox 43"/>
+          <p:cNvPr id="45" name="TextBox 44"/>
           <p:cNvSpPr txBox="1"/>
           <p:nvPr/>
         </p:nvSpPr>
@@ -21533,7 +21779,7 @@
       </p:sp>
       <p:sp>
         <p:nvSpPr>
-          <p:cNvPr id="45" name="TextBox 44"/>
+          <p:cNvPr id="46" name="TextBox 45"/>
           <p:cNvSpPr txBox="1"/>
           <p:nvPr/>
         </p:nvSpPr>
@@ -21612,7 +21858,7 @@
       </p:sp>
       <p:sp>
         <p:nvSpPr>
-          <p:cNvPr id="46" name="Rounded Rectangle 45"/>
+          <p:cNvPr id="47" name="Rounded Rectangle 46"/>
           <p:cNvSpPr/>
           <p:nvPr/>
         </p:nvSpPr>
@@ -21666,7 +21912,7 @@
       </p:sp>
       <p:sp>
         <p:nvSpPr>
-          <p:cNvPr id="47" name="TextBox 46"/>
+          <p:cNvPr id="48" name="TextBox 47"/>
           <p:cNvSpPr txBox="1"/>
           <p:nvPr/>
         </p:nvSpPr>
@@ -21707,7 +21953,7 @@
       </p:sp>
       <p:sp>
         <p:nvSpPr>
-          <p:cNvPr id="48" name="TextBox 47"/>
+          <p:cNvPr id="49" name="TextBox 48"/>
           <p:cNvSpPr txBox="1"/>
           <p:nvPr/>
         </p:nvSpPr>
@@ -21748,7 +21994,7 @@
       </p:sp>
       <p:sp>
         <p:nvSpPr>
-          <p:cNvPr id="49" name="Rounded Rectangle 48"/>
+          <p:cNvPr id="50" name="Rounded Rectangle 49"/>
           <p:cNvSpPr/>
           <p:nvPr/>
         </p:nvSpPr>
@@ -21796,7 +22042,7 @@
       </p:sp>
       <p:sp>
         <p:nvSpPr>
-          <p:cNvPr id="50" name="TextBox 49"/>
+          <p:cNvPr id="51" name="TextBox 50"/>
           <p:cNvSpPr txBox="1"/>
           <p:nvPr/>
         </p:nvSpPr>
@@ -21870,7 +22116,7 @@
       </p:sp>
       <p:sp>
         <p:nvSpPr>
-          <p:cNvPr id="51" name="TextBox 50"/>
+          <p:cNvPr id="52" name="TextBox 51"/>
           <p:cNvSpPr txBox="1"/>
           <p:nvPr/>
         </p:nvSpPr>
@@ -21911,7 +22157,7 @@
       </p:sp>
       <p:sp>
         <p:nvSpPr>
-          <p:cNvPr id="52" name="TextBox 51"/>
+          <p:cNvPr id="53" name="TextBox 52"/>
           <p:cNvSpPr txBox="1"/>
           <p:nvPr/>
         </p:nvSpPr>
@@ -21952,7 +22198,7 @@
       </p:sp>
       <p:sp>
         <p:nvSpPr>
-          <p:cNvPr id="53" name="Freeform 52"/>
+          <p:cNvPr id="54" name="Freeform 53"/>
           <p:cNvSpPr/>
           <p:nvPr/>
         </p:nvSpPr>
@@ -22010,7 +22256,7 @@
       </p:sp>
       <p:sp>
         <p:nvSpPr>
-          <p:cNvPr id="54" name="Oval 53"/>
+          <p:cNvPr id="55" name="Oval 54"/>
           <p:cNvSpPr/>
           <p:nvPr/>
         </p:nvSpPr>
@@ -22054,7 +22300,7 @@
       </p:sp>
       <p:sp>
         <p:nvSpPr>
-          <p:cNvPr id="55" name="Freeform 54"/>
+          <p:cNvPr id="56" name="Freeform 55"/>
           <p:cNvSpPr/>
           <p:nvPr/>
         </p:nvSpPr>
@@ -22112,7 +22358,7 @@
       </p:sp>
       <p:sp>
         <p:nvSpPr>
-          <p:cNvPr id="56" name="Freeform 55"/>
+          <p:cNvPr id="57" name="Freeform 56"/>
           <p:cNvSpPr/>
           <p:nvPr/>
         </p:nvSpPr>
@@ -22174,7 +22420,7 @@
       </p:sp>
       <p:sp>
         <p:nvSpPr>
-          <p:cNvPr id="57" name="Rounded Rectangle 56"/>
+          <p:cNvPr id="58" name="Rounded Rectangle 57"/>
           <p:cNvSpPr/>
           <p:nvPr/>
         </p:nvSpPr>
@@ -22222,7 +22468,7 @@
       </p:sp>
       <p:sp>
         <p:nvSpPr>
-          <p:cNvPr id="58" name="Rounded Rectangle 57"/>
+          <p:cNvPr id="59" name="Rounded Rectangle 58"/>
           <p:cNvSpPr/>
           <p:nvPr/>
         </p:nvSpPr>
@@ -22268,7 +22514,7 @@
       </p:sp>
       <p:sp>
         <p:nvSpPr>
-          <p:cNvPr id="59" name="TextBox 58"/>
+          <p:cNvPr id="60" name="TextBox 59"/>
           <p:cNvSpPr txBox="1"/>
           <p:nvPr/>
         </p:nvSpPr>
@@ -22309,7 +22555,7 @@
       </p:sp>
       <p:sp>
         <p:nvSpPr>
-          <p:cNvPr id="60" name="Freeform 59"/>
+          <p:cNvPr id="61" name="Freeform 60"/>
           <p:cNvSpPr/>
           <p:nvPr/>
         </p:nvSpPr>
@@ -22367,7 +22613,7 @@
       </p:sp>
       <p:sp>
         <p:nvSpPr>
-          <p:cNvPr id="61" name="TextBox 60"/>
+          <p:cNvPr id="62" name="TextBox 61"/>
           <p:cNvSpPr txBox="1"/>
           <p:nvPr/>
         </p:nvSpPr>
@@ -22408,7 +22654,7 @@
       </p:sp>
       <p:sp>
         <p:nvSpPr>
-          <p:cNvPr id="62" name="Freeform 61"/>
+          <p:cNvPr id="63" name="Freeform 62"/>
           <p:cNvSpPr/>
           <p:nvPr/>
         </p:nvSpPr>
@@ -22466,7 +22712,7 @@
       </p:sp>
       <p:sp>
         <p:nvSpPr>
-          <p:cNvPr id="63" name="Freeform 62"/>
+          <p:cNvPr id="64" name="Freeform 63"/>
           <p:cNvSpPr/>
           <p:nvPr/>
         </p:nvSpPr>
@@ -22528,7 +22774,7 @@
       </p:sp>
       <p:sp>
         <p:nvSpPr>
-          <p:cNvPr id="64" name="Rounded Rectangle 63"/>
+          <p:cNvPr id="65" name="Rounded Rectangle 64"/>
           <p:cNvSpPr/>
           <p:nvPr/>
         </p:nvSpPr>
@@ -22576,7 +22822,7 @@
       </p:sp>
       <p:sp>
         <p:nvSpPr>
-          <p:cNvPr id="65" name="Rounded Rectangle 64"/>
+          <p:cNvPr id="66" name="Rounded Rectangle 65"/>
           <p:cNvSpPr/>
           <p:nvPr/>
         </p:nvSpPr>
@@ -22622,7 +22868,7 @@
       </p:sp>
       <p:sp>
         <p:nvSpPr>
-          <p:cNvPr id="66" name="TextBox 65"/>
+          <p:cNvPr id="67" name="TextBox 66"/>
           <p:cNvSpPr txBox="1"/>
           <p:nvPr/>
         </p:nvSpPr>
@@ -22663,7 +22909,7 @@
       </p:sp>
       <p:sp>
         <p:nvSpPr>
-          <p:cNvPr id="67" name="Freeform 66"/>
+          <p:cNvPr id="68" name="Freeform 67"/>
           <p:cNvSpPr/>
           <p:nvPr/>
         </p:nvSpPr>
@@ -22721,7 +22967,7 @@
       </p:sp>
       <p:sp>
         <p:nvSpPr>
-          <p:cNvPr id="68" name="TextBox 67"/>
+          <p:cNvPr id="69" name="TextBox 68"/>
           <p:cNvSpPr txBox="1"/>
           <p:nvPr/>
         </p:nvSpPr>
@@ -22828,7 +23074,7 @@
       </p:sp>
       <p:sp>
         <p:nvSpPr>
-          <p:cNvPr id="69" name="Freeform 68"/>
+          <p:cNvPr id="70" name="Freeform 69"/>
           <p:cNvSpPr/>
           <p:nvPr/>
         </p:nvSpPr>
@@ -22886,7 +23132,7 @@
       </p:sp>
       <p:sp>
         <p:nvSpPr>
-          <p:cNvPr id="70" name="Freeform 69"/>
+          <p:cNvPr id="71" name="Freeform 70"/>
           <p:cNvSpPr/>
           <p:nvPr/>
         </p:nvSpPr>
@@ -22948,7 +23194,7 @@
       </p:sp>
       <p:sp>
         <p:nvSpPr>
-          <p:cNvPr id="71" name="Rounded Rectangle 70"/>
+          <p:cNvPr id="72" name="Rounded Rectangle 71"/>
           <p:cNvSpPr/>
           <p:nvPr/>
         </p:nvSpPr>
@@ -22996,7 +23242,7 @@
       </p:sp>
       <p:sp>
         <p:nvSpPr>
-          <p:cNvPr id="72" name="Rounded Rectangle 71"/>
+          <p:cNvPr id="73" name="Rounded Rectangle 72"/>
           <p:cNvSpPr/>
           <p:nvPr/>
         </p:nvSpPr>
@@ -23042,7 +23288,7 @@
       </p:sp>
       <p:sp>
         <p:nvSpPr>
-          <p:cNvPr id="73" name="TextBox 72"/>
+          <p:cNvPr id="74" name="TextBox 73"/>
           <p:cNvSpPr txBox="1"/>
           <p:nvPr/>
         </p:nvSpPr>
@@ -23083,7 +23329,7 @@
       </p:sp>
       <p:sp>
         <p:nvSpPr>
-          <p:cNvPr id="74" name="Freeform 73"/>
+          <p:cNvPr id="75" name="Freeform 74"/>
           <p:cNvSpPr/>
           <p:nvPr/>
         </p:nvSpPr>
@@ -23141,7 +23387,7 @@
       </p:sp>
       <p:sp>
         <p:nvSpPr>
-          <p:cNvPr id="75" name="TextBox 74"/>
+          <p:cNvPr id="76" name="TextBox 75"/>
           <p:cNvSpPr txBox="1"/>
           <p:nvPr/>
         </p:nvSpPr>
@@ -23400,7 +23646,48 @@
       </p:sp>
       <p:sp>
         <p:nvSpPr>
-          <p:cNvPr id="6" name="Freeform 5"/>
+          <p:cNvPr id="6" name="TextBox 5"/>
+          <p:cNvSpPr txBox="1"/>
+          <p:nvPr/>
+        </p:nvSpPr>
+        <p:spPr>
+          <a:xfrm>
+            <a:off x="10312400" y="254000"/>
+            <a:ext cx="1270000" cy="558800"/>
+          </a:xfrm>
+          <a:prstGeom prst="rect">
+            <a:avLst/>
+          </a:prstGeom>
+          <a:noFill/>
+        </p:spPr>
+        <p:txBody>
+          <a:bodyPr wrap="square" lIns="0" rIns="0" tIns="0" bIns="0" anchor="t">
+            <a:noAutofit/>
+          </a:bodyPr>
+          <a:lstStyle/>
+          <a:p>
+            <a:pPr algn="r">
+              <a:lnSpc>
+                <a:spcPct val="100000"/>
+              </a:lnSpc>
+            </a:pPr>
+            <a:r>
+              <a:rPr sz="3000" b="1" i="0">
+                <a:solidFill>
+                  <a:srgbClr val="E3EAF2"/>
+                </a:solidFill>
+                <a:latin typeface="Arial"/>
+                <a:ea typeface="Microsoft YaHei"/>
+                <a:cs typeface="Arial"/>
+              </a:rPr>
+              <a:t>08</a:t>
+            </a:r>
+          </a:p>
+        </p:txBody>
+      </p:sp>
+      <p:sp>
+        <p:nvSpPr>
+          <p:cNvPr id="7" name="Freeform 6"/>
           <p:cNvSpPr/>
           <p:nvPr/>
         </p:nvSpPr>
@@ -23458,7 +23745,7 @@
       </p:sp>
       <p:sp>
         <p:nvSpPr>
-          <p:cNvPr id="7" name="Freeform 6"/>
+          <p:cNvPr id="8" name="Freeform 7"/>
           <p:cNvSpPr/>
           <p:nvPr/>
         </p:nvSpPr>
@@ -23516,7 +23803,7 @@
       </p:sp>
       <p:sp>
         <p:nvSpPr>
-          <p:cNvPr id="8" name="TextBox 7"/>
+          <p:cNvPr id="9" name="TextBox 8"/>
           <p:cNvSpPr txBox="1"/>
           <p:nvPr/>
         </p:nvSpPr>
@@ -23557,7 +23844,7 @@
       </p:sp>
       <p:sp>
         <p:nvSpPr>
-          <p:cNvPr id="9" name="TextBox 8"/>
+          <p:cNvPr id="10" name="TextBox 9"/>
           <p:cNvSpPr txBox="1"/>
           <p:nvPr/>
         </p:nvSpPr>
@@ -23598,7 +23885,7 @@
       </p:sp>
       <p:sp>
         <p:nvSpPr>
-          <p:cNvPr id="10" name="Rounded Rectangle 9"/>
+          <p:cNvPr id="11" name="Rounded Rectangle 10"/>
           <p:cNvSpPr/>
           <p:nvPr/>
         </p:nvSpPr>
@@ -23652,7 +23939,7 @@
       </p:sp>
       <p:sp>
         <p:nvSpPr>
-          <p:cNvPr id="11" name="TextBox 10"/>
+          <p:cNvPr id="12" name="TextBox 11"/>
           <p:cNvSpPr txBox="1"/>
           <p:nvPr/>
         </p:nvSpPr>
@@ -23693,7 +23980,7 @@
       </p:sp>
       <p:sp>
         <p:nvSpPr>
-          <p:cNvPr id="12" name="TextBox 11"/>
+          <p:cNvPr id="13" name="TextBox 12"/>
           <p:cNvSpPr txBox="1"/>
           <p:nvPr/>
         </p:nvSpPr>
@@ -23734,7 +24021,7 @@
       </p:sp>
       <p:sp>
         <p:nvSpPr>
-          <p:cNvPr id="13" name="Rounded Rectangle 12"/>
+          <p:cNvPr id="14" name="Rounded Rectangle 13"/>
           <p:cNvSpPr/>
           <p:nvPr/>
         </p:nvSpPr>
@@ -23780,7 +24067,7 @@
       </p:sp>
       <p:sp>
         <p:nvSpPr>
-          <p:cNvPr id="14" name="TextBox 13"/>
+          <p:cNvPr id="15" name="TextBox 14"/>
           <p:cNvSpPr txBox="1"/>
           <p:nvPr/>
         </p:nvSpPr>
@@ -23821,7 +24108,7 @@
       </p:sp>
       <p:sp>
         <p:nvSpPr>
-          <p:cNvPr id="15" name="Freeform 14"/>
+          <p:cNvPr id="16" name="Freeform 15"/>
           <p:cNvSpPr/>
           <p:nvPr/>
         </p:nvSpPr>
@@ -23879,7 +24166,7 @@
       </p:sp>
       <p:sp>
         <p:nvSpPr>
-          <p:cNvPr id="16" name="Oval 15"/>
+          <p:cNvPr id="17" name="Oval 16"/>
           <p:cNvSpPr/>
           <p:nvPr/>
         </p:nvSpPr>
@@ -23925,7 +24212,7 @@
       </p:sp>
       <p:sp>
         <p:nvSpPr>
-          <p:cNvPr id="17" name="TextBox 16"/>
+          <p:cNvPr id="18" name="TextBox 17"/>
           <p:cNvSpPr txBox="1"/>
           <p:nvPr/>
         </p:nvSpPr>
@@ -23966,7 +24253,7 @@
       </p:sp>
       <p:sp>
         <p:nvSpPr>
-          <p:cNvPr id="18" name="Oval 17"/>
+          <p:cNvPr id="19" name="Oval 18"/>
           <p:cNvSpPr/>
           <p:nvPr/>
         </p:nvSpPr>
@@ -24012,7 +24299,7 @@
       </p:sp>
       <p:sp>
         <p:nvSpPr>
-          <p:cNvPr id="19" name="TextBox 18"/>
+          <p:cNvPr id="20" name="TextBox 19"/>
           <p:cNvSpPr txBox="1"/>
           <p:nvPr/>
         </p:nvSpPr>
@@ -24053,7 +24340,7 @@
       </p:sp>
       <p:sp>
         <p:nvSpPr>
-          <p:cNvPr id="20" name="Oval 19"/>
+          <p:cNvPr id="21" name="Oval 20"/>
           <p:cNvSpPr/>
           <p:nvPr/>
         </p:nvSpPr>
@@ -24099,7 +24386,7 @@
       </p:sp>
       <p:sp>
         <p:nvSpPr>
-          <p:cNvPr id="21" name="TextBox 20"/>
+          <p:cNvPr id="22" name="TextBox 21"/>
           <p:cNvSpPr txBox="1"/>
           <p:nvPr/>
         </p:nvSpPr>
@@ -24140,7 +24427,7 @@
       </p:sp>
       <p:sp>
         <p:nvSpPr>
-          <p:cNvPr id="22" name="Oval 21"/>
+          <p:cNvPr id="23" name="Oval 22"/>
           <p:cNvSpPr/>
           <p:nvPr/>
         </p:nvSpPr>
@@ -24186,7 +24473,7 @@
       </p:sp>
       <p:sp>
         <p:nvSpPr>
-          <p:cNvPr id="23" name="TextBox 22"/>
+          <p:cNvPr id="24" name="TextBox 23"/>
           <p:cNvSpPr txBox="1"/>
           <p:nvPr/>
         </p:nvSpPr>
@@ -24227,7 +24514,7 @@
       </p:sp>
       <p:sp>
         <p:nvSpPr>
-          <p:cNvPr id="24" name="Oval 23"/>
+          <p:cNvPr id="25" name="Oval 24"/>
           <p:cNvSpPr/>
           <p:nvPr/>
         </p:nvSpPr>
@@ -24273,7 +24560,7 @@
       </p:sp>
       <p:sp>
         <p:nvSpPr>
-          <p:cNvPr id="25" name="TextBox 24"/>
+          <p:cNvPr id="26" name="TextBox 25"/>
           <p:cNvSpPr txBox="1"/>
           <p:nvPr/>
         </p:nvSpPr>
@@ -24314,7 +24601,7 @@
       </p:sp>
       <p:sp>
         <p:nvSpPr>
-          <p:cNvPr id="26" name="Oval 25"/>
+          <p:cNvPr id="27" name="Oval 26"/>
           <p:cNvSpPr/>
           <p:nvPr/>
         </p:nvSpPr>
@@ -24360,7 +24647,7 @@
       </p:sp>
       <p:sp>
         <p:nvSpPr>
-          <p:cNvPr id="27" name="TextBox 26"/>
+          <p:cNvPr id="28" name="TextBox 27"/>
           <p:cNvSpPr txBox="1"/>
           <p:nvPr/>
         </p:nvSpPr>
@@ -24401,7 +24688,7 @@
       </p:sp>
       <p:sp>
         <p:nvSpPr>
-          <p:cNvPr id="28" name="Oval 27"/>
+          <p:cNvPr id="29" name="Oval 28"/>
           <p:cNvSpPr/>
           <p:nvPr/>
         </p:nvSpPr>
@@ -24447,7 +24734,7 @@
       </p:sp>
       <p:sp>
         <p:nvSpPr>
-          <p:cNvPr id="29" name="TextBox 28"/>
+          <p:cNvPr id="30" name="TextBox 29"/>
           <p:cNvSpPr txBox="1"/>
           <p:nvPr/>
         </p:nvSpPr>
@@ -24488,7 +24775,7 @@
       </p:sp>
       <p:sp>
         <p:nvSpPr>
-          <p:cNvPr id="30" name="TextBox 29"/>
+          <p:cNvPr id="31" name="TextBox 30"/>
           <p:cNvSpPr txBox="1"/>
           <p:nvPr/>
         </p:nvSpPr>
@@ -24529,7 +24816,7 @@
       </p:sp>
       <p:sp>
         <p:nvSpPr>
-          <p:cNvPr id="31" name="Freeform 30"/>
+          <p:cNvPr id="32" name="Freeform 31"/>
           <p:cNvSpPr/>
           <p:nvPr/>
         </p:nvSpPr>
@@ -24587,7 +24874,7 @@
       </p:sp>
       <p:sp>
         <p:nvSpPr>
-          <p:cNvPr id="32" name="Freeform 31"/>
+          <p:cNvPr id="33" name="Freeform 32"/>
           <p:cNvSpPr/>
           <p:nvPr/>
         </p:nvSpPr>
@@ -24649,7 +24936,7 @@
       </p:sp>
       <p:sp>
         <p:nvSpPr>
-          <p:cNvPr id="33" name="Rounded Rectangle 32"/>
+          <p:cNvPr id="34" name="Rounded Rectangle 33"/>
           <p:cNvSpPr/>
           <p:nvPr/>
         </p:nvSpPr>
@@ -24703,7 +24990,7 @@
       </p:sp>
       <p:sp>
         <p:nvSpPr>
-          <p:cNvPr id="34" name="Rounded Rectangle 33"/>
+          <p:cNvPr id="35" name="Rounded Rectangle 34"/>
           <p:cNvSpPr/>
           <p:nvPr/>
         </p:nvSpPr>
@@ -24749,7 +25036,7 @@
       </p:sp>
       <p:sp>
         <p:nvSpPr>
-          <p:cNvPr id="35" name="Rounded Rectangle 34"/>
+          <p:cNvPr id="36" name="Rounded Rectangle 35"/>
           <p:cNvSpPr/>
           <p:nvPr/>
         </p:nvSpPr>
@@ -24795,7 +25082,7 @@
       </p:sp>
       <p:sp>
         <p:nvSpPr>
-          <p:cNvPr id="36" name="TextBox 35"/>
+          <p:cNvPr id="37" name="TextBox 36"/>
           <p:cNvSpPr txBox="1"/>
           <p:nvPr/>
         </p:nvSpPr>
@@ -24836,7 +25123,7 @@
       </p:sp>
       <p:sp>
         <p:nvSpPr>
-          <p:cNvPr id="37" name="TextBox 36"/>
+          <p:cNvPr id="38" name="TextBox 37"/>
           <p:cNvSpPr txBox="1"/>
           <p:nvPr/>
         </p:nvSpPr>
@@ -24910,7 +25197,7 @@
       </p:sp>
       <p:sp>
         <p:nvSpPr>
-          <p:cNvPr id="38" name="TextBox 37"/>
+          <p:cNvPr id="39" name="TextBox 38"/>
           <p:cNvSpPr txBox="1"/>
           <p:nvPr/>
         </p:nvSpPr>
@@ -24951,7 +25238,7 @@
       </p:sp>
       <p:sp>
         <p:nvSpPr>
-          <p:cNvPr id="39" name="Freeform 38"/>
+          <p:cNvPr id="40" name="Freeform 39"/>
           <p:cNvSpPr/>
           <p:nvPr/>
         </p:nvSpPr>
@@ -25009,7 +25296,7 @@
       </p:sp>
       <p:sp>
         <p:nvSpPr>
-          <p:cNvPr id="40" name="TextBox 39"/>
+          <p:cNvPr id="41" name="TextBox 40"/>
           <p:cNvSpPr txBox="1"/>
           <p:nvPr/>
         </p:nvSpPr>
@@ -25050,7 +25337,7 @@
       </p:sp>
       <p:sp>
         <p:nvSpPr>
-          <p:cNvPr id="41" name="Rounded Rectangle 40"/>
+          <p:cNvPr id="42" name="Rounded Rectangle 41"/>
           <p:cNvSpPr/>
           <p:nvPr/>
         </p:nvSpPr>
@@ -25096,7 +25383,7 @@
       </p:sp>
       <p:sp>
         <p:nvSpPr>
-          <p:cNvPr id="42" name="TextBox 41"/>
+          <p:cNvPr id="43" name="TextBox 42"/>
           <p:cNvSpPr txBox="1"/>
           <p:nvPr/>
         </p:nvSpPr>
@@ -25137,7 +25424,7 @@
       </p:sp>
       <p:sp>
         <p:nvSpPr>
-          <p:cNvPr id="43" name="Rounded Rectangle 42"/>
+          <p:cNvPr id="44" name="Rounded Rectangle 43"/>
           <p:cNvSpPr/>
           <p:nvPr/>
         </p:nvSpPr>
@@ -25191,7 +25478,7 @@
       </p:sp>
       <p:sp>
         <p:nvSpPr>
-          <p:cNvPr id="44" name="Rounded Rectangle 43"/>
+          <p:cNvPr id="45" name="Rounded Rectangle 44"/>
           <p:cNvSpPr/>
           <p:nvPr/>
         </p:nvSpPr>
@@ -25237,7 +25524,7 @@
       </p:sp>
       <p:sp>
         <p:nvSpPr>
-          <p:cNvPr id="45" name="Rounded Rectangle 44"/>
+          <p:cNvPr id="46" name="Rounded Rectangle 45"/>
           <p:cNvSpPr/>
           <p:nvPr/>
         </p:nvSpPr>
@@ -25283,7 +25570,7 @@
       </p:sp>
       <p:sp>
         <p:nvSpPr>
-          <p:cNvPr id="46" name="TextBox 45"/>
+          <p:cNvPr id="47" name="TextBox 46"/>
           <p:cNvSpPr txBox="1"/>
           <p:nvPr/>
         </p:nvSpPr>
@@ -25324,7 +25611,7 @@
       </p:sp>
       <p:sp>
         <p:nvSpPr>
-          <p:cNvPr id="47" name="TextBox 46"/>
+          <p:cNvPr id="48" name="TextBox 47"/>
           <p:cNvSpPr txBox="1"/>
           <p:nvPr/>
         </p:nvSpPr>
@@ -25398,7 +25685,7 @@
       </p:sp>
       <p:sp>
         <p:nvSpPr>
-          <p:cNvPr id="48" name="TextBox 47"/>
+          <p:cNvPr id="49" name="TextBox 48"/>
           <p:cNvSpPr txBox="1"/>
           <p:nvPr/>
         </p:nvSpPr>
@@ -25439,7 +25726,7 @@
       </p:sp>
       <p:sp>
         <p:nvSpPr>
-          <p:cNvPr id="49" name="Freeform 48"/>
+          <p:cNvPr id="50" name="Freeform 49"/>
           <p:cNvSpPr/>
           <p:nvPr/>
         </p:nvSpPr>
@@ -25497,7 +25784,7 @@
       </p:sp>
       <p:sp>
         <p:nvSpPr>
-          <p:cNvPr id="50" name="TextBox 49"/>
+          <p:cNvPr id="51" name="TextBox 50"/>
           <p:cNvSpPr txBox="1"/>
           <p:nvPr/>
         </p:nvSpPr>
@@ -25538,7 +25825,7 @@
       </p:sp>
       <p:sp>
         <p:nvSpPr>
-          <p:cNvPr id="51" name="Rounded Rectangle 50"/>
+          <p:cNvPr id="52" name="Rounded Rectangle 51"/>
           <p:cNvSpPr/>
           <p:nvPr/>
         </p:nvSpPr>
@@ -25584,7 +25871,7 @@
       </p:sp>
       <p:sp>
         <p:nvSpPr>
-          <p:cNvPr id="52" name="TextBox 51"/>
+          <p:cNvPr id="53" name="TextBox 52"/>
           <p:cNvSpPr txBox="1"/>
           <p:nvPr/>
         </p:nvSpPr>
@@ -25625,7 +25912,7 @@
       </p:sp>
       <p:sp>
         <p:nvSpPr>
-          <p:cNvPr id="53" name="Rounded Rectangle 52"/>
+          <p:cNvPr id="54" name="Rounded Rectangle 53"/>
           <p:cNvSpPr/>
           <p:nvPr/>
         </p:nvSpPr>
@@ -25679,7 +25966,7 @@
       </p:sp>
       <p:sp>
         <p:nvSpPr>
-          <p:cNvPr id="54" name="Rounded Rectangle 53"/>
+          <p:cNvPr id="55" name="Rounded Rectangle 54"/>
           <p:cNvSpPr/>
           <p:nvPr/>
         </p:nvSpPr>
@@ -25725,7 +26012,7 @@
       </p:sp>
       <p:sp>
         <p:nvSpPr>
-          <p:cNvPr id="55" name="Rounded Rectangle 54"/>
+          <p:cNvPr id="56" name="Rounded Rectangle 55"/>
           <p:cNvSpPr/>
           <p:nvPr/>
         </p:nvSpPr>
@@ -25771,7 +26058,7 @@
       </p:sp>
       <p:sp>
         <p:nvSpPr>
-          <p:cNvPr id="56" name="TextBox 55"/>
+          <p:cNvPr id="57" name="TextBox 56"/>
           <p:cNvSpPr txBox="1"/>
           <p:nvPr/>
         </p:nvSpPr>
@@ -25812,7 +26099,7 @@
       </p:sp>
       <p:sp>
         <p:nvSpPr>
-          <p:cNvPr id="57" name="TextBox 56"/>
+          <p:cNvPr id="58" name="TextBox 57"/>
           <p:cNvSpPr txBox="1"/>
           <p:nvPr/>
         </p:nvSpPr>
@@ -25886,7 +26173,7 @@
       </p:sp>
       <p:sp>
         <p:nvSpPr>
-          <p:cNvPr id="58" name="TextBox 57"/>
+          <p:cNvPr id="59" name="TextBox 58"/>
           <p:cNvSpPr txBox="1"/>
           <p:nvPr/>
         </p:nvSpPr>
@@ -25927,7 +26214,7 @@
       </p:sp>
       <p:sp>
         <p:nvSpPr>
-          <p:cNvPr id="59" name="Freeform 58"/>
+          <p:cNvPr id="60" name="Freeform 59"/>
           <p:cNvSpPr/>
           <p:nvPr/>
         </p:nvSpPr>
@@ -25985,7 +26272,7 @@
       </p:sp>
       <p:sp>
         <p:nvSpPr>
-          <p:cNvPr id="60" name="TextBox 59"/>
+          <p:cNvPr id="61" name="TextBox 60"/>
           <p:cNvSpPr txBox="1"/>
           <p:nvPr/>
         </p:nvSpPr>
@@ -26026,7 +26313,7 @@
       </p:sp>
       <p:sp>
         <p:nvSpPr>
-          <p:cNvPr id="61" name="Rounded Rectangle 60"/>
+          <p:cNvPr id="62" name="Rounded Rectangle 61"/>
           <p:cNvSpPr/>
           <p:nvPr/>
         </p:nvSpPr>
@@ -26072,7 +26359,7 @@
       </p:sp>
       <p:sp>
         <p:nvSpPr>
-          <p:cNvPr id="62" name="TextBox 61"/>
+          <p:cNvPr id="63" name="TextBox 62"/>
           <p:cNvSpPr txBox="1"/>
           <p:nvPr/>
         </p:nvSpPr>
@@ -26113,7 +26400,7 @@
       </p:sp>
       <p:sp>
         <p:nvSpPr>
-          <p:cNvPr id="63" name="Rounded Rectangle 62"/>
+          <p:cNvPr id="64" name="Rounded Rectangle 63"/>
           <p:cNvSpPr/>
           <p:nvPr/>
         </p:nvSpPr>
@@ -26167,7 +26454,7 @@
       </p:sp>
       <p:sp>
         <p:nvSpPr>
-          <p:cNvPr id="64" name="Rounded Rectangle 63"/>
+          <p:cNvPr id="65" name="Rounded Rectangle 64"/>
           <p:cNvSpPr/>
           <p:nvPr/>
         </p:nvSpPr>
@@ -26213,7 +26500,7 @@
       </p:sp>
       <p:sp>
         <p:nvSpPr>
-          <p:cNvPr id="65" name="Rounded Rectangle 64"/>
+          <p:cNvPr id="66" name="Rounded Rectangle 65"/>
           <p:cNvSpPr/>
           <p:nvPr/>
         </p:nvSpPr>
@@ -26259,7 +26546,7 @@
       </p:sp>
       <p:sp>
         <p:nvSpPr>
-          <p:cNvPr id="66" name="TextBox 65"/>
+          <p:cNvPr id="67" name="TextBox 66"/>
           <p:cNvSpPr txBox="1"/>
           <p:nvPr/>
         </p:nvSpPr>
@@ -26300,7 +26587,7 @@
       </p:sp>
       <p:sp>
         <p:nvSpPr>
-          <p:cNvPr id="67" name="TextBox 66"/>
+          <p:cNvPr id="68" name="TextBox 67"/>
           <p:cNvSpPr txBox="1"/>
           <p:nvPr/>
         </p:nvSpPr>
@@ -26341,7 +26628,7 @@
       </p:sp>
       <p:sp>
         <p:nvSpPr>
-          <p:cNvPr id="68" name="TextBox 67"/>
+          <p:cNvPr id="69" name="TextBox 68"/>
           <p:cNvSpPr txBox="1"/>
           <p:nvPr/>
         </p:nvSpPr>
@@ -26382,7 +26669,7 @@
       </p:sp>
       <p:sp>
         <p:nvSpPr>
-          <p:cNvPr id="69" name="Freeform 68"/>
+          <p:cNvPr id="70" name="Freeform 69"/>
           <p:cNvSpPr/>
           <p:nvPr/>
         </p:nvSpPr>
@@ -26440,7 +26727,7 @@
       </p:sp>
       <p:sp>
         <p:nvSpPr>
-          <p:cNvPr id="70" name="TextBox 69"/>
+          <p:cNvPr id="71" name="TextBox 70"/>
           <p:cNvSpPr txBox="1"/>
           <p:nvPr/>
         </p:nvSpPr>
@@ -26481,7 +26768,7 @@
       </p:sp>
       <p:sp>
         <p:nvSpPr>
-          <p:cNvPr id="71" name="Rounded Rectangle 70"/>
+          <p:cNvPr id="72" name="Rounded Rectangle 71"/>
           <p:cNvSpPr/>
           <p:nvPr/>
         </p:nvSpPr>
@@ -26527,7 +26814,7 @@
       </p:sp>
       <p:sp>
         <p:nvSpPr>
-          <p:cNvPr id="72" name="TextBox 71"/>
+          <p:cNvPr id="73" name="TextBox 72"/>
           <p:cNvSpPr txBox="1"/>
           <p:nvPr/>
         </p:nvSpPr>
@@ -26568,7 +26855,7 @@
       </p:sp>
       <p:sp>
         <p:nvSpPr>
-          <p:cNvPr id="73" name="Rounded Rectangle 72"/>
+          <p:cNvPr id="74" name="Rounded Rectangle 73"/>
           <p:cNvSpPr/>
           <p:nvPr/>
         </p:nvSpPr>
@@ -26616,7 +26903,7 @@
       </p:sp>
       <p:sp>
         <p:nvSpPr>
-          <p:cNvPr id="74" name="Rounded Rectangle 73"/>
+          <p:cNvPr id="75" name="Rounded Rectangle 74"/>
           <p:cNvSpPr/>
           <p:nvPr/>
         </p:nvSpPr>
@@ -26662,7 +26949,7 @@
       </p:sp>
       <p:sp>
         <p:nvSpPr>
-          <p:cNvPr id="75" name="TextBox 74"/>
+          <p:cNvPr id="76" name="TextBox 75"/>
           <p:cNvSpPr txBox="1"/>
           <p:nvPr/>
         </p:nvSpPr>
@@ -26976,7 +27263,48 @@
       </p:sp>
       <p:sp>
         <p:nvSpPr>
-          <p:cNvPr id="6" name="Freeform 5"/>
+          <p:cNvPr id="6" name="TextBox 5"/>
+          <p:cNvSpPr txBox="1"/>
+          <p:nvPr/>
+        </p:nvSpPr>
+        <p:spPr>
+          <a:xfrm>
+            <a:off x="10312400" y="254000"/>
+            <a:ext cx="1270000" cy="558800"/>
+          </a:xfrm>
+          <a:prstGeom prst="rect">
+            <a:avLst/>
+          </a:prstGeom>
+          <a:noFill/>
+        </p:spPr>
+        <p:txBody>
+          <a:bodyPr wrap="square" lIns="0" rIns="0" tIns="0" bIns="0" anchor="t">
+            <a:noAutofit/>
+          </a:bodyPr>
+          <a:lstStyle/>
+          <a:p>
+            <a:pPr algn="r">
+              <a:lnSpc>
+                <a:spcPct val="100000"/>
+              </a:lnSpc>
+            </a:pPr>
+            <a:r>
+              <a:rPr sz="3000" b="1" i="0">
+                <a:solidFill>
+                  <a:srgbClr val="E3EAF2"/>
+                </a:solidFill>
+                <a:latin typeface="Arial"/>
+                <a:ea typeface="Microsoft YaHei"/>
+                <a:cs typeface="Arial"/>
+              </a:rPr>
+              <a:t>09</a:t>
+            </a:r>
+          </a:p>
+        </p:txBody>
+      </p:sp>
+      <p:sp>
+        <p:nvSpPr>
+          <p:cNvPr id="7" name="Freeform 6"/>
           <p:cNvSpPr/>
           <p:nvPr/>
         </p:nvSpPr>
@@ -27034,7 +27362,7 @@
       </p:sp>
       <p:sp>
         <p:nvSpPr>
-          <p:cNvPr id="7" name="Freeform 6"/>
+          <p:cNvPr id="8" name="Freeform 7"/>
           <p:cNvSpPr/>
           <p:nvPr/>
         </p:nvSpPr>
@@ -27092,7 +27420,7 @@
       </p:sp>
       <p:sp>
         <p:nvSpPr>
-          <p:cNvPr id="8" name="TextBox 7"/>
+          <p:cNvPr id="9" name="TextBox 8"/>
           <p:cNvSpPr txBox="1"/>
           <p:nvPr/>
         </p:nvSpPr>
@@ -27133,7 +27461,7 @@
       </p:sp>
       <p:sp>
         <p:nvSpPr>
-          <p:cNvPr id="9" name="TextBox 8"/>
+          <p:cNvPr id="10" name="TextBox 9"/>
           <p:cNvSpPr txBox="1"/>
           <p:nvPr/>
         </p:nvSpPr>
@@ -27174,7 +27502,7 @@
       </p:sp>
       <p:sp>
         <p:nvSpPr>
-          <p:cNvPr id="10" name="Rounded Rectangle 9"/>
+          <p:cNvPr id="11" name="Rounded Rectangle 10"/>
           <p:cNvSpPr/>
           <p:nvPr/>
         </p:nvSpPr>
@@ -27228,7 +27556,7 @@
       </p:sp>
       <p:sp>
         <p:nvSpPr>
-          <p:cNvPr id="11" name="TextBox 10"/>
+          <p:cNvPr id="12" name="TextBox 11"/>
           <p:cNvSpPr txBox="1"/>
           <p:nvPr/>
         </p:nvSpPr>
@@ -27269,7 +27597,7 @@
       </p:sp>
       <p:sp>
         <p:nvSpPr>
-          <p:cNvPr id="12" name="Rectangle 11"/>
+          <p:cNvPr id="13" name="Rectangle 12"/>
           <p:cNvSpPr/>
           <p:nvPr/>
         </p:nvSpPr>
@@ -27313,7 +27641,7 @@
       </p:sp>
       <p:sp>
         <p:nvSpPr>
-          <p:cNvPr id="13" name="TextBox 12"/>
+          <p:cNvPr id="14" name="TextBox 13"/>
           <p:cNvSpPr txBox="1"/>
           <p:nvPr/>
         </p:nvSpPr>
@@ -27407,7 +27735,7 @@
       </p:sp>
       <p:sp>
         <p:nvSpPr>
-          <p:cNvPr id="14" name="Rounded Rectangle 13"/>
+          <p:cNvPr id="15" name="Rounded Rectangle 14"/>
           <p:cNvSpPr/>
           <p:nvPr/>
         </p:nvSpPr>
@@ -27453,7 +27781,7 @@
       </p:sp>
       <p:sp>
         <p:nvSpPr>
-          <p:cNvPr id="15" name="Freeform 14"/>
+          <p:cNvPr id="16" name="Freeform 15"/>
           <p:cNvSpPr/>
           <p:nvPr/>
         </p:nvSpPr>
@@ -27511,7 +27839,7 @@
       </p:sp>
       <p:sp>
         <p:nvSpPr>
-          <p:cNvPr id="16" name="TextBox 15"/>
+          <p:cNvPr id="17" name="TextBox 16"/>
           <p:cNvSpPr txBox="1"/>
           <p:nvPr/>
         </p:nvSpPr>
@@ -27552,7 +27880,7 @@
       </p:sp>
       <p:sp>
         <p:nvSpPr>
-          <p:cNvPr id="17" name="Freeform 16"/>
+          <p:cNvPr id="18" name="Freeform 17"/>
           <p:cNvSpPr/>
           <p:nvPr/>
         </p:nvSpPr>
@@ -27610,7 +27938,7 @@
       </p:sp>
       <p:sp>
         <p:nvSpPr>
-          <p:cNvPr id="18" name="TextBox 17"/>
+          <p:cNvPr id="19" name="TextBox 18"/>
           <p:cNvSpPr txBox="1"/>
           <p:nvPr/>
         </p:nvSpPr>
@@ -27651,7 +27979,7 @@
       </p:sp>
       <p:sp>
         <p:nvSpPr>
-          <p:cNvPr id="19" name="Freeform 18"/>
+          <p:cNvPr id="20" name="Freeform 19"/>
           <p:cNvSpPr/>
           <p:nvPr/>
         </p:nvSpPr>
@@ -27709,7 +28037,7 @@
       </p:sp>
       <p:sp>
         <p:nvSpPr>
-          <p:cNvPr id="20" name="TextBox 19"/>
+          <p:cNvPr id="21" name="TextBox 20"/>
           <p:cNvSpPr txBox="1"/>
           <p:nvPr/>
         </p:nvSpPr>
@@ -27750,7 +28078,7 @@
       </p:sp>
       <p:sp>
         <p:nvSpPr>
-          <p:cNvPr id="21" name="Freeform 20"/>
+          <p:cNvPr id="22" name="Freeform 21"/>
           <p:cNvSpPr/>
           <p:nvPr/>
         </p:nvSpPr>
@@ -27808,7 +28136,7 @@
       </p:sp>
       <p:sp>
         <p:nvSpPr>
-          <p:cNvPr id="22" name="TextBox 21"/>
+          <p:cNvPr id="23" name="TextBox 22"/>
           <p:cNvSpPr txBox="1"/>
           <p:nvPr/>
         </p:nvSpPr>
@@ -27849,7 +28177,7 @@
       </p:sp>
       <p:sp>
         <p:nvSpPr>
-          <p:cNvPr id="23" name="Freeform 22"/>
+          <p:cNvPr id="24" name="Freeform 23"/>
           <p:cNvSpPr/>
           <p:nvPr/>
         </p:nvSpPr>
@@ -27907,7 +28235,7 @@
       </p:sp>
       <p:sp>
         <p:nvSpPr>
-          <p:cNvPr id="24" name="Freeform 23"/>
+          <p:cNvPr id="25" name="Freeform 24"/>
           <p:cNvSpPr/>
           <p:nvPr/>
         </p:nvSpPr>
@@ -27965,7 +28293,7 @@
       </p:sp>
       <p:sp>
         <p:nvSpPr>
-          <p:cNvPr id="25" name="Freeform 24"/>
+          <p:cNvPr id="26" name="Freeform 25"/>
           <p:cNvSpPr/>
           <p:nvPr/>
         </p:nvSpPr>
@@ -28023,7 +28351,7 @@
       </p:sp>
       <p:sp>
         <p:nvSpPr>
-          <p:cNvPr id="26" name="Freeform 25"/>
+          <p:cNvPr id="27" name="Freeform 26"/>
           <p:cNvSpPr/>
           <p:nvPr/>
         </p:nvSpPr>
@@ -28085,7 +28413,7 @@
       </p:sp>
       <p:sp>
         <p:nvSpPr>
-          <p:cNvPr id="27" name="Freeform 26"/>
+          <p:cNvPr id="28" name="Freeform 27"/>
           <p:cNvSpPr/>
           <p:nvPr/>
         </p:nvSpPr>
@@ -28143,7 +28471,7 @@
       </p:sp>
       <p:sp>
         <p:nvSpPr>
-          <p:cNvPr id="28" name="Freeform 27"/>
+          <p:cNvPr id="29" name="Freeform 28"/>
           <p:cNvSpPr/>
           <p:nvPr/>
         </p:nvSpPr>
@@ -28205,7 +28533,7 @@
       </p:sp>
       <p:sp>
         <p:nvSpPr>
-          <p:cNvPr id="29" name="TextBox 28"/>
+          <p:cNvPr id="30" name="TextBox 29"/>
           <p:cNvSpPr txBox="1"/>
           <p:nvPr/>
         </p:nvSpPr>
@@ -28246,7 +28574,7 @@
       </p:sp>
       <p:sp>
         <p:nvSpPr>
-          <p:cNvPr id="30" name="TextBox 29"/>
+          <p:cNvPr id="31" name="TextBox 30"/>
           <p:cNvSpPr txBox="1"/>
           <p:nvPr/>
         </p:nvSpPr>
@@ -28287,7 +28615,7 @@
       </p:sp>
       <p:sp>
         <p:nvSpPr>
-          <p:cNvPr id="31" name="Freeform 30"/>
+          <p:cNvPr id="32" name="Freeform 31"/>
           <p:cNvSpPr/>
           <p:nvPr/>
         </p:nvSpPr>
@@ -28345,7 +28673,7 @@
       </p:sp>
       <p:sp>
         <p:nvSpPr>
-          <p:cNvPr id="32" name="TextBox 31"/>
+          <p:cNvPr id="33" name="TextBox 32"/>
           <p:cNvSpPr txBox="1"/>
           <p:nvPr/>
         </p:nvSpPr>
@@ -28386,7 +28714,7 @@
       </p:sp>
       <p:sp>
         <p:nvSpPr>
-          <p:cNvPr id="33" name="Freeform 32"/>
+          <p:cNvPr id="34" name="Freeform 33"/>
           <p:cNvSpPr/>
           <p:nvPr/>
         </p:nvSpPr>
@@ -28444,7 +28772,7 @@
       </p:sp>
       <p:sp>
         <p:nvSpPr>
-          <p:cNvPr id="34" name="TextBox 33"/>
+          <p:cNvPr id="35" name="TextBox 34"/>
           <p:cNvSpPr txBox="1"/>
           <p:nvPr/>
         </p:nvSpPr>
@@ -28485,7 +28813,7 @@
       </p:sp>
       <p:sp>
         <p:nvSpPr>
-          <p:cNvPr id="35" name="Freeform 34"/>
+          <p:cNvPr id="36" name="Freeform 35"/>
           <p:cNvSpPr/>
           <p:nvPr/>
         </p:nvSpPr>
@@ -28543,7 +28871,7 @@
       </p:sp>
       <p:sp>
         <p:nvSpPr>
-          <p:cNvPr id="36" name="TextBox 35"/>
+          <p:cNvPr id="37" name="TextBox 36"/>
           <p:cNvSpPr txBox="1"/>
           <p:nvPr/>
         </p:nvSpPr>
@@ -28584,7 +28912,7 @@
       </p:sp>
       <p:sp>
         <p:nvSpPr>
-          <p:cNvPr id="37" name="Freeform 36"/>
+          <p:cNvPr id="38" name="Freeform 37"/>
           <p:cNvSpPr/>
           <p:nvPr/>
         </p:nvSpPr>
@@ -28642,7 +28970,7 @@
       </p:sp>
       <p:sp>
         <p:nvSpPr>
-          <p:cNvPr id="38" name="TextBox 37"/>
+          <p:cNvPr id="39" name="TextBox 38"/>
           <p:cNvSpPr txBox="1"/>
           <p:nvPr/>
         </p:nvSpPr>
@@ -28683,7 +29011,7 @@
       </p:sp>
       <p:sp>
         <p:nvSpPr>
-          <p:cNvPr id="39" name="Freeform 38"/>
+          <p:cNvPr id="40" name="Freeform 39"/>
           <p:cNvSpPr/>
           <p:nvPr/>
         </p:nvSpPr>
@@ -28930,7 +29258,7 @@
       </p:sp>
       <p:sp>
         <p:nvSpPr>
-          <p:cNvPr id="40" name="Freeform 39"/>
+          <p:cNvPr id="41" name="Freeform 40"/>
           <p:cNvSpPr/>
           <p:nvPr/>
         </p:nvSpPr>
@@ -29129,7 +29457,7 @@
       </p:sp>
       <p:sp>
         <p:nvSpPr>
-          <p:cNvPr id="41" name="Freeform 40"/>
+          <p:cNvPr id="42" name="Freeform 41"/>
           <p:cNvSpPr/>
           <p:nvPr/>
         </p:nvSpPr>
@@ -29328,7 +29656,7 @@
       </p:sp>
       <p:sp>
         <p:nvSpPr>
-          <p:cNvPr id="42" name="Freeform 41"/>
+          <p:cNvPr id="43" name="Freeform 42"/>
           <p:cNvSpPr/>
           <p:nvPr/>
         </p:nvSpPr>
@@ -29575,7 +29903,7 @@
       </p:sp>
       <p:sp>
         <p:nvSpPr>
-          <p:cNvPr id="43" name="TextBox 42"/>
+          <p:cNvPr id="44" name="TextBox 43"/>
           <p:cNvSpPr txBox="1"/>
           <p:nvPr/>
         </p:nvSpPr>
@@ -29616,7 +29944,7 @@
       </p:sp>
       <p:sp>
         <p:nvSpPr>
-          <p:cNvPr id="44" name="Rounded Rectangle 43"/>
+          <p:cNvPr id="45" name="Rounded Rectangle 44"/>
           <p:cNvSpPr/>
           <p:nvPr/>
         </p:nvSpPr>
@@ -29670,7 +29998,7 @@
       </p:sp>
       <p:sp>
         <p:nvSpPr>
-          <p:cNvPr id="45" name="TextBox 44"/>
+          <p:cNvPr id="46" name="TextBox 45"/>
           <p:cNvSpPr txBox="1"/>
           <p:nvPr/>
         </p:nvSpPr>
@@ -29711,7 +30039,7 @@
       </p:sp>
       <p:sp>
         <p:nvSpPr>
-          <p:cNvPr id="46" name="Rectangle 45"/>
+          <p:cNvPr id="47" name="Rectangle 46"/>
           <p:cNvSpPr/>
           <p:nvPr/>
         </p:nvSpPr>
@@ -29755,7 +30083,7 @@
       </p:sp>
       <p:sp>
         <p:nvSpPr>
-          <p:cNvPr id="47" name="Rounded Rectangle 46"/>
+          <p:cNvPr id="48" name="Rounded Rectangle 47"/>
           <p:cNvSpPr/>
           <p:nvPr/>
         </p:nvSpPr>
@@ -29801,7 +30129,7 @@
       </p:sp>
       <p:sp>
         <p:nvSpPr>
-          <p:cNvPr id="48" name="Rounded Rectangle 47"/>
+          <p:cNvPr id="49" name="Rounded Rectangle 48"/>
           <p:cNvSpPr/>
           <p:nvPr/>
         </p:nvSpPr>
@@ -29847,7 +30175,7 @@
       </p:sp>
       <p:sp>
         <p:nvSpPr>
-          <p:cNvPr id="49" name="Oval 48"/>
+          <p:cNvPr id="50" name="Oval 49"/>
           <p:cNvSpPr/>
           <p:nvPr/>
         </p:nvSpPr>
@@ -29891,7 +30219,7 @@
       </p:sp>
       <p:sp>
         <p:nvSpPr>
-          <p:cNvPr id="50" name="TextBox 49"/>
+          <p:cNvPr id="51" name="TextBox 50"/>
           <p:cNvSpPr txBox="1"/>
           <p:nvPr/>
         </p:nvSpPr>
@@ -29932,7 +30260,7 @@
       </p:sp>
       <p:sp>
         <p:nvSpPr>
-          <p:cNvPr id="51" name="TextBox 50"/>
+          <p:cNvPr id="52" name="TextBox 51"/>
           <p:cNvSpPr txBox="1"/>
           <p:nvPr/>
         </p:nvSpPr>
@@ -29973,7 +30301,7 @@
       </p:sp>
       <p:sp>
         <p:nvSpPr>
-          <p:cNvPr id="52" name="TextBox 51"/>
+          <p:cNvPr id="53" name="TextBox 52"/>
           <p:cNvSpPr txBox="1"/>
           <p:nvPr/>
         </p:nvSpPr>
@@ -30014,7 +30342,7 @@
       </p:sp>
       <p:sp>
         <p:nvSpPr>
-          <p:cNvPr id="53" name="TextBox 52"/>
+          <p:cNvPr id="54" name="TextBox 53"/>
           <p:cNvSpPr txBox="1"/>
           <p:nvPr/>
         </p:nvSpPr>
@@ -30055,7 +30383,7 @@
       </p:sp>
       <p:sp>
         <p:nvSpPr>
-          <p:cNvPr id="54" name="Oval 53"/>
+          <p:cNvPr id="55" name="Oval 54"/>
           <p:cNvSpPr/>
           <p:nvPr/>
         </p:nvSpPr>
@@ -30099,7 +30427,7 @@
       </p:sp>
       <p:sp>
         <p:nvSpPr>
-          <p:cNvPr id="55" name="Oval 54"/>
+          <p:cNvPr id="56" name="Oval 55"/>
           <p:cNvSpPr/>
           <p:nvPr/>
         </p:nvSpPr>
@@ -30143,7 +30471,7 @@
       </p:sp>
       <p:sp>
         <p:nvSpPr>
-          <p:cNvPr id="56" name="Oval 55"/>
+          <p:cNvPr id="57" name="Oval 56"/>
           <p:cNvSpPr/>
           <p:nvPr/>
         </p:nvSpPr>
@@ -30187,7 +30515,7 @@
       </p:sp>
       <p:sp>
         <p:nvSpPr>
-          <p:cNvPr id="57" name="Freeform 56"/>
+          <p:cNvPr id="58" name="Freeform 57"/>
           <p:cNvSpPr/>
           <p:nvPr/>
         </p:nvSpPr>
@@ -30245,7 +30573,7 @@
       </p:sp>
       <p:sp>
         <p:nvSpPr>
-          <p:cNvPr id="58" name="Freeform 57"/>
+          <p:cNvPr id="59" name="Freeform 58"/>
           <p:cNvSpPr/>
           <p:nvPr/>
         </p:nvSpPr>
@@ -30307,7 +30635,7 @@
       </p:sp>
       <p:sp>
         <p:nvSpPr>
-          <p:cNvPr id="59" name="Rounded Rectangle 58"/>
+          <p:cNvPr id="60" name="Rounded Rectangle 59"/>
           <p:cNvSpPr/>
           <p:nvPr/>
         </p:nvSpPr>
@@ -30353,7 +30681,7 @@
       </p:sp>
       <p:sp>
         <p:nvSpPr>
-          <p:cNvPr id="60" name="Rounded Rectangle 59"/>
+          <p:cNvPr id="61" name="Rounded Rectangle 60"/>
           <p:cNvSpPr/>
           <p:nvPr/>
         </p:nvSpPr>
@@ -30399,7 +30727,7 @@
       </p:sp>
       <p:sp>
         <p:nvSpPr>
-          <p:cNvPr id="61" name="Oval 60"/>
+          <p:cNvPr id="62" name="Oval 61"/>
           <p:cNvSpPr/>
           <p:nvPr/>
         </p:nvSpPr>
@@ -30443,7 +30771,7 @@
       </p:sp>
       <p:sp>
         <p:nvSpPr>
-          <p:cNvPr id="62" name="TextBox 61"/>
+          <p:cNvPr id="63" name="TextBox 62"/>
           <p:cNvSpPr txBox="1"/>
           <p:nvPr/>
         </p:nvSpPr>
@@ -30484,7 +30812,7 @@
       </p:sp>
       <p:sp>
         <p:nvSpPr>
-          <p:cNvPr id="63" name="TextBox 62"/>
+          <p:cNvPr id="64" name="TextBox 63"/>
           <p:cNvSpPr txBox="1"/>
           <p:nvPr/>
         </p:nvSpPr>
@@ -30525,7 +30853,7 @@
       </p:sp>
       <p:sp>
         <p:nvSpPr>
-          <p:cNvPr id="64" name="TextBox 63"/>
+          <p:cNvPr id="65" name="TextBox 64"/>
           <p:cNvSpPr txBox="1"/>
           <p:nvPr/>
         </p:nvSpPr>
@@ -30566,7 +30894,7 @@
       </p:sp>
       <p:sp>
         <p:nvSpPr>
-          <p:cNvPr id="65" name="TextBox 64"/>
+          <p:cNvPr id="66" name="TextBox 65"/>
           <p:cNvSpPr txBox="1"/>
           <p:nvPr/>
         </p:nvSpPr>
@@ -30607,7 +30935,7 @@
       </p:sp>
       <p:sp>
         <p:nvSpPr>
-          <p:cNvPr id="66" name="Freeform 65"/>
+          <p:cNvPr id="67" name="Freeform 66"/>
           <p:cNvSpPr/>
           <p:nvPr/>
         </p:nvSpPr>
@@ -30734,7 +31062,7 @@
       </p:sp>
       <p:sp>
         <p:nvSpPr>
-          <p:cNvPr id="67" name="Freeform 66"/>
+          <p:cNvPr id="68" name="Freeform 67"/>
           <p:cNvSpPr/>
           <p:nvPr/>
         </p:nvSpPr>
@@ -30861,7 +31189,7 @@
       </p:sp>
       <p:sp>
         <p:nvSpPr>
-          <p:cNvPr id="68" name="Freeform 67"/>
+          <p:cNvPr id="69" name="Freeform 68"/>
           <p:cNvSpPr/>
           <p:nvPr/>
         </p:nvSpPr>
@@ -30919,7 +31247,7 @@
       </p:sp>
       <p:sp>
         <p:nvSpPr>
-          <p:cNvPr id="69" name="Freeform 68"/>
+          <p:cNvPr id="70" name="Freeform 69"/>
           <p:cNvSpPr/>
           <p:nvPr/>
         </p:nvSpPr>
@@ -30977,7 +31305,7 @@
       </p:sp>
       <p:sp>
         <p:nvSpPr>
-          <p:cNvPr id="70" name="Freeform 69"/>
+          <p:cNvPr id="71" name="Freeform 70"/>
           <p:cNvSpPr/>
           <p:nvPr/>
         </p:nvSpPr>
@@ -31035,7 +31363,7 @@
       </p:sp>
       <p:sp>
         <p:nvSpPr>
-          <p:cNvPr id="71" name="Freeform 70"/>
+          <p:cNvPr id="72" name="Freeform 71"/>
           <p:cNvSpPr/>
           <p:nvPr/>
         </p:nvSpPr>
@@ -31093,7 +31421,7 @@
       </p:sp>
       <p:sp>
         <p:nvSpPr>
-          <p:cNvPr id="72" name="Freeform 71"/>
+          <p:cNvPr id="73" name="Freeform 72"/>
           <p:cNvSpPr/>
           <p:nvPr/>
         </p:nvSpPr>
@@ -31155,7 +31483,7 @@
       </p:sp>
       <p:sp>
         <p:nvSpPr>
-          <p:cNvPr id="73" name="Rounded Rectangle 72"/>
+          <p:cNvPr id="74" name="Rounded Rectangle 73"/>
           <p:cNvSpPr/>
           <p:nvPr/>
         </p:nvSpPr>
@@ -31201,7 +31529,7 @@
       </p:sp>
       <p:sp>
         <p:nvSpPr>
-          <p:cNvPr id="74" name="Rounded Rectangle 73"/>
+          <p:cNvPr id="75" name="Rounded Rectangle 74"/>
           <p:cNvSpPr/>
           <p:nvPr/>
         </p:nvSpPr>
@@ -31247,7 +31575,7 @@
       </p:sp>
       <p:sp>
         <p:nvSpPr>
-          <p:cNvPr id="75" name="Oval 74"/>
+          <p:cNvPr id="76" name="Oval 75"/>
           <p:cNvSpPr/>
           <p:nvPr/>
         </p:nvSpPr>
@@ -31291,7 +31619,7 @@
       </p:sp>
       <p:sp>
         <p:nvSpPr>
-          <p:cNvPr id="76" name="TextBox 75"/>
+          <p:cNvPr id="77" name="TextBox 76"/>
           <p:cNvSpPr txBox="1"/>
           <p:nvPr/>
         </p:nvSpPr>
@@ -31332,7 +31660,7 @@
       </p:sp>
       <p:sp>
         <p:nvSpPr>
-          <p:cNvPr id="77" name="TextBox 76"/>
+          <p:cNvPr id="78" name="TextBox 77"/>
           <p:cNvSpPr txBox="1"/>
           <p:nvPr/>
         </p:nvSpPr>
@@ -31373,7 +31701,7 @@
       </p:sp>
       <p:sp>
         <p:nvSpPr>
-          <p:cNvPr id="78" name="TextBox 77"/>
+          <p:cNvPr id="79" name="TextBox 78"/>
           <p:cNvSpPr txBox="1"/>
           <p:nvPr/>
         </p:nvSpPr>
@@ -31414,7 +31742,7 @@
       </p:sp>
       <p:sp>
         <p:nvSpPr>
-          <p:cNvPr id="79" name="TextBox 78"/>
+          <p:cNvPr id="80" name="TextBox 79"/>
           <p:cNvSpPr txBox="1"/>
           <p:nvPr/>
         </p:nvSpPr>
@@ -31455,7 +31783,7 @@
       </p:sp>
       <p:sp>
         <p:nvSpPr>
-          <p:cNvPr id="80" name="Freeform 79"/>
+          <p:cNvPr id="81" name="Freeform 80"/>
           <p:cNvSpPr/>
           <p:nvPr/>
         </p:nvSpPr>
@@ -31525,7 +31853,7 @@
       </p:sp>
       <p:sp>
         <p:nvSpPr>
-          <p:cNvPr id="81" name="Freeform 80"/>
+          <p:cNvPr id="82" name="Freeform 81"/>
           <p:cNvSpPr/>
           <p:nvPr/>
         </p:nvSpPr>
@@ -31583,7 +31911,7 @@
       </p:sp>
       <p:sp>
         <p:nvSpPr>
-          <p:cNvPr id="82" name="Freeform 81"/>
+          <p:cNvPr id="83" name="Freeform 82"/>
           <p:cNvSpPr/>
           <p:nvPr/>
         </p:nvSpPr>
@@ -31641,7 +31969,7 @@
       </p:sp>
       <p:sp>
         <p:nvSpPr>
-          <p:cNvPr id="83" name="Oval 82"/>
+          <p:cNvPr id="84" name="Oval 83"/>
           <p:cNvSpPr/>
           <p:nvPr/>
         </p:nvSpPr>

</xml_diff>